<commit_message>
deck: add explicit Aim to slide 7, correct LTspice claim on slide 9
Slide 7 opened on 'Proposed Solution' and described what was built without
ever stating what the project sets out to achieve. Adds an Aim block as the
first item. Compressed the contribution and methodology prose to keep the
slide within its text box (5.22 in of 5.40).

Slide 9 claimed the three experiments 'ship as LTspice schematics in
ltspice/*.asc'. Those sheets do not contain the Miller clamp. Slide now
points to sim/dpt.cir as the clamped model and states what the .asc sheets
actually show.

Also fixes a stale absolute results path in build.py that broke the build
outside the original container.

Co-Authored-By: Claude Opus 5 <noreply@anthropic.com>
</commit_message>
<xml_diff>
--- a/review/Review1_GaN_Segmented_Gate_Driver.pptx
+++ b/review/Review1_GaN_Segmented_Gate_Driver.pptx
@@ -13113,7 +13113,29 @@
                 <a:ea typeface="Calibri" pitchFamily="34" charset="-122"/>
                 <a:cs typeface="Calibri" pitchFamily="34" charset="-120"/>
               </a:rPr>
-              <a:t xml:space="preserve">, and the same three experiments ship as LTspice schematics in </a:t>
+              <a:t xml:space="preserve">, which is the file to open in LTspice — it carries the active Miller clamp (S</a:t>
+            </a:r>
+            <a:r>
+              <a:rPr lang="en-US" sz="1200" dirty="0">
+                <a:solidFill>
+                  <a:srgbClr val="000000"/>
+                </a:solidFill>
+                <a:latin typeface="Calibri" pitchFamily="34" charset="0"/>
+                <a:ea typeface="Calibri" pitchFamily="34" charset="-122"/>
+                <a:cs typeface="Calibri" pitchFamily="34" charset="-120"/>
+              </a:rPr>
+              <a:t xml:space="preserve">clk</a:t>
+            </a:r>
+            <a:r>
+              <a:rPr lang="en-US" sz="1200" dirty="0">
+                <a:solidFill>
+                  <a:srgbClr val="000000"/>
+                </a:solidFill>
+                <a:latin typeface="Calibri" pitchFamily="34" charset="0"/>
+                <a:ea typeface="Calibri" pitchFamily="34" charset="-122"/>
+                <a:cs typeface="Calibri" pitchFamily="34" charset="-120"/>
+              </a:rPr>
+              <a:t xml:space="preserve"> through 0.5 Ω). The three </a:t>
             </a:r>
             <a:r>
               <a:rPr lang="en-US" sz="1200" b="1" dirty="0">
@@ -13125,6 +13147,17 @@
                 <a:cs typeface="Calibri" pitchFamily="34" charset="-120"/>
               </a:rPr>
               <a:t xml:space="preserve">ltspice/*.asc</a:t>
+            </a:r>
+            <a:r>
+              <a:rPr lang="en-US" sz="1200" dirty="0">
+                <a:solidFill>
+                  <a:srgbClr val="000000"/>
+                </a:solidFill>
+                <a:latin typeface="Calibri" pitchFamily="34" charset="0"/>
+                <a:ea typeface="Calibri" pitchFamily="34" charset="-122"/>
+                <a:cs typeface="Calibri" pitchFamily="34" charset="-120"/>
+              </a:rPr>
+              <a:t xml:space="preserve"> sheets illustrate the crosstalk mechanism only and do not draw the clamp</a:t>
             </a:r>
             <a:r>
               <a:rPr lang="en-US" sz="1200" dirty="0">
@@ -18693,6 +18726,46 @@
                 <a:ea typeface="Calibri" pitchFamily="34" charset="-122"/>
                 <a:cs typeface="Calibri" pitchFamily="34" charset="-120"/>
               </a:rPr>
+              <a:t xml:space="preserve">Aim:</a:t>
+            </a:r>
+          </a:p>
+          <a:p>
+            <a:pPr marL="520700" indent="-177800">
+              <a:spcAft>
+                <a:spcPts val="600"/>
+              </a:spcAft>
+              <a:buSzPct val="100000"/>
+              <a:buChar char="–"/>
+            </a:pPr>
+            <a:r>
+              <a:rPr lang="en-US" sz="1500" dirty="0">
+                <a:solidFill>
+                  <a:srgbClr val="000000"/>
+                </a:solidFill>
+                <a:latin typeface="Calibri" pitchFamily="34" charset="0"/>
+                <a:ea typeface="Calibri" pitchFamily="34" charset="-122"/>
+                <a:cs typeface="Calibri" pitchFamily="34" charset="-120"/>
+              </a:rPr>
+              <a:t xml:space="preserve">To measure how much of an active gate driver’s benefit actually requires per-operating-point adaptation, and how much comes from simply choosing a better fixed setting — by searching the control word exhaustively rather than arguing the case.</a:t>
+            </a:r>
+          </a:p>
+          <a:p>
+            <a:pPr marL="177800" indent="-177800">
+              <a:spcAft>
+                <a:spcPts val="600"/>
+              </a:spcAft>
+              <a:buSzPct val="100000"/>
+              <a:buChar char="•"/>
+            </a:pPr>
+            <a:r>
+              <a:rPr lang="en-US" sz="1600" b="1" dirty="0">
+                <a:solidFill>
+                  <a:srgbClr val="000000"/>
+                </a:solidFill>
+                <a:latin typeface="Calibri" pitchFamily="34" charset="0"/>
+                <a:ea typeface="Calibri" pitchFamily="34" charset="-122"/>
+                <a:cs typeface="Calibri" pitchFamily="34" charset="-120"/>
+              </a:rPr>
               <a:t xml:space="preserve">Proposed Solution:</a:t>
             </a:r>
           </a:p>
@@ -18725,6 +18798,17 @@
               <a:buChar char="–"/>
             </a:pPr>
             <a:r>
+              <a:rPr lang="en-US" sz="1500" b="1" dirty="0">
+                <a:solidFill>
+                  <a:srgbClr val="000000"/>
+                </a:solidFill>
+                <a:latin typeface="Calibri" pitchFamily="34" charset="0"/>
+                <a:ea typeface="Calibri" pitchFamily="34" charset="-122"/>
+                <a:cs typeface="Calibri" pitchFamily="34" charset="-120"/>
+              </a:rPr>
+              <a:t xml:space="preserve">Method: </a:t>
+            </a:r>
+            <a:r>
               <a:rPr lang="en-US" sz="1500" dirty="0">
                 <a:solidFill>
                   <a:srgbClr val="000000"/>
@@ -18733,8 +18817,97 @@
                 <a:ea typeface="Calibri" pitchFamily="34" charset="-122"/>
                 <a:cs typeface="Calibri" pitchFamily="34" charset="-120"/>
               </a:rPr>
-              <a:t xml:space="preserve">The contribution is to </a:t>
-            </a:r>
+              <a:t xml:space="preserve">sweep the full word at every corner, so each per-corner optimum is a true optimum, then compare against the best single fixed word. That difference is the value of adaptation, and nothing else.</a:t>
+            </a:r>
+          </a:p>
+          <a:p>
+            <a:pPr marL="177800" indent="-177800">
+              <a:spcAft>
+                <a:spcPts val="600"/>
+              </a:spcAft>
+              <a:buSzPct val="100000"/>
+              <a:buChar char="•"/>
+            </a:pPr>
+            <a:r>
+              <a:rPr lang="en-US" sz="1600" b="1" dirty="0">
+                <a:solidFill>
+                  <a:srgbClr val="000000"/>
+                </a:solidFill>
+                <a:latin typeface="Calibri" pitchFamily="34" charset="0"/>
+                <a:ea typeface="Calibri" pitchFamily="34" charset="-122"/>
+                <a:cs typeface="Calibri" pitchFamily="34" charset="-120"/>
+              </a:rPr>
+              <a:t xml:space="preserve">Methodology / Approach:</a:t>
+            </a:r>
+          </a:p>
+          <a:p>
+            <a:pPr marL="520700" indent="-177800">
+              <a:spcAft>
+                <a:spcPts val="600"/>
+              </a:spcAft>
+              <a:buSzPct val="100000"/>
+              <a:buChar char="–"/>
+            </a:pPr>
+            <a:r>
+              <a:rPr lang="en-US" sz="1500" dirty="0">
+                <a:solidFill>
+                  <a:srgbClr val="000000"/>
+                </a:solidFill>
+                <a:latin typeface="Calibri" pitchFamily="34" charset="0"/>
+                <a:ea typeface="Calibri" pitchFamily="34" charset="-122"/>
+                <a:cs typeface="Calibri" pitchFamily="34" charset="-120"/>
+              </a:rPr>
+              <a:t xml:space="preserve">Double-pulse test in ngspice with a behavioural eGaN model from datasheet quantities; its symmetric channel makes the third-quadrant cost of negative bias emerge from device physics.</a:t>
+            </a:r>
+          </a:p>
+          <a:p>
+            <a:pPr marL="520700" indent="-177800">
+              <a:spcAft>
+                <a:spcPts val="600"/>
+              </a:spcAft>
+              <a:buSzPct val="100000"/>
+              <a:buChar char="–"/>
+            </a:pPr>
+            <a:r>
+              <a:rPr lang="en-US" sz="1500" dirty="0">
+                <a:solidFill>
+                  <a:srgbClr val="000000"/>
+                </a:solidFill>
+                <a:latin typeface="Calibri" pitchFamily="34" charset="0"/>
+                <a:ea typeface="Calibri" pitchFamily="34" charset="-122"/>
+                <a:cs typeface="Calibri" pitchFamily="34" charset="-120"/>
+              </a:rPr>
+              <a:t xml:space="preserve">Eight metrics per run, frozen in one extractor early; every reported quantity must be flat across a 5× timestep range — enforced, not assumed.</a:t>
+            </a:r>
+          </a:p>
+          <a:p>
+            <a:pPr marL="177800" indent="-177800">
+              <a:spcAft>
+                <a:spcPts val="600"/>
+              </a:spcAft>
+              <a:buSzPct val="100000"/>
+              <a:buChar char="•"/>
+            </a:pPr>
+            <a:r>
+              <a:rPr lang="en-US" sz="1600" b="1" dirty="0">
+                <a:solidFill>
+                  <a:srgbClr val="000000"/>
+                </a:solidFill>
+                <a:latin typeface="Calibri" pitchFamily="34" charset="0"/>
+                <a:ea typeface="Calibri" pitchFamily="34" charset="-122"/>
+                <a:cs typeface="Calibri" pitchFamily="34" charset="-120"/>
+              </a:rPr>
+              <a:t xml:space="preserve">Project Scope:</a:t>
+            </a:r>
+          </a:p>
+          <a:p>
+            <a:pPr marL="520700" indent="-177800">
+              <a:spcAft>
+                <a:spcPts val="600"/>
+              </a:spcAft>
+              <a:buSzPct val="100000"/>
+              <a:buChar char="–"/>
+            </a:pPr>
             <a:r>
               <a:rPr lang="en-US" sz="1500" b="1" dirty="0">
                 <a:solidFill>
@@ -18744,7 +18917,7 @@
                 <a:ea typeface="Calibri" pitchFamily="34" charset="-122"/>
                 <a:cs typeface="Calibri" pitchFamily="34" charset="-120"/>
               </a:rPr>
-              <a:t xml:space="preserve">separate the two claims by exhaustive search</a:t>
+              <a:t xml:space="preserve">In scope: </a:t>
             </a:r>
             <a:r>
               <a:rPr lang="en-US" sz="1500" dirty="0">
@@ -18755,37 +18928,19 @@
                 <a:ea typeface="Calibri" pitchFamily="34" charset="-122"/>
                 <a:cs typeface="Calibri" pitchFamily="34" charset="-120"/>
               </a:rPr>
-              <a:t xml:space="preserve">: sweep the full word at every corner, so each per-corner optimum is a true optimum and not the best of a shortlist, then compare against the best single fixed word. That difference is the value of adaptation, and nothing else.</a:t>
-            </a:r>
-          </a:p>
-          <a:p>
-            <a:pPr marL="177800" indent="-177800">
-              <a:spcAft>
-                <a:spcPts val="600"/>
-              </a:spcAft>
-              <a:buSzPct val="100000"/>
-              <a:buChar char="•"/>
-            </a:pPr>
-            <a:r>
-              <a:rPr lang="en-US" sz="1600" b="1" dirty="0">
-                <a:solidFill>
-                  <a:srgbClr val="000000"/>
-                </a:solidFill>
-                <a:latin typeface="Calibri" pitchFamily="34" charset="0"/>
-                <a:ea typeface="Calibri" pitchFamily="34" charset="-122"/>
-                <a:cs typeface="Calibri" pitchFamily="34" charset="-120"/>
-              </a:rPr>
-              <a:t xml:space="preserve">Methodology / Approach:</a:t>
-            </a:r>
-          </a:p>
-          <a:p>
-            <a:pPr marL="520700" indent="-177800">
-              <a:spcAft>
-                <a:spcPts val="600"/>
-              </a:spcAft>
-              <a:buSzPct val="100000"/>
-              <a:buChar char="–"/>
-            </a:pPr>
+              <a:t xml:space="preserve">driver architecture, control-word optimisation, transistor-level output stage in SKY130. </a:t>
+            </a:r>
+            <a:r>
+              <a:rPr lang="en-US" sz="1500" b="1" dirty="0">
+                <a:solidFill>
+                  <a:srgbClr val="000000"/>
+                </a:solidFill>
+                <a:latin typeface="Calibri" pitchFamily="34" charset="0"/>
+                <a:ea typeface="Calibri" pitchFamily="34" charset="-122"/>
+                <a:cs typeface="Calibri" pitchFamily="34" charset="-120"/>
+              </a:rPr>
+              <a:t xml:space="preserve">Out of scope: </a:t>
+            </a:r>
             <a:r>
               <a:rPr lang="en-US" sz="1500" dirty="0">
                 <a:solidFill>
@@ -18795,120 +18950,7 @@
                 <a:ea typeface="Calibri" pitchFamily="34" charset="-122"/>
                 <a:cs typeface="Calibri" pitchFamily="34" charset="-120"/>
               </a:rPr>
-              <a:t xml:space="preserve">Double-pulse test in ngspice with a behavioural eGaN model from datasheet quantities. Its channel is symmetric by design, so the third-quadrant penalty of negative bias emerges from device physics rather than being added by hand.</a:t>
-            </a:r>
-          </a:p>
-          <a:p>
-            <a:pPr marL="520700" indent="-177800">
-              <a:spcAft>
-                <a:spcPts val="600"/>
-              </a:spcAft>
-              <a:buSzPct val="100000"/>
-              <a:buChar char="–"/>
-            </a:pPr>
-            <a:r>
-              <a:rPr lang="en-US" sz="1500" dirty="0">
-                <a:solidFill>
-                  <a:srgbClr val="000000"/>
-                </a:solidFill>
-                <a:latin typeface="Calibri" pitchFamily="34" charset="0"/>
-                <a:ea typeface="Calibri" pitchFamily="34" charset="-122"/>
-                <a:cs typeface="Calibri" pitchFamily="34" charset="-120"/>
-              </a:rPr>
-              <a:t xml:space="preserve">Eight metrics per run — three energies, overshoot, settling, oscillation energy, spurious gate voltage, crosstalk margin — frozen in one extractor early, so no later sweep becomes incomparable.</a:t>
-            </a:r>
-          </a:p>
-          <a:p>
-            <a:pPr marL="520700" indent="-177800">
-              <a:spcAft>
-                <a:spcPts val="600"/>
-              </a:spcAft>
-              <a:buSzPct val="100000"/>
-              <a:buChar char="–"/>
-            </a:pPr>
-            <a:r>
-              <a:rPr lang="en-US" sz="1500" dirty="0">
-                <a:solidFill>
-                  <a:srgbClr val="000000"/>
-                </a:solidFill>
-                <a:latin typeface="Calibri" pitchFamily="34" charset="0"/>
-                <a:ea typeface="Calibri" pitchFamily="34" charset="-122"/>
-                <a:cs typeface="Calibri" pitchFamily="34" charset="-120"/>
-              </a:rPr>
-              <a:t xml:space="preserve">Every reported quantity must be flat across a 5× timestep range. Enforced, not assumed: it has twice rejected a number that had already reached a draft.</a:t>
-            </a:r>
-          </a:p>
-          <a:p>
-            <a:pPr marL="177800" indent="-177800">
-              <a:spcAft>
-                <a:spcPts val="600"/>
-              </a:spcAft>
-              <a:buSzPct val="100000"/>
-              <a:buChar char="•"/>
-            </a:pPr>
-            <a:r>
-              <a:rPr lang="en-US" sz="1600" b="1" dirty="0">
-                <a:solidFill>
-                  <a:srgbClr val="000000"/>
-                </a:solidFill>
-                <a:latin typeface="Calibri" pitchFamily="34" charset="0"/>
-                <a:ea typeface="Calibri" pitchFamily="34" charset="-122"/>
-                <a:cs typeface="Calibri" pitchFamily="34" charset="-120"/>
-              </a:rPr>
-              <a:t xml:space="preserve">Project Scope:</a:t>
-            </a:r>
-          </a:p>
-          <a:p>
-            <a:pPr marL="520700" indent="-177800">
-              <a:spcAft>
-                <a:spcPts val="600"/>
-              </a:spcAft>
-              <a:buSzPct val="100000"/>
-              <a:buChar char="–"/>
-            </a:pPr>
-            <a:r>
-              <a:rPr lang="en-US" sz="1500" b="1" dirty="0">
-                <a:solidFill>
-                  <a:srgbClr val="000000"/>
-                </a:solidFill>
-                <a:latin typeface="Calibri" pitchFamily="34" charset="0"/>
-                <a:ea typeface="Calibri" pitchFamily="34" charset="-122"/>
-                <a:cs typeface="Calibri" pitchFamily="34" charset="-120"/>
-              </a:rPr>
-              <a:t xml:space="preserve">In scope: </a:t>
-            </a:r>
-            <a:r>
-              <a:rPr lang="en-US" sz="1500" dirty="0">
-                <a:solidFill>
-                  <a:srgbClr val="000000"/>
-                </a:solidFill>
-                <a:latin typeface="Calibri" pitchFamily="34" charset="0"/>
-                <a:ea typeface="Calibri" pitchFamily="34" charset="-122"/>
-                <a:cs typeface="Calibri" pitchFamily="34" charset="-120"/>
-              </a:rPr>
-              <a:t xml:space="preserve">driver architecture, control-word optimisation, transistor-level output stage in SKY130. </a:t>
-            </a:r>
-            <a:r>
-              <a:rPr lang="en-US" sz="1500" b="1" dirty="0">
-                <a:solidFill>
-                  <a:srgbClr val="000000"/>
-                </a:solidFill>
-                <a:latin typeface="Calibri" pitchFamily="34" charset="0"/>
-                <a:ea typeface="Calibri" pitchFamily="34" charset="-122"/>
-                <a:cs typeface="Calibri" pitchFamily="34" charset="-120"/>
-              </a:rPr>
-              <a:t xml:space="preserve">Out of scope: </a:t>
-            </a:r>
-            <a:r>
-              <a:rPr lang="en-US" sz="1500" dirty="0">
-                <a:solidFill>
-                  <a:srgbClr val="000000"/>
-                </a:solidFill>
-                <a:latin typeface="Calibri" pitchFamily="34" charset="0"/>
-                <a:ea typeface="Calibri" pitchFamily="34" charset="-122"/>
-                <a:cs typeface="Calibri" pitchFamily="34" charset="-120"/>
-              </a:rPr>
-              <a:t xml:space="preserve">GaN device fabrication, closed-loop sensing hardware, PCB build.</a:t>
+              <a:t xml:space="preserve">GaN device fabrication, sensing hardware, PCB build.</a:t>
             </a:r>
           </a:p>
         </p:txBody>

</xml_diff>

<commit_message>
deck: reconcile the two ceiling figures on slides 17 and 20
Slides 17 and 20 both used the word 'ceiling' for quantities computed on
different sweeps, so 5.2 % and 5.95 % read as a contradiction.

Verified they are not. ceiling.py reproduces 5.2 % exactly on
sweep_nominal.csv + full_corners.csv (four corners, 474 feasible words,
per-corner penalties 1.1/2.3/12.7/3.8 %). lloop_analyse.py and
robust_analyse.py run on lloop_sweep.csv.gz + robust_all.csv over two
corners, giving a different best fixed word and a 5.95 % nominal. All
three use the same cost weight (w_ov = 0.05), so weighting is not the
difference -- the corner set is.

No number changed. Slide 17 now names its denominator (= 3.9 % of
baseline) so it reconciles with RESULTS-SUMMARY, and slide 20 carries a
baseline note saying its nominal is a two-corner search and that the
'vs nom.' column, not the absolute values, is what compares to slide 17.

Co-Authored-By: Claude Opus 5 <noreply@anthropic.com>
</commit_message>
<xml_diff>
--- a/review/Review1_GaN_Segmented_Gate_Driver.pptx
+++ b/review/Review1_GaN_Segmented_Gate_Driver.pptx
@@ -4029,7 +4029,7 @@
                 <a:ea typeface="Calibri" pitchFamily="34" charset="-122"/>
                 <a:cs typeface="Calibri" pitchFamily="34" charset="-120"/>
               </a:rPr>
-              <a:t xml:space="preserve">vs the best single fixed word. A fixed word is nearly as good.</a:t>
+              <a:t xml:space="preserve">vs the best single fixed word (= 3.9 % of baseline). A fixed word is nearly as good.</a:t>
             </a:r>
           </a:p>
         </p:txBody>
@@ -7085,21 +7085,74 @@
           <a:p>
             <a:pPr marL="177800" indent="-177800">
               <a:spcAft>
+                <a:spcPts val="200"/>
+              </a:spcAft>
+              <a:buSzPct val="100000"/>
+              <a:buChar char="•"/>
+            </a:pPr>
+            <a:r>
+              <a:rPr lang="en-US" sz="1300" dirty="0">
+                <a:solidFill>
+                  <a:srgbClr val="000000"/>
+                </a:solidFill>
+                <a:latin typeface="Calibri" pitchFamily="34" charset="0"/>
+                <a:ea typeface="Calibri" pitchFamily="34" charset="-122"/>
+                <a:cs typeface="Calibri" pitchFamily="34" charset="-120"/>
+              </a:rPr>
+              <a:t xml:space="preserve">So the claim is narrower and more useful than “robust”: from about 2.5 nH upward a fixed word is nearly as good; on a tighter loop the question has to be re-asked, and the answer there is not even monotonic — see slide 19.</a:t>
+            </a:r>
+          </a:p>
+          <a:p>
+            <a:pPr marL="177800" indent="-177800">
+              <a:spcAft>
                 <a:spcPts val="0"/>
               </a:spcAft>
               <a:buSzPct val="100000"/>
               <a:buChar char="•"/>
             </a:pPr>
             <a:r>
-              <a:rPr lang="en-US" sz="1300" dirty="0">
-                <a:solidFill>
-                  <a:srgbClr val="000000"/>
-                </a:solidFill>
-                <a:latin typeface="Calibri" pitchFamily="34" charset="0"/>
-                <a:ea typeface="Calibri" pitchFamily="34" charset="-122"/>
-                <a:cs typeface="Calibri" pitchFamily="34" charset="-120"/>
-              </a:rPr>
-              <a:t xml:space="preserve">So the claim is narrower and more useful than “robust”: from about 2.5 nH upward a fixed word is nearly as good; on a tighter loop the question has to be re-asked, and the answer there is not even monotonic — see slide 19.</a:t>
+              <a:rPr lang="en-US" sz="1150" b="1" dirty="0">
+                <a:solidFill>
+                  <a:srgbClr val="000000"/>
+                </a:solidFill>
+                <a:latin typeface="Calibri" pitchFamily="34" charset="0"/>
+                <a:ea typeface="Calibri" pitchFamily="34" charset="-122"/>
+                <a:cs typeface="Calibri" pitchFamily="34" charset="-120"/>
+              </a:rPr>
+              <a:t xml:space="preserve">Baseline note. </a:t>
+            </a:r>
+            <a:r>
+              <a:rPr lang="en-US" sz="1150" dirty="0">
+                <a:solidFill>
+                  <a:srgbClr val="000000"/>
+                </a:solidFill>
+                <a:latin typeface="Calibri" pitchFamily="34" charset="0"/>
+                <a:ea typeface="Calibri" pitchFamily="34" charset="-122"/>
+                <a:cs typeface="Calibri" pitchFamily="34" charset="-120"/>
+              </a:rPr>
+              <a:t xml:space="preserve">Nominal here is 5.95 %, not the 5.2 % headline — a two-corner search on its own sweep. Compare the </a:t>
+            </a:r>
+            <a:r>
+              <a:rPr lang="en-US" sz="1150" b="1" dirty="0">
+                <a:solidFill>
+                  <a:srgbClr val="000000"/>
+                </a:solidFill>
+                <a:latin typeface="Calibri" pitchFamily="34" charset="0"/>
+                <a:ea typeface="Calibri" pitchFamily="34" charset="-122"/>
+                <a:cs typeface="Calibri" pitchFamily="34" charset="-120"/>
+              </a:rPr>
+              <a:t xml:space="preserve">vs nom.</a:t>
+            </a:r>
+            <a:r>
+              <a:rPr lang="en-US" sz="1150" dirty="0">
+                <a:solidFill>
+                  <a:srgbClr val="000000"/>
+                </a:solidFill>
+                <a:latin typeface="Calibri" pitchFamily="34" charset="0"/>
+                <a:ea typeface="Calibri" pitchFamily="34" charset="-122"/>
+                <a:cs typeface="Calibri" pitchFamily="34" charset="-120"/>
+              </a:rPr>
+              <a:t xml:space="preserve"> column, not the absolute values.</a:t>
             </a:r>
           </a:p>
         </p:txBody>

</xml_diff>

<commit_message>
deck: sharpen the closest prior art, justify the Cadence request
Slide 6's row for [10] described it generically. Verified specifics are now
on the slide: 7 segmented slices, 0.5-5 ns pattern timing, drive strength set
by one external bias resistor. [10] is the architecturally closest published
driver, so showing we have read it in that detail is worth the line.

Slide 23 asked for Cadence in Review-II without saying why silicon is needed.
It now carries the argument: [13] reaches 0.19 ns dead time in 0.18 um BCD,
where a 200 MHz FPGA grid is 5 ns -- roughly 25x coarser. Sub-nanosecond
dead-time control needs silicon, not fabric. That turns the access request
into a technical justification.

Deck validates; qa.py reports the same 8 lines as before (all previously
investigated false positives), so no new geometry problems.

Co-Authored-By: Claude Opus 5 <noreply@anthropic.com>
</commit_message>
<xml_diff>
--- a/review/Review1_GaN_Segmented_Gate_Driver.pptx
+++ b/review/Review1_GaN_Segmented_Gate_Driver.pptx
@@ -8619,7 +8619,7 @@
                 <a:ea typeface="Calibri" pitchFamily="34" charset="-122"/>
                 <a:cs typeface="Calibri" pitchFamily="34" charset="-120"/>
               </a:rPr>
-              <a:t xml:space="preserve">transistor-level output stage in Cadence on a 5 V-capable PDK; re-run the ceiling on real devices. </a:t>
+              <a:t xml:space="preserve">transistor-level output stage in Cadence on a 5 V-capable PDK; re-run the ceiling on real devices — sub-nanosecond dead-time control needs silicon, not fabric: [13] reaches 0.19 ns where a 200 MHz FPGA grid is 5 ns. </a:t>
             </a:r>
             <a:r>
               <a:rPr lang="en-US" sz="1450" b="1" dirty="0">
@@ -17445,7 +17445,7 @@
                           </a:solidFill>
                           <a:latin typeface="Calibri"/>
                         </a:rPr>
-                        <a:t>Segmented output stage on E-mode GaN with an on-chip pattern generator for drive strength</a:t>
+                        <a:t>Segmented output stage on E-mode GaN: 7 slices, pattern timing 0.5–5 ns, strength set by one external bias resistor</a:t>
                       </a:r>
                       <a:endParaRPr lang="en-US" sz="1300" dirty="0">
                         <a:latin typeface="Calibri" charset="0"/>

</xml_diff>

<commit_message>
deck: put the synthesis result on slide 14 and in the results summary
Slide 14 now carries the hardware side of the argument: strapping the control
word instead of leaving all six fields live takes the controller from 371
cells to 129, so 65 % less logic for the 3.9 % of baseline that adaptation
buys. Labelled as generic gates rather than Xilinx LUTs, because ABC does not
complete in the WASM Yosys build.

RESULTS-SUMMARY gains a WHAT THE ADAPTIVE HARDWARE COSTS section with both
cell/FF counts and the script that regenerates them.

RTL block measures 2.45 in of its 2.55 in budget; deck validates; qa.py
reports the same 8 lines as every prior run.

Co-Authored-By: Claude Opus 5 <noreply@anthropic.com>
Claude-Session: https://claude.ai/code/session_01G68jkQqEKnRspdjUF9vfMm
</commit_message>
<xml_diff>
--- a/review/Review1_GaN_Segmented_Gate_Driver.pptx
+++ b/review/Review1_GaN_Segmented_Gate_Driver.pptx
@@ -3076,6 +3076,59 @@
                 <a:cs typeface="Calibri" pitchFamily="34" charset="-120"/>
               </a:rPr>
               <a:t xml:space="preserve">Eight asserted properties, all passing under Icarus Verilog; a deliberate shoot-through mutant is caught 221 times (sh rtl/mutate.sh).</a:t>
+            </a:r>
+          </a:p>
+          <a:p>
+            <a:pPr marL="520700" indent="-177800">
+              <a:spcAft>
+                <a:spcPts val="600"/>
+              </a:spcAft>
+              <a:buSzPct val="100000"/>
+              <a:buChar char="–"/>
+            </a:pPr>
+            <a:r>
+              <a:rPr lang="en-US" sz="1500" b="1" dirty="0">
+                <a:solidFill>
+                  <a:srgbClr val="000000"/>
+                </a:solidFill>
+                <a:latin typeface="Calibri" pitchFamily="34" charset="0"/>
+                <a:ea typeface="Calibri" pitchFamily="34" charset="-122"/>
+                <a:cs typeface="Calibri" pitchFamily="34" charset="-120"/>
+              </a:rPr>
+              <a:t xml:space="preserve">Synthesised. </a:t>
+            </a:r>
+            <a:r>
+              <a:rPr lang="en-US" sz="1500" dirty="0">
+                <a:solidFill>
+                  <a:srgbClr val="000000"/>
+                </a:solidFill>
+                <a:latin typeface="Calibri" pitchFamily="34" charset="0"/>
+                <a:ea typeface="Calibri" pitchFamily="34" charset="-122"/>
+                <a:cs typeface="Calibri" pitchFamily="34" charset="-120"/>
+              </a:rPr>
+              <a:t xml:space="preserve">Strapping the word instead of leaving all six fields live takes the controller from </a:t>
+            </a:r>
+            <a:r>
+              <a:rPr lang="en-US" sz="1500" b="1" dirty="0">
+                <a:solidFill>
+                  <a:srgbClr val="000000"/>
+                </a:solidFill>
+                <a:latin typeface="Calibri" pitchFamily="34" charset="0"/>
+                <a:ea typeface="Calibri" pitchFamily="34" charset="-122"/>
+                <a:cs typeface="Calibri" pitchFamily="34" charset="-120"/>
+              </a:rPr>
+              <a:t xml:space="preserve">371 cells to 129</a:t>
+            </a:r>
+            <a:r>
+              <a:rPr lang="en-US" sz="1500" dirty="0">
+                <a:solidFill>
+                  <a:srgbClr val="000000"/>
+                </a:solidFill>
+                <a:latin typeface="Calibri" pitchFamily="34" charset="0"/>
+                <a:ea typeface="Calibri" pitchFamily="34" charset="-122"/>
+                <a:cs typeface="Calibri" pitchFamily="34" charset="-120"/>
+              </a:rPr>
+              <a:t xml:space="preserve"> — 65 % less logic for the 3.9 % of baseline that adaptation buys. Generic gates, not Xilinx LUTs.</a:t>
             </a:r>
           </a:p>
         </p:txBody>

</xml_diff>

<commit_message>
deck: point the reproducibility link at the gan-driver repo
Slide 15 cited 'github.com/Amritha902/vero, under gan-driver/'. Now cites
github.com/Amritha902/gan-driver directly, ahead of the subtree split.

Note for whoever presents: that repository does not exist yet. It has to be
created and pushed (HANDOFF.md, 'Splitting this project into its own
repository') or the link on the slide is dead.

Deck rebuilds to 27 slides, validates, qa.py at the usual 8 known lines.

Co-Authored-By: Claude Opus 5 <noreply@anthropic.com>
Claude-Session: https://claude.ai/code/session_01G68jkQqEKnRspdjUF9vfMm
</commit_message>
<xml_diff>
--- a/review/Review1_GaN_Segmented_Gate_Driver.pptx
+++ b/review/Review1_GaN_Segmented_Gate_Driver.pptx
@@ -2763,29 +2763,7 @@
                 <a:ea typeface="Calibri" pitchFamily="34" charset="-122"/>
                 <a:cs typeface="Calibri" pitchFamily="34" charset="-120"/>
               </a:rPr>
-              <a:t xml:space="preserve">github.com/Amritha902/vero</a:t>
-            </a:r>
-            <a:r>
-              <a:rPr lang="en-US" sz="1500" dirty="0">
-                <a:solidFill>
-                  <a:srgbClr val="000000"/>
-                </a:solidFill>
-                <a:latin typeface="Calibri" pitchFamily="34" charset="0"/>
-                <a:ea typeface="Calibri" pitchFamily="34" charset="-122"/>
-                <a:cs typeface="Calibri" pitchFamily="34" charset="-120"/>
-              </a:rPr>
-              <a:t xml:space="preserve">, under </a:t>
-            </a:r>
-            <a:r>
-              <a:rPr lang="en-US" sz="1500" b="1" dirty="0">
-                <a:solidFill>
-                  <a:srgbClr val="000000"/>
-                </a:solidFill>
-                <a:latin typeface="Calibri" pitchFamily="34" charset="0"/>
-                <a:ea typeface="Calibri" pitchFamily="34" charset="-122"/>
-                <a:cs typeface="Calibri" pitchFamily="34" charset="-120"/>
-              </a:rPr>
-              <a:t xml:space="preserve">gan-driver/</a:t>
+              <a:t xml:space="preserve">github.com/Amritha902/gan-driver</a:t>
             </a:r>
             <a:r>
               <a:rPr lang="en-US" sz="1500" dirty="0">

</xml_diff>

<commit_message>
Fix slide 1 text overflow and corner overlap
Co-Authored-By: Claude Sonnet 5 <noreply@anthropic.com>
Claude-Session: https://claude.ai/code/session_01Tk9Fwx1Mh2DbuNmZCWA4F7
</commit_message>
<xml_diff>
--- a/review/Review1_GaN_Segmented_Gate_Driver.pptx
+++ b/review/Review1_GaN_Segmented_Gate_Driver.pptx
@@ -2236,7 +2236,7 @@
         <p:spPr>
           <a:xfrm>
             <a:off x="548640" y="320040"/>
-            <a:ext cx="9601200" cy="685800"/>
+            <a:ext cx="9601200" cy="914400"/>
           </a:xfrm>
           <a:prstGeom prst="rect">
             <a:avLst/>
@@ -2299,7 +2299,7 @@
         <p:spPr>
           <a:xfrm>
             <a:off x="640080" y="1554480"/>
-            <a:ext cx="10881360" cy="4937760"/>
+            <a:ext cx="10881360" cy="4828032"/>
           </a:xfrm>
           <a:prstGeom prst="rect">
             <a:avLst/>

</xml_diff>

<commit_message>
Run the LTspice port in real LTspice; set reg number and review date
LTspice 24 on macOS confirms the three shipped .cir files: 1.64869 / 0.82821 /
-1.17681 V against ngspice's 1.649 / 0.830 / -1.176 -- within 2 mV on all
three. The port is correct and the crosstalk result is not an artefact of one
simulator, so slides 14 and 24 no longer claim LTspice was never run. Spectre
is still a port and still says so.

The macOS launcher drops the -b batch flag (LTspice 24 for Mac is a Wine
wrapper), so `LTspice -b -Run x.cir` opens the GUI and hangs. README-LTSPICE.txt
now records the working invocation through the bundled wine.

Title slide: reg number 23BEC1368, and the review date moved from 02.09.2026
to 09.09.2026 on slides 2 and 3. Both dates are Wednesdays so the day name on
slide 2 still holds.

Co-Authored-By: Claude Opus 5 <noreply@anthropic.com>
</commit_message>
<xml_diff>
--- a/review/Review1_GaN_Segmented_Gate_Driver.pptx
+++ b/review/Review1_GaN_Segmented_Gate_Driver.pptx
@@ -8214,7 +8214,7 @@
                 <a:ea typeface="Calibri" pitchFamily="34" charset="-122"/>
                 <a:cs typeface="Calibri" pitchFamily="34" charset="-120"/>
               </a:rPr>
-              <a:t xml:space="preserve">LTspice and Spectre decks are faithful ports re-simulated to the same numbers, but neither simulator has itself been run — no installation was available.</a:t>
+              <a:t xml:space="preserve">LTspice has now been run: the three shipped .cir files reproduce 1.6487 / 0.8282 / −1.1768 V, matching ngspice to within 2 mV. Spectre is still a port — no installation available.</a:t>
             </a:r>
           </a:p>
         </p:txBody>
@@ -8964,7 +8964,7 @@
                 <a:ea typeface="Calibri" pitchFamily="34" charset="-122"/>
                 <a:cs typeface="Calibri" pitchFamily="34" charset="-120"/>
               </a:rPr>
-              <a:t>Amritha  —  Reg. No. ________</a:t>
+              <a:t>Amritha S  —  23BEC1368</a:t>
             </a:r>
             <a:endParaRPr lang="en-US" sz="1400" dirty="0"/>
           </a:p>
@@ -9288,7 +9288,7 @@
                 <a:ea typeface="Calibri" pitchFamily="34" charset="-122"/>
                 <a:cs typeface="Calibri" pitchFamily="34" charset="-120"/>
               </a:rPr>
-              <a:t>Review-I  ·  02.09.2026 (Wednesday)</a:t>
+              <a:t>Review-I  ·  09.09.2026 (Wednesday)</a:t>
             </a:r>
             <a:endParaRPr lang="en-US" sz="1400" dirty="0"/>
           </a:p>
@@ -15265,7 +15265,7 @@
                 <a:ea typeface="Calibri" pitchFamily="34" charset="-122"/>
                 <a:cs typeface="Calibri" pitchFamily="34" charset="-120"/>
               </a:rPr>
-              <a:t>Review-I — 02.09.2026 (5 Marks, 5%)</a:t>
+              <a:t>Review-I — 09.09.2026 (5 Marks, 5%)</a:t>
             </a:r>
             <a:endParaRPr lang="en-US" sz="2800" dirty="0"/>
           </a:p>
@@ -21237,7 +21237,7 @@
                 <a:ea typeface="Calibri" pitchFamily="34" charset="-122"/>
                 <a:cs typeface="Calibri" pitchFamily="34" charset="-120"/>
               </a:rPr>
-              <a:t xml:space="preserve">The port to other simulators is written and re-simulated.</a:t>
+              <a:t xml:space="preserve">The LTspice port has been run in LTspice.</a:t>
             </a:r>
           </a:p>
           <a:p>
@@ -21257,7 +21257,7 @@
                 <a:ea typeface="Calibri" pitchFamily="34" charset="-122"/>
                 <a:cs typeface="Calibri" pitchFamily="34" charset="-120"/>
               </a:rPr>
-              <a:t xml:space="preserve">LTspice-dialect and Spectre decks both reproduce 122.4 V / 5.00 V / 1.65 V. Neither has itself been run — no installation was available — so these are faithful ports.</a:t>
+              <a:t xml:space="preserve">The three shipped .cir files give 1.6487 / 0.8282 / −1.1768 V in LTspice 24, matching ngspice within 2 mV — the result is not an artefact of one simulator. Spectre remains a port.</a:t>
             </a:r>
           </a:p>
           <a:p>

</xml_diff>

<commit_message>
Complete all 13 references from the publisher record
Crossref is reachable from a local machine, which the cloud container's egress
proxy blocked. All nine references that carried "authors: Xplore Cite This"
now have full author lists, volume, issue, pages and DOI, resolved by title
with a 1.00 match on every one and cross-checked against the stored Xplore
document IDs. Ref [9] gains its citation line, confirmed by DOI
10.1002/cta.3136.

Nothing was transcribed by hand and nothing was guessed. The references slide
footnote is now conditional and reads "All 13 verified against the publisher
record" instead of "3 of 13", and no survey row still shows the placeholder.

Co-Authored-By: Claude Opus 5 <noreply@anthropic.com>
</commit_message>
<xml_diff>
--- a/review/Review1_GaN_Segmented_Gate_Driver.pptx
+++ b/review/Review1_GaN_Segmented_Gate_Driver.pptx
@@ -9821,7 +9821,7 @@
                 <a:ea typeface="Calibri" pitchFamily="34" charset="-122"/>
                 <a:cs typeface="Calibri" pitchFamily="34" charset="-120"/>
               </a:rPr>
-              <a:t xml:space="preserve">“Crosstalk Suppression Method for GaN-Based Bridge Configuration Using Negative Voltage Self-Recovery Gate Drive,” IEEE Trans. Power Electron., 2021,  [author list and page range: Xplore “Cite This”]</a:t>
+              <a:t xml:space="preserve">B. Li, G. Zhang, C. Li, G. Wang, S. Liu and D. Xu, “Crosstalk Suppression Method for GaN-Based Bridge Configuration Using Negative Voltage Self-Recovery Gate Drive,” IEEE Trans. Power Electron., vol. 37, no. 4, pp. 4406–4418, 2022.</a:t>
             </a:r>
             <a:r>
               <a:rPr lang="en-US" sz="900" b="1" dirty="0">
@@ -9863,7 +9863,7 @@
                 <a:ea typeface="Calibri" pitchFamily="34" charset="-122"/>
                 <a:cs typeface="Calibri" pitchFamily="34" charset="-120"/>
               </a:rPr>
-              <a:t xml:space="preserve">“A Novel Control Strategy for Optimal Tradeoff between Overshoot and Switching Loss Based on Double Closed-Loop Self-Regulating Active Gate Driver,” IEEE journal, 2024,  [author list and page range: Xplore “Cite This”]</a:t>
+              <a:t xml:space="preserve">X. Chen, H. Peng, S. Song, Q. Tong and Y. Kang, “A Novel Control Strategy for Optimal Tradeoff between Overshoot and Switching Loss Based on Double Closed-Loop Self-Regulating Active Gate Driver,” IEEE Trans. Power Electron., vol. 39, no. 10, pp. 13033–13043, 2024.</a:t>
             </a:r>
             <a:r>
               <a:rPr lang="en-US" sz="900" b="1" dirty="0">
@@ -9905,7 +9905,7 @@
                 <a:ea typeface="Calibri" pitchFamily="34" charset="-122"/>
                 <a:cs typeface="Calibri" pitchFamily="34" charset="-120"/>
               </a:rPr>
-              <a:t xml:space="preserve">“A Self-Regulating Active Gate Driver of Voltage Overshoot Suppression for SiC MOSFETs Under Variable Load Current Conditions,” IEEE journal, 2025,  [author list and page range: Xplore “Cite This”]</a:t>
+              <a:t xml:space="preserve">W. Song, T. Hu, J. Chen, T. Tang, H. Yue and G. Liu, “A Self-Regulating Active Gate Driver of Voltage Overshoot Suppression for SiC MOSFETs Under Variable Load Current Conditions,” IEEE Trans. Power Electron., vol. 40, no. 8, pp. 10623–10634, 2025.</a:t>
             </a:r>
             <a:r>
               <a:rPr lang="en-US" sz="900" b="1" dirty="0">
@@ -9947,7 +9947,7 @@
                 <a:ea typeface="Calibri" pitchFamily="34" charset="-122"/>
                 <a:cs typeface="Calibri" pitchFamily="34" charset="-120"/>
               </a:rPr>
-              <a:t xml:space="preserve">“Universal Active Gate Driver IC With Closed-Loop Timing Control and Gate-Sensing Technique for Silicon Carbide Power Devices,” IEEE journal, 2025,  [author list and page range: Xplore “Cite This”]</a:t>
+              <a:t xml:space="preserve">C.W. Kuo, T.W. Wang, L.C. Chen, C.C. Tu, Y.K. Hsiao and P.H. Chen, “Universal Active Gate Driver IC With Closed-Loop Timing Control and Gate-Sensing Technique for Silicon Carbide Power Devices,” IEEE Trans. Power Electron., vol. 40, no. 4, pp. 5120–5129, 2025.</a:t>
             </a:r>
             <a:r>
               <a:rPr lang="en-US" sz="900" b="1" dirty="0">
@@ -9989,7 +9989,7 @@
                 <a:ea typeface="Calibri" pitchFamily="34" charset="-122"/>
                 <a:cs typeface="Calibri" pitchFamily="34" charset="-120"/>
               </a:rPr>
-              <a:t xml:space="preserve">“An Integrated Driver With Dual-Edge Adaptive Dead-Time Control for GaN-Based Synchronous Buck Converter,” IEEE Trans. Ind. Appl., vol. 60, 2024, doi: 10.1109/TIA.2024.3454198.  [author list and page range: Xplore “Cite This”]</a:t>
+              <a:t xml:space="preserve">G.H. Thuc and C.J. Chen, “An Integrated Driver With Dual-Edge Adaptive Dead-Time Control for GaN-Based Synchronous Buck Converter,” IEEE Trans. Ind. Appl., vol. 60, no. 6, pp. 9157–9170, 2024.</a:t>
             </a:r>
             <a:r>
               <a:rPr lang="en-US" sz="900" b="1" dirty="0">
@@ -10042,7 +10042,7 @@
                 <a:ea typeface="Calibri" pitchFamily="34" charset="-122"/>
                 <a:cs typeface="Calibri" pitchFamily="34" charset="-120"/>
               </a:rPr>
-              <a:t xml:space="preserve">H. Takayama, T. Okuda &amp; T. Hikihara, “Digital Active Gate Drive of SiC MOSFETs for Controlling Switching Behavior — Preparation Toward Universal Digitization of Power Switching,” Int. J. Circuit Theory Appl., vol. 50, no. 1, pp. 183–196, 2022, doi: 10.1002/cta.3136.  [author list and page range: Xplore “Cite This”]</a:t>
+              <a:t xml:space="preserve">H. Takayama, T. Okuda and T. Hikihara, “Digital Active Gate Drive of SiC MOSFETs for Controlling Switching Behavior — Preparation Toward Universal Digitization of Power Switching,” Int. J. Circuit Theory Appl., vol. 50, no. 1, pp. 183–196, 2022.</a:t>
             </a:r>
             <a:r>
               <a:rPr lang="en-US" sz="900" b="1" dirty="0">
@@ -10084,7 +10084,7 @@
                 <a:ea typeface="Calibri" pitchFamily="34" charset="-122"/>
                 <a:cs typeface="Calibri" pitchFamily="34" charset="-120"/>
               </a:rPr>
-              <a:t xml:space="preserve">“A Segmented Gate Driver for E-mode GaN HEMTs with Simple Driving Strength Pattern Control,” IEEE conference, 2020,  [author list and page range: Xplore “Cite This”]</a:t>
+              <a:t xml:space="preserve">W.J. Zhang, J. Yu, Y. Leng, W.T. Cui, G.Q. Deng and W.T. Ng, “A Segmented Gate Driver for E-mode GaN HEMTs with Simple Driving Strength Pattern Control,” in Proc. IEEE 32nd Int. Symp. Power Semicond. Devices ICs (ISPSD), 2020, pp. 102–105.</a:t>
             </a:r>
             <a:r>
               <a:rPr lang="en-US" sz="900" b="1" dirty="0">
@@ -10126,7 +10126,7 @@
                 <a:ea typeface="Calibri" pitchFamily="34" charset="-122"/>
                 <a:cs typeface="Calibri" pitchFamily="34" charset="-120"/>
               </a:rPr>
-              <a:t xml:space="preserve">“High-Frequency Three-Level Gate Driver for GaN HEMT Bridge Crosstalk Suppression,” IEEE journal, 2024,  [author list and page range: Xplore “Cite This”]</a:t>
+              <a:t xml:space="preserve">X. Wang, M. Tao, J. Xiao, D. Luo, M. He, Q. Zhou, X. Zhang and M. Wang, “High-Frequency Three-Level Gate Driver for GaN HEMT Bridge Crosstalk Suppression,” IEEE Trans. Power Electron., vol. 39, no. 1, pp. 1343–1352, 2024.</a:t>
             </a:r>
             <a:r>
               <a:rPr lang="en-US" sz="900" b="1" dirty="0">
@@ -10168,7 +10168,7 @@
                 <a:ea typeface="Calibri" pitchFamily="34" charset="-122"/>
                 <a:cs typeface="Calibri" pitchFamily="34" charset="-120"/>
               </a:rPr>
-              <a:t xml:space="preserve">“An Integrated Suppression Method of Both Gate-Source Voltage Oscillation and Crosstalk for GaN HEMT Gate Driver,” IEEE journal, 2024,  [author list and page range: Xplore “Cite This”]</a:t>
+              <a:t xml:space="preserve">L. Wang, X. Sun, Y. Yan, M. Ma and D. Xu, “An Integrated Suppression Method of Both Gate-Source Voltage Oscillation and Crosstalk for GaN HEMT Gate Driver,” IEEE Trans. Power Electron., vol. 39, no. 11, pp. 14643–14655, 2024.</a:t>
             </a:r>
             <a:r>
               <a:rPr lang="en-US" sz="900" b="1" dirty="0">
@@ -10210,7 +10210,7 @@
                 <a:ea typeface="Calibri" pitchFamily="34" charset="-122"/>
                 <a:cs typeface="Calibri" pitchFamily="34" charset="-120"/>
               </a:rPr>
-              <a:t xml:space="preserve">“A High-Efficient GaN Driver With Hybrid Adaptive Dead-Time Control and Peak Delay Control for Synchronous Buck Converter,” IEEE journal, 2025,  [author list and page range: Xplore “Cite This”]</a:t>
+              <a:t xml:space="preserve">Y. Cai, D. Ye, W. Lv and Z. Chen, “A High-Efficient GaN Driver With Hybrid Adaptive Dead-Time Control and Peak Delay Control for Synchronous Buck Converter,” IEEE Trans. Power Electron., vol. 41, no. 1, pp. 279–290, 2026.</a:t>
             </a:r>
             <a:r>
               <a:rPr lang="en-US" sz="900" b="1" dirty="0">
@@ -10241,7 +10241,7 @@
                 <a:ea typeface="Calibri" pitchFamily="34" charset="-122"/>
                 <a:cs typeface="Calibri" pitchFamily="34" charset="-120"/>
               </a:rPr>
-              <a:t xml:space="preserve">3 of 13 verified against the publisher record. </a:t>
+              <a:t xml:space="preserve">All 13 verified against the publisher record </a:t>
             </a:r>
             <a:r>
               <a:rPr lang="en-US" sz="850" dirty="0">
@@ -10252,18 +10252,7 @@
                 <a:ea typeface="Calibri" pitchFamily="34" charset="-122"/>
                 <a:cs typeface="Calibri" pitchFamily="34" charset="-120"/>
               </a:rPr>
-              <a:t xml:space="preserve">The remaining 10 carry title, journal status and Xplore document ID; </a:t>
-            </a:r>
-            <a:r>
-              <a:rPr lang="en-US" sz="850" dirty="0">
-                <a:solidFill>
-                  <a:srgbClr val="000000"/>
-                </a:solidFill>
-                <a:latin typeface="Calibri" pitchFamily="34" charset="0"/>
-                <a:ea typeface="Calibri" pitchFamily="34" charset="-122"/>
-                <a:cs typeface="Calibri" pitchFamily="34" charset="-120"/>
-              </a:rPr>
-              <a:t xml:space="preserve">volume, issue, pages and authors were not reachable from the build environment and are left blank rather than guessed.</a:t>
+              <a:t xml:space="preserve">— authors, volume, issue and pages resolved through Crossref by DOI and title, not transcribed by hand.</a:t>
             </a:r>
           </a:p>
         </p:txBody>
@@ -18411,7 +18400,7 @@
                       <a:r>
                         <a:rPr sz="1050" b="0">
                           <a:solidFill>
-                            <a:srgbClr val="7A7A7A"/>
+                            <a:srgbClr val="000000"/>
                           </a:solidFill>
                           <a:latin typeface="Calibri"/>
                         </a:rPr>
@@ -18773,28 +18762,17 @@
                       <a:r>
                         <a:rPr sz="1050" b="0">
                           <a:solidFill>
-                            <a:srgbClr val="7A7A7A"/>
+                            <a:srgbClr val="000000"/>
                           </a:solidFill>
                           <a:latin typeface="Calibri"/>
                         </a:rPr>
-                        <a:t>2020</a:t>
+                        <a:t>Zhang, Yu, Leng, Cui, Deng &amp; Ng (2020)</a:t>
                       </a:r>
                       <a:endParaRPr lang="en-US" sz="1300" dirty="0">
                         <a:latin typeface="Calibri" charset="0"/>
                         <a:ea typeface="Calibri" charset="0"/>
                         <a:cs typeface="Calibri" charset="0"/>
                       </a:endParaRPr>
-                    </a:p>
-                    <a:p>
-                      <a:r>
-                        <a:rPr sz="1050" b="0">
-                          <a:solidFill>
-                            <a:srgbClr val="7A7A7A"/>
-                          </a:solidFill>
-                          <a:latin typeface="Calibri"/>
-                        </a:rPr>
-                        <a:t>authors: Xplore “Cite This”</a:t>
-                      </a:r>
                     </a:p>
                   </a:txBody>
                   <a:tcPr marL="54864" marR="54864" marT="54864" marB="54864" anchor="ctr">
@@ -18867,7 +18845,7 @@
                           </a:solidFill>
                           <a:latin typeface="Calibri"/>
                         </a:rPr>
-                        <a:t>IEEE conference</a:t>
+                        <a:t>Proc. IEEE ISPSD, 2020, pp. 102–105</a:t>
                       </a:r>
                     </a:p>
                     <a:p>
@@ -19146,28 +19124,17 @@
                       <a:r>
                         <a:rPr sz="1050" b="0">
                           <a:solidFill>
-                            <a:srgbClr val="7A7A7A"/>
+                            <a:srgbClr val="000000"/>
                           </a:solidFill>
                           <a:latin typeface="Calibri"/>
                         </a:rPr>
-                        <a:t>2024</a:t>
+                        <a:t>Wang, Tao, Xiao, Luo, He, Zhou, Zhang &amp; Wang (2024)</a:t>
                       </a:r>
                       <a:endParaRPr lang="en-US" sz="1300" dirty="0">
                         <a:latin typeface="Calibri" charset="0"/>
                         <a:ea typeface="Calibri" charset="0"/>
                         <a:cs typeface="Calibri" charset="0"/>
                       </a:endParaRPr>
-                    </a:p>
-                    <a:p>
-                      <a:r>
-                        <a:rPr sz="1050" b="0">
-                          <a:solidFill>
-                            <a:srgbClr val="7A7A7A"/>
-                          </a:solidFill>
-                          <a:latin typeface="Calibri"/>
-                        </a:rPr>
-                        <a:t>authors: Xplore “Cite This”</a:t>
-                      </a:r>
                     </a:p>
                   </a:txBody>
                   <a:tcPr marL="54864" marR="54864" marT="54864" marB="54864" anchor="ctr">
@@ -19240,7 +19207,7 @@
                           </a:solidFill>
                           <a:latin typeface="Calibri"/>
                         </a:rPr>
-                        <a:t>IEEE journal</a:t>
+                        <a:t>IEEE Trans. Power Electron., 39(1), 1343–1352</a:t>
                       </a:r>
                     </a:p>
                     <a:p>
@@ -19519,28 +19486,17 @@
                       <a:r>
                         <a:rPr sz="1050" b="0">
                           <a:solidFill>
-                            <a:srgbClr val="7A7A7A"/>
+                            <a:srgbClr val="000000"/>
                           </a:solidFill>
                           <a:latin typeface="Calibri"/>
                         </a:rPr>
-                        <a:t>2024</a:t>
+                        <a:t>Wang, Sun, Yan, Ma &amp; Xu (2024)</a:t>
                       </a:r>
                       <a:endParaRPr lang="en-US" sz="1300" dirty="0">
                         <a:latin typeface="Calibri" charset="0"/>
                         <a:ea typeface="Calibri" charset="0"/>
                         <a:cs typeface="Calibri" charset="0"/>
                       </a:endParaRPr>
-                    </a:p>
-                    <a:p>
-                      <a:r>
-                        <a:rPr sz="1050" b="0">
-                          <a:solidFill>
-                            <a:srgbClr val="7A7A7A"/>
-                          </a:solidFill>
-                          <a:latin typeface="Calibri"/>
-                        </a:rPr>
-                        <a:t>authors: Xplore “Cite This”</a:t>
-                      </a:r>
                     </a:p>
                   </a:txBody>
                   <a:tcPr marL="54864" marR="54864" marT="54864" marB="54864" anchor="ctr">
@@ -19613,7 +19569,7 @@
                           </a:solidFill>
                           <a:latin typeface="Calibri"/>
                         </a:rPr>
-                        <a:t>IEEE journal</a:t>
+                        <a:t>IEEE Trans. Power Electron., 39(11), 14643–14655</a:t>
                       </a:r>
                     </a:p>
                     <a:p>
@@ -19892,28 +19848,17 @@
                       <a:r>
                         <a:rPr sz="1050" b="0">
                           <a:solidFill>
-                            <a:srgbClr val="7A7A7A"/>
+                            <a:srgbClr val="000000"/>
                           </a:solidFill>
                           <a:latin typeface="Calibri"/>
                         </a:rPr>
-                        <a:t>2025</a:t>
+                        <a:t>Cai, Ye, Lv &amp; Chen (2026)</a:t>
                       </a:r>
                       <a:endParaRPr lang="en-US" sz="1300" dirty="0">
                         <a:latin typeface="Calibri" charset="0"/>
                         <a:ea typeface="Calibri" charset="0"/>
                         <a:cs typeface="Calibri" charset="0"/>
                       </a:endParaRPr>
-                    </a:p>
-                    <a:p>
-                      <a:r>
-                        <a:rPr sz="1050" b="0">
-                          <a:solidFill>
-                            <a:srgbClr val="7A7A7A"/>
-                          </a:solidFill>
-                          <a:latin typeface="Calibri"/>
-                        </a:rPr>
-                        <a:t>authors: Xplore “Cite This”</a:t>
-                      </a:r>
                     </a:p>
                   </a:txBody>
                   <a:tcPr marL="54864" marR="54864" marT="54864" marB="54864" anchor="ctr">
@@ -19986,7 +19931,7 @@
                           </a:solidFill>
                           <a:latin typeface="Calibri"/>
                         </a:rPr>
-                        <a:t>IEEE journal</a:t>
+                        <a:t>IEEE Trans. Power Electron., 41(1), 279–290</a:t>
                       </a:r>
                     </a:p>
                     <a:p>

</xml_diff>

<commit_message>
Expand the literature survey to 30 verified references
Seventeen further papers, found by Crossref topic search and kept only where
the record carried a real author list: 2022-2026, mostly journals, assigned to
the four existing clusters. Every one is publisher-verified the same way as
the first thirteen, so the deck now states "30 references, all publisher-
verified" rather than a minimum-met count.

Thirty citations need 9.6 in in a 4.75 in box, so the references slide is now
two: 1-15 and 16-30. Shrinking the type to fit would have been the wrong fix --
nobody reads 7 pt from the back of a room. Deck is 28 slides.

Wrapping was rebuilt with break_on_hyphens=False after the first pass rendered
"Turn- Off" and "Dual- Polarity" in the citations.

Speech script updated: 28 slides, and the references line now says thirty
verified rather than thirteen.

Co-Authored-By: Claude Opus 5 <noreply@anthropic.com>
</commit_message>
<xml_diff>
--- a/review/Review1_GaN_Segmented_Gate_Driver.pptx
+++ b/review/Review1_GaN_Segmented_Gate_Driver.pptx
@@ -34,6 +34,7 @@
     <p:sldId id="270" r:id="rId21"/>
     <p:sldId id="271" r:id="rId22"/>
     <p:sldId id="265" r:id="rId11"/>
+    <p:sldId id="283" r:id="rId34"/>
     <p:sldId id="266" r:id="rId12"/>
   </p:sldIdLst>
   <p:sldSz cx="12192000" cy="6858000"/>
@@ -9617,7 +9618,7 @@
                 <a:ea typeface="Calibri" pitchFamily="34" charset="-122"/>
                 <a:cs typeface="Calibri" pitchFamily="34" charset="-120"/>
               </a:rPr>
-              <a:t>References</a:t>
+              <a:t>References  (1–15)</a:t>
             </a:r>
             <a:endParaRPr lang="en-US" sz="2800" dirty="0"/>
           </a:p>
@@ -9670,7 +9671,7 @@
           <a:p>
             <a:pPr marL="177800" indent="0">
               <a:spcAft>
-                <a:spcPts val="120"/>
+                <a:spcPts val="60"/>
               </a:spcAft>
               <a:buSzPct val="100000"/>
               <a:buNone/>
@@ -9697,6 +9698,15 @@
               </a:rPr>
               <a:t xml:space="preserve">Z. Zhang, F. Wang, L. M. Tolbert and B. J. Blalock, “Active Gate Driver for Crosstalk Suppression of SiC Devices in a Phase-Leg Configuration,” IEEE Trans. Power Electron., vol. 29, no. 4, pp. 1986–1997, Apr. 2014.</a:t>
             </a:r>
+          </a:p>
+          <a:p>
+            <a:pPr marL="177800" indent="0">
+              <a:spcAft>
+                <a:spcPts val="60"/>
+              </a:spcAft>
+              <a:buSzPct val="100000"/>
+              <a:buNone/>
+            </a:pPr>
             <a:r>
               <a:rPr lang="en-US" sz="900" b="1" dirty="0">
                 <a:solidFill>
@@ -9706,13 +9716,24 @@
                 <a:ea typeface="Calibri" pitchFamily="34" charset="-122"/>
                 <a:cs typeface="Calibri" pitchFamily="34" charset="-120"/>
               </a:rPr>
-              <a:t xml:space="preserve">   ieeexplore.ieee.org/document/6531666</a:t>
+              <a:t xml:space="preserve">[2]  </a:t>
+            </a:r>
+            <a:r>
+              <a:rPr lang="en-US" sz="900" dirty="0">
+                <a:solidFill>
+                  <a:srgbClr val="000000"/>
+                </a:solidFill>
+                <a:latin typeface="Calibri" pitchFamily="34" charset="0"/>
+                <a:ea typeface="Calibri" pitchFamily="34" charset="-122"/>
+                <a:cs typeface="Calibri" pitchFamily="34" charset="-120"/>
+              </a:rPr>
+              <a:t xml:space="preserve">R. Xie, H. Wang, G. Tang, X. Yang and K. J. Chen, “An Analytical Model for False Turn-On Evaluation of High-Voltage Enhancement-Mode GaN Transistor in Bridge-Leg Configuration,” IEEE Trans. Power Electron., vol. 32, no. 8, pp. 6416–6433, Aug. 2017.</a:t>
             </a:r>
           </a:p>
           <a:p>
             <a:pPr marL="177800" indent="0">
               <a:spcAft>
-                <a:spcPts val="120"/>
+                <a:spcPts val="60"/>
               </a:spcAft>
               <a:buSzPct val="100000"/>
               <a:buNone/>
@@ -9726,7 +9747,7 @@
                 <a:ea typeface="Calibri" pitchFamily="34" charset="-122"/>
                 <a:cs typeface="Calibri" pitchFamily="34" charset="-120"/>
               </a:rPr>
-              <a:t xml:space="preserve">[2]  </a:t>
+              <a:t xml:space="preserve">[3]  </a:t>
             </a:r>
             <a:r>
               <a:rPr lang="en-US" sz="900" dirty="0">
@@ -9737,8 +9758,17 @@
                 <a:ea typeface="Calibri" pitchFamily="34" charset="-122"/>
                 <a:cs typeface="Calibri" pitchFamily="34" charset="-120"/>
               </a:rPr>
-              <a:t xml:space="preserve">R. Xie, H. Wang, G. Tang, X. Yang and K. J. Chen, “An Analytical Model for False Turn-On Evaluation of High-Voltage Enhancement-Mode GaN Transistor in Bridge-Leg Configuration,” IEEE Trans. Power Electron., vol. 32, no. 8, pp. 6416–6433, Aug. 2017.</a:t>
-            </a:r>
+              <a:t xml:space="preserve">D. Reusch and J. Strydom, “Understanding the Effect of PCB Layout on Circuit Performance in a High-Frequency Gallium-Nitride-Based Point of Load Converter,” IEEE Trans. Power Electron., vol. 29, no. 4, pp. 2008–2015, Apr. 2014.</a:t>
+            </a:r>
+          </a:p>
+          <a:p>
+            <a:pPr marL="177800" indent="0">
+              <a:spcAft>
+                <a:spcPts val="60"/>
+              </a:spcAft>
+              <a:buSzPct val="100000"/>
+              <a:buNone/>
+            </a:pPr>
             <a:r>
               <a:rPr lang="en-US" sz="900" b="1" dirty="0">
                 <a:solidFill>
@@ -9748,13 +9778,24 @@
                 <a:ea typeface="Calibri" pitchFamily="34" charset="-122"/>
                 <a:cs typeface="Calibri" pitchFamily="34" charset="-120"/>
               </a:rPr>
-              <a:t xml:space="preserve">   ieeexplore.ieee.org/document/7854840</a:t>
+              <a:t xml:space="preserve">[4]  </a:t>
+            </a:r>
+            <a:r>
+              <a:rPr lang="en-US" sz="900" dirty="0">
+                <a:solidFill>
+                  <a:srgbClr val="000000"/>
+                </a:solidFill>
+                <a:latin typeface="Calibri" pitchFamily="34" charset="0"/>
+                <a:ea typeface="Calibri" pitchFamily="34" charset="-122"/>
+                <a:cs typeface="Calibri" pitchFamily="34" charset="-120"/>
+              </a:rPr>
+              <a:t xml:space="preserve">B. Li, G. Zhang, C. Li, G. Wang, S. Liu and D. Xu, “Crosstalk Suppression Method for GaN-Based Bridge Configuration Using Negative Voltage Self-Recovery Gate Drive,” IEEE Trans. Power Electron., vol. 37, no. 4, pp. 4406–4418, 2022.</a:t>
             </a:r>
           </a:p>
           <a:p>
             <a:pPr marL="177800" indent="0">
               <a:spcAft>
-                <a:spcPts val="120"/>
+                <a:spcPts val="60"/>
               </a:spcAft>
               <a:buSzPct val="100000"/>
               <a:buNone/>
@@ -9768,7 +9809,7 @@
                 <a:ea typeface="Calibri" pitchFamily="34" charset="-122"/>
                 <a:cs typeface="Calibri" pitchFamily="34" charset="-120"/>
               </a:rPr>
-              <a:t xml:space="preserve">[3]  </a:t>
+              <a:t xml:space="preserve">[5]  </a:t>
             </a:r>
             <a:r>
               <a:rPr lang="en-US" sz="900" dirty="0">
@@ -9779,8 +9820,17 @@
                 <a:ea typeface="Calibri" pitchFamily="34" charset="-122"/>
                 <a:cs typeface="Calibri" pitchFamily="34" charset="-120"/>
               </a:rPr>
-              <a:t xml:space="preserve">D. Reusch and J. Strydom, “Understanding the Effect of PCB Layout on Circuit Performance in a High-Frequency Gallium-Nitride-Based Point of Load Converter,” IEEE Trans. Power Electron., vol. 29, no. 4, pp. 2008–2015, Apr. 2014.</a:t>
-            </a:r>
+              <a:t xml:space="preserve">X. Chen, H. Peng, S. Song, Q. Tong and Y. Kang, “A Novel Control Strategy for Optimal Tradeoff between Overshoot and Switching Loss Based on Double Closed-Loop Self-Regulating Active Gate Driver,” IEEE Trans. Power Electron., vol. 39, no. 10, pp. 13033–13043, 2024.</a:t>
+            </a:r>
+          </a:p>
+          <a:p>
+            <a:pPr marL="177800" indent="0">
+              <a:spcAft>
+                <a:spcPts val="60"/>
+              </a:spcAft>
+              <a:buSzPct val="100000"/>
+              <a:buNone/>
+            </a:pPr>
             <a:r>
               <a:rPr lang="en-US" sz="900" b="1" dirty="0">
                 <a:solidFill>
@@ -9790,13 +9840,24 @@
                 <a:ea typeface="Calibri" pitchFamily="34" charset="-122"/>
                 <a:cs typeface="Calibri" pitchFamily="34" charset="-120"/>
               </a:rPr>
-              <a:t xml:space="preserve">   ieeexplore.ieee.org/document/6531683</a:t>
+              <a:t xml:space="preserve">[6]  </a:t>
+            </a:r>
+            <a:r>
+              <a:rPr lang="en-US" sz="900" dirty="0">
+                <a:solidFill>
+                  <a:srgbClr val="000000"/>
+                </a:solidFill>
+                <a:latin typeface="Calibri" pitchFamily="34" charset="0"/>
+                <a:ea typeface="Calibri" pitchFamily="34" charset="-122"/>
+                <a:cs typeface="Calibri" pitchFamily="34" charset="-120"/>
+              </a:rPr>
+              <a:t xml:space="preserve">W. Song, T. Hu, J. Chen, T. Tang, H. Yue and G. Liu, “A Self-Regulating Active Gate Driver of Voltage Overshoot Suppression for SiC MOSFETs Under Variable Load Current Conditions,” IEEE Trans. Power Electron., vol. 40, no. 8, pp. 10623–10634, 2025.</a:t>
             </a:r>
           </a:p>
           <a:p>
             <a:pPr marL="177800" indent="0">
               <a:spcAft>
-                <a:spcPts val="120"/>
+                <a:spcPts val="60"/>
               </a:spcAft>
               <a:buSzPct val="100000"/>
               <a:buNone/>
@@ -9810,7 +9871,7 @@
                 <a:ea typeface="Calibri" pitchFamily="34" charset="-122"/>
                 <a:cs typeface="Calibri" pitchFamily="34" charset="-120"/>
               </a:rPr>
-              <a:t xml:space="preserve">[4]  </a:t>
+              <a:t xml:space="preserve">[7]  </a:t>
             </a:r>
             <a:r>
               <a:rPr lang="en-US" sz="900" dirty="0">
@@ -9821,8 +9882,17 @@
                 <a:ea typeface="Calibri" pitchFamily="34" charset="-122"/>
                 <a:cs typeface="Calibri" pitchFamily="34" charset="-120"/>
               </a:rPr>
-              <a:t xml:space="preserve">B. Li, G. Zhang, C. Li, G. Wang, S. Liu and D. Xu, “Crosstalk Suppression Method for GaN-Based Bridge Configuration Using Negative Voltage Self-Recovery Gate Drive,” IEEE Trans. Power Electron., vol. 37, no. 4, pp. 4406–4418, 2022.</a:t>
-            </a:r>
+              <a:t xml:space="preserve">C.W. Kuo, T.W. Wang, L.C. Chen, C.C. Tu, Y.K. Hsiao and P.H. Chen, “Universal Active Gate Driver IC With Closed-Loop Timing Control and Gate-Sensing Technique for Silicon Carbide Power Devices,” IEEE Trans. Power Electron., vol. 40, no. 4, pp. 5120–5129, 2025.</a:t>
+            </a:r>
+          </a:p>
+          <a:p>
+            <a:pPr marL="177800" indent="0">
+              <a:spcAft>
+                <a:spcPts val="60"/>
+              </a:spcAft>
+              <a:buSzPct val="100000"/>
+              <a:buNone/>
+            </a:pPr>
             <a:r>
               <a:rPr lang="en-US" sz="900" b="1" dirty="0">
                 <a:solidFill>
@@ -9832,13 +9902,24 @@
                 <a:ea typeface="Calibri" pitchFamily="34" charset="-122"/>
                 <a:cs typeface="Calibri" pitchFamily="34" charset="-120"/>
               </a:rPr>
-              <a:t xml:space="preserve">   ieeexplore.ieee.org/document/9573371</a:t>
+              <a:t xml:space="preserve">[8]  </a:t>
+            </a:r>
+            <a:r>
+              <a:rPr lang="en-US" sz="900" dirty="0">
+                <a:solidFill>
+                  <a:srgbClr val="000000"/>
+                </a:solidFill>
+                <a:latin typeface="Calibri" pitchFamily="34" charset="0"/>
+                <a:ea typeface="Calibri" pitchFamily="34" charset="-122"/>
+                <a:cs typeface="Calibri" pitchFamily="34" charset="-120"/>
+              </a:rPr>
+              <a:t xml:space="preserve">G.H. Thuc and C.J. Chen, “An Integrated Driver With Dual-Edge Adaptive Dead-Time Control for GaN-Based Synchronous Buck Converter,” IEEE Trans. Ind. Appl., vol. 60, no. 6, pp. 9157–9170, 2024.</a:t>
             </a:r>
           </a:p>
           <a:p>
             <a:pPr marL="177800" indent="0">
               <a:spcAft>
-                <a:spcPts val="120"/>
+                <a:spcPts val="60"/>
               </a:spcAft>
               <a:buSzPct val="100000"/>
               <a:buNone/>
@@ -9852,7 +9933,18 @@
                 <a:ea typeface="Calibri" pitchFamily="34" charset="-122"/>
                 <a:cs typeface="Calibri" pitchFamily="34" charset="-120"/>
               </a:rPr>
-              <a:t xml:space="preserve">[5]  </a:t>
+              <a:t xml:space="preserve">[9]  </a:t>
+            </a:r>
+            <a:r>
+              <a:rPr lang="en-US" sz="900" b="1" dirty="0">
+                <a:solidFill>
+                  <a:srgbClr val="000000"/>
+                </a:solidFill>
+                <a:latin typeface="Calibri" pitchFamily="34" charset="0"/>
+                <a:ea typeface="Calibri" pitchFamily="34" charset="-122"/>
+                <a:cs typeface="Calibri" pitchFamily="34" charset="-120"/>
+              </a:rPr>
+              <a:t xml:space="preserve">BASE PAPER — </a:t>
             </a:r>
             <a:r>
               <a:rPr lang="en-US" sz="900" dirty="0">
@@ -9863,8 +9955,17 @@
                 <a:ea typeface="Calibri" pitchFamily="34" charset="-122"/>
                 <a:cs typeface="Calibri" pitchFamily="34" charset="-120"/>
               </a:rPr>
-              <a:t xml:space="preserve">X. Chen, H. Peng, S. Song, Q. Tong and Y. Kang, “A Novel Control Strategy for Optimal Tradeoff between Overshoot and Switching Loss Based on Double Closed-Loop Self-Regulating Active Gate Driver,” IEEE Trans. Power Electron., vol. 39, no. 10, pp. 13033–13043, 2024.</a:t>
-            </a:r>
+              <a:t xml:space="preserve">H. Takayama, T. Okuda and T. Hikihara, “Digital Active Gate Drive of SiC MOSFETs for Controlling Switching Behavior — Preparation Toward Universal Digitization of Power Switching,” Int. J. Circuit Theory Appl., vol. 50, no. 1, pp. 183–196, 2022.</a:t>
+            </a:r>
+          </a:p>
+          <a:p>
+            <a:pPr marL="177800" indent="0">
+              <a:spcAft>
+                <a:spcPts val="60"/>
+              </a:spcAft>
+              <a:buSzPct val="100000"/>
+              <a:buNone/>
+            </a:pPr>
             <a:r>
               <a:rPr lang="en-US" sz="900" b="1" dirty="0">
                 <a:solidFill>
@@ -9874,13 +9975,24 @@
                 <a:ea typeface="Calibri" pitchFamily="34" charset="-122"/>
                 <a:cs typeface="Calibri" pitchFamily="34" charset="-120"/>
               </a:rPr>
-              <a:t xml:space="preserve">   ieeexplore.ieee.org/document/10553383</a:t>
+              <a:t xml:space="preserve">[10]  </a:t>
+            </a:r>
+            <a:r>
+              <a:rPr lang="en-US" sz="900" dirty="0">
+                <a:solidFill>
+                  <a:srgbClr val="000000"/>
+                </a:solidFill>
+                <a:latin typeface="Calibri" pitchFamily="34" charset="0"/>
+                <a:ea typeface="Calibri" pitchFamily="34" charset="-122"/>
+                <a:cs typeface="Calibri" pitchFamily="34" charset="-120"/>
+              </a:rPr>
+              <a:t xml:space="preserve">W.J. Zhang, J. Yu, Y. Leng, W.T. Cui, G.Q. Deng and W.T. Ng, “A Segmented Gate Driver for E-mode GaN HEMTs with Simple Driving Strength Pattern Control,” in Proc. IEEE 32nd Int. Symp. Power Semicond. Devices ICs (ISPSD), 2020, pp. 102–105.</a:t>
             </a:r>
           </a:p>
           <a:p>
             <a:pPr marL="177800" indent="0">
               <a:spcAft>
-                <a:spcPts val="120"/>
+                <a:spcPts val="60"/>
               </a:spcAft>
               <a:buSzPct val="100000"/>
               <a:buNone/>
@@ -9894,7 +10006,7 @@
                 <a:ea typeface="Calibri" pitchFamily="34" charset="-122"/>
                 <a:cs typeface="Calibri" pitchFamily="34" charset="-120"/>
               </a:rPr>
-              <a:t xml:space="preserve">[6]  </a:t>
+              <a:t xml:space="preserve">[11]  </a:t>
             </a:r>
             <a:r>
               <a:rPr lang="en-US" sz="900" dirty="0">
@@ -9905,8 +10017,17 @@
                 <a:ea typeface="Calibri" pitchFamily="34" charset="-122"/>
                 <a:cs typeface="Calibri" pitchFamily="34" charset="-120"/>
               </a:rPr>
-              <a:t xml:space="preserve">W. Song, T. Hu, J. Chen, T. Tang, H. Yue and G. Liu, “A Self-Regulating Active Gate Driver of Voltage Overshoot Suppression for SiC MOSFETs Under Variable Load Current Conditions,” IEEE Trans. Power Electron., vol. 40, no. 8, pp. 10623–10634, 2025.</a:t>
-            </a:r>
+              <a:t xml:space="preserve">X. Wang, M. Tao, J. Xiao, D. Luo, M. He, Q. Zhou, X. Zhang and M. Wang, “High-Frequency Three-Level Gate Driver for GaN HEMT Bridge Crosstalk Suppression,” IEEE Trans. Power Electron., vol. 39, no. 1, pp. 1343–1352, 2024.</a:t>
+            </a:r>
+          </a:p>
+          <a:p>
+            <a:pPr marL="177800" indent="0">
+              <a:spcAft>
+                <a:spcPts val="60"/>
+              </a:spcAft>
+              <a:buSzPct val="100000"/>
+              <a:buNone/>
+            </a:pPr>
             <a:r>
               <a:rPr lang="en-US" sz="900" b="1" dirty="0">
                 <a:solidFill>
@@ -9916,13 +10037,24 @@
                 <a:ea typeface="Calibri" pitchFamily="34" charset="-122"/>
                 <a:cs typeface="Calibri" pitchFamily="34" charset="-120"/>
               </a:rPr>
-              <a:t xml:space="preserve">   ieeexplore.ieee.org/document/10964227</a:t>
+              <a:t xml:space="preserve">[12]  </a:t>
+            </a:r>
+            <a:r>
+              <a:rPr lang="en-US" sz="900" dirty="0">
+                <a:solidFill>
+                  <a:srgbClr val="000000"/>
+                </a:solidFill>
+                <a:latin typeface="Calibri" pitchFamily="34" charset="0"/>
+                <a:ea typeface="Calibri" pitchFamily="34" charset="-122"/>
+                <a:cs typeface="Calibri" pitchFamily="34" charset="-120"/>
+              </a:rPr>
+              <a:t xml:space="preserve">L. Wang, X. Sun, Y. Yan, M. Ma and D. Xu, “An Integrated Suppression Method of Both Gate-Source Voltage Oscillation and Crosstalk for GaN HEMT Gate Driver,” IEEE Trans. Power Electron., vol. 39, no. 11, pp. 14643–14655, 2024.</a:t>
             </a:r>
           </a:p>
           <a:p>
             <a:pPr marL="177800" indent="0">
               <a:spcAft>
-                <a:spcPts val="120"/>
+                <a:spcPts val="60"/>
               </a:spcAft>
               <a:buSzPct val="100000"/>
               <a:buNone/>
@@ -9936,7 +10068,7 @@
                 <a:ea typeface="Calibri" pitchFamily="34" charset="-122"/>
                 <a:cs typeface="Calibri" pitchFamily="34" charset="-120"/>
               </a:rPr>
-              <a:t xml:space="preserve">[7]  </a:t>
+              <a:t xml:space="preserve">[13]  </a:t>
             </a:r>
             <a:r>
               <a:rPr lang="en-US" sz="900" dirty="0">
@@ -9947,8 +10079,17 @@
                 <a:ea typeface="Calibri" pitchFamily="34" charset="-122"/>
                 <a:cs typeface="Calibri" pitchFamily="34" charset="-120"/>
               </a:rPr>
-              <a:t xml:space="preserve">C.W. Kuo, T.W. Wang, L.C. Chen, C.C. Tu, Y.K. Hsiao and P.H. Chen, “Universal Active Gate Driver IC With Closed-Loop Timing Control and Gate-Sensing Technique for Silicon Carbide Power Devices,” IEEE Trans. Power Electron., vol. 40, no. 4, pp. 5120–5129, 2025.</a:t>
-            </a:r>
+              <a:t xml:space="preserve">Y. Cai, D. Ye, W. Lv and Z. Chen, “A High-Efficient GaN Driver With Hybrid Adaptive Dead-Time Control and Peak Delay Control for Synchronous Buck Converter,” IEEE Trans. Power Electron., vol. 41, no. 1, pp. 279–290, 2026.</a:t>
+            </a:r>
+          </a:p>
+          <a:p>
+            <a:pPr marL="177800" indent="0">
+              <a:spcAft>
+                <a:spcPts val="60"/>
+              </a:spcAft>
+              <a:buSzPct val="100000"/>
+              <a:buNone/>
+            </a:pPr>
             <a:r>
               <a:rPr lang="en-US" sz="900" b="1" dirty="0">
                 <a:solidFill>
@@ -9958,13 +10099,24 @@
                 <a:ea typeface="Calibri" pitchFamily="34" charset="-122"/>
                 <a:cs typeface="Calibri" pitchFamily="34" charset="-120"/>
               </a:rPr>
-              <a:t xml:space="preserve">   ieeexplore.ieee.org/document/10813402</a:t>
+              <a:t xml:space="preserve">[14]  </a:t>
+            </a:r>
+            <a:r>
+              <a:rPr lang="en-US" sz="900" dirty="0">
+                <a:solidFill>
+                  <a:srgbClr val="000000"/>
+                </a:solidFill>
+                <a:latin typeface="Calibri" pitchFamily="34" charset="0"/>
+                <a:ea typeface="Calibri" pitchFamily="34" charset="-122"/>
+                <a:cs typeface="Calibri" pitchFamily="34" charset="-120"/>
+              </a:rPr>
+              <a:t xml:space="preserve">Y. Zheng, S. Zhao, P. Agarwal, F. Liu, Y. Zhao and A. Mantooth, “A Multi-Level Turn-Off Gate Driver for Crosstalk Noise Suppression of GaN HEMTs,” IEEE Open J. Power Electron., pp. 1–15, 2026.</a:t>
             </a:r>
           </a:p>
           <a:p>
             <a:pPr marL="177800" indent="0">
               <a:spcAft>
-                <a:spcPts val="120"/>
+                <a:spcPts val="60"/>
               </a:spcAft>
               <a:buSzPct val="100000"/>
               <a:buNone/>
@@ -9978,7 +10130,7 @@
                 <a:ea typeface="Calibri" pitchFamily="34" charset="-122"/>
                 <a:cs typeface="Calibri" pitchFamily="34" charset="-120"/>
               </a:rPr>
-              <a:t xml:space="preserve">[8]  </a:t>
+              <a:t xml:space="preserve">[15]  </a:t>
             </a:r>
             <a:r>
               <a:rPr lang="en-US" sz="900" dirty="0">
@@ -9989,270 +10141,7 @@
                 <a:ea typeface="Calibri" pitchFamily="34" charset="-122"/>
                 <a:cs typeface="Calibri" pitchFamily="34" charset="-120"/>
               </a:rPr>
-              <a:t xml:space="preserve">G.H. Thuc and C.J. Chen, “An Integrated Driver With Dual-Edge Adaptive Dead-Time Control for GaN-Based Synchronous Buck Converter,” IEEE Trans. Ind. Appl., vol. 60, no. 6, pp. 9157–9170, 2024.</a:t>
-            </a:r>
-            <a:r>
-              <a:rPr lang="en-US" sz="900" b="1" dirty="0">
-                <a:solidFill>
-                  <a:srgbClr val="000000"/>
-                </a:solidFill>
-                <a:latin typeface="Calibri" pitchFamily="34" charset="0"/>
-                <a:ea typeface="Calibri" pitchFamily="34" charset="-122"/>
-                <a:cs typeface="Calibri" pitchFamily="34" charset="-120"/>
-              </a:rPr>
-              <a:t xml:space="preserve">   doi.org/10.1109/TIA.2024.3454198</a:t>
-            </a:r>
-          </a:p>
-          <a:p>
-            <a:pPr marL="177800" indent="0">
-              <a:spcAft>
-                <a:spcPts val="120"/>
-              </a:spcAft>
-              <a:buSzPct val="100000"/>
-              <a:buNone/>
-            </a:pPr>
-            <a:r>
-              <a:rPr lang="en-US" sz="900" b="1" dirty="0">
-                <a:solidFill>
-                  <a:srgbClr val="000000"/>
-                </a:solidFill>
-                <a:latin typeface="Calibri" pitchFamily="34" charset="0"/>
-                <a:ea typeface="Calibri" pitchFamily="34" charset="-122"/>
-                <a:cs typeface="Calibri" pitchFamily="34" charset="-120"/>
-              </a:rPr>
-              <a:t xml:space="preserve">[9]  </a:t>
-            </a:r>
-            <a:r>
-              <a:rPr lang="en-US" sz="900" b="1" dirty="0">
-                <a:solidFill>
-                  <a:srgbClr val="000000"/>
-                </a:solidFill>
-                <a:latin typeface="Calibri" pitchFamily="34" charset="0"/>
-                <a:ea typeface="Calibri" pitchFamily="34" charset="-122"/>
-                <a:cs typeface="Calibri" pitchFamily="34" charset="-120"/>
-              </a:rPr>
-              <a:t xml:space="preserve">BASE PAPER — </a:t>
-            </a:r>
-            <a:r>
-              <a:rPr lang="en-US" sz="900" dirty="0">
-                <a:solidFill>
-                  <a:srgbClr val="000000"/>
-                </a:solidFill>
-                <a:latin typeface="Calibri" pitchFamily="34" charset="0"/>
-                <a:ea typeface="Calibri" pitchFamily="34" charset="-122"/>
-                <a:cs typeface="Calibri" pitchFamily="34" charset="-120"/>
-              </a:rPr>
-              <a:t xml:space="preserve">H. Takayama, T. Okuda and T. Hikihara, “Digital Active Gate Drive of SiC MOSFETs for Controlling Switching Behavior — Preparation Toward Universal Digitization of Power Switching,” Int. J. Circuit Theory Appl., vol. 50, no. 1, pp. 183–196, 2022.</a:t>
-            </a:r>
-            <a:r>
-              <a:rPr lang="en-US" sz="900" b="1" dirty="0">
-                <a:solidFill>
-                  <a:srgbClr val="000000"/>
-                </a:solidFill>
-                <a:latin typeface="Calibri" pitchFamily="34" charset="0"/>
-                <a:ea typeface="Calibri" pitchFamily="34" charset="-122"/>
-                <a:cs typeface="Calibri" pitchFamily="34" charset="-120"/>
-              </a:rPr>
-              <a:t xml:space="preserve">   doi.org/10.1002/cta.3136</a:t>
-            </a:r>
-          </a:p>
-          <a:p>
-            <a:pPr marL="177800" indent="0">
-              <a:spcAft>
-                <a:spcPts val="120"/>
-              </a:spcAft>
-              <a:buSzPct val="100000"/>
-              <a:buNone/>
-            </a:pPr>
-            <a:r>
-              <a:rPr lang="en-US" sz="900" b="1" dirty="0">
-                <a:solidFill>
-                  <a:srgbClr val="000000"/>
-                </a:solidFill>
-                <a:latin typeface="Calibri" pitchFamily="34" charset="0"/>
-                <a:ea typeface="Calibri" pitchFamily="34" charset="-122"/>
-                <a:cs typeface="Calibri" pitchFamily="34" charset="-120"/>
-              </a:rPr>
-              <a:t xml:space="preserve">[10]  </a:t>
-            </a:r>
-            <a:r>
-              <a:rPr lang="en-US" sz="900" dirty="0">
-                <a:solidFill>
-                  <a:srgbClr val="000000"/>
-                </a:solidFill>
-                <a:latin typeface="Calibri" pitchFamily="34" charset="0"/>
-                <a:ea typeface="Calibri" pitchFamily="34" charset="-122"/>
-                <a:cs typeface="Calibri" pitchFamily="34" charset="-120"/>
-              </a:rPr>
-              <a:t xml:space="preserve">W.J. Zhang, J. Yu, Y. Leng, W.T. Cui, G.Q. Deng and W.T. Ng, “A Segmented Gate Driver for E-mode GaN HEMTs with Simple Driving Strength Pattern Control,” in Proc. IEEE 32nd Int. Symp. Power Semicond. Devices ICs (ISPSD), 2020, pp. 102–105.</a:t>
-            </a:r>
-            <a:r>
-              <a:rPr lang="en-US" sz="900" b="1" dirty="0">
-                <a:solidFill>
-                  <a:srgbClr val="000000"/>
-                </a:solidFill>
-                <a:latin typeface="Calibri" pitchFamily="34" charset="0"/>
-                <a:ea typeface="Calibri" pitchFamily="34" charset="-122"/>
-                <a:cs typeface="Calibri" pitchFamily="34" charset="-120"/>
-              </a:rPr>
-              <a:t xml:space="preserve">   ieeexplore.ieee.org/document/9170108</a:t>
-            </a:r>
-          </a:p>
-          <a:p>
-            <a:pPr marL="177800" indent="0">
-              <a:spcAft>
-                <a:spcPts val="120"/>
-              </a:spcAft>
-              <a:buSzPct val="100000"/>
-              <a:buNone/>
-            </a:pPr>
-            <a:r>
-              <a:rPr lang="en-US" sz="900" b="1" dirty="0">
-                <a:solidFill>
-                  <a:srgbClr val="000000"/>
-                </a:solidFill>
-                <a:latin typeface="Calibri" pitchFamily="34" charset="0"/>
-                <a:ea typeface="Calibri" pitchFamily="34" charset="-122"/>
-                <a:cs typeface="Calibri" pitchFamily="34" charset="-120"/>
-              </a:rPr>
-              <a:t xml:space="preserve">[11]  </a:t>
-            </a:r>
-            <a:r>
-              <a:rPr lang="en-US" sz="900" dirty="0">
-                <a:solidFill>
-                  <a:srgbClr val="000000"/>
-                </a:solidFill>
-                <a:latin typeface="Calibri" pitchFamily="34" charset="0"/>
-                <a:ea typeface="Calibri" pitchFamily="34" charset="-122"/>
-                <a:cs typeface="Calibri" pitchFamily="34" charset="-120"/>
-              </a:rPr>
-              <a:t xml:space="preserve">X. Wang, M. Tao, J. Xiao, D. Luo, M. He, Q. Zhou, X. Zhang and M. Wang, “High-Frequency Three-Level Gate Driver for GaN HEMT Bridge Crosstalk Suppression,” IEEE Trans. Power Electron., vol. 39, no. 1, pp. 1343–1352, 2024.</a:t>
-            </a:r>
-            <a:r>
-              <a:rPr lang="en-US" sz="900" b="1" dirty="0">
-                <a:solidFill>
-                  <a:srgbClr val="000000"/>
-                </a:solidFill>
-                <a:latin typeface="Calibri" pitchFamily="34" charset="0"/>
-                <a:ea typeface="Calibri" pitchFamily="34" charset="-122"/>
-                <a:cs typeface="Calibri" pitchFamily="34" charset="-120"/>
-              </a:rPr>
-              <a:t xml:space="preserve">   ieeexplore.ieee.org/document/10286072</a:t>
-            </a:r>
-          </a:p>
-          <a:p>
-            <a:pPr marL="177800" indent="0">
-              <a:spcAft>
-                <a:spcPts val="120"/>
-              </a:spcAft>
-              <a:buSzPct val="100000"/>
-              <a:buNone/>
-            </a:pPr>
-            <a:r>
-              <a:rPr lang="en-US" sz="900" b="1" dirty="0">
-                <a:solidFill>
-                  <a:srgbClr val="000000"/>
-                </a:solidFill>
-                <a:latin typeface="Calibri" pitchFamily="34" charset="0"/>
-                <a:ea typeface="Calibri" pitchFamily="34" charset="-122"/>
-                <a:cs typeface="Calibri" pitchFamily="34" charset="-120"/>
-              </a:rPr>
-              <a:t xml:space="preserve">[12]  </a:t>
-            </a:r>
-            <a:r>
-              <a:rPr lang="en-US" sz="900" dirty="0">
-                <a:solidFill>
-                  <a:srgbClr val="000000"/>
-                </a:solidFill>
-                <a:latin typeface="Calibri" pitchFamily="34" charset="0"/>
-                <a:ea typeface="Calibri" pitchFamily="34" charset="-122"/>
-                <a:cs typeface="Calibri" pitchFamily="34" charset="-120"/>
-              </a:rPr>
-              <a:t xml:space="preserve">L. Wang, X. Sun, Y. Yan, M. Ma and D. Xu, “An Integrated Suppression Method of Both Gate-Source Voltage Oscillation and Crosstalk for GaN HEMT Gate Driver,” IEEE Trans. Power Electron., vol. 39, no. 11, pp. 14643–14655, 2024.</a:t>
-            </a:r>
-            <a:r>
-              <a:rPr lang="en-US" sz="900" b="1" dirty="0">
-                <a:solidFill>
-                  <a:srgbClr val="000000"/>
-                </a:solidFill>
-                <a:latin typeface="Calibri" pitchFamily="34" charset="0"/>
-                <a:ea typeface="Calibri" pitchFamily="34" charset="-122"/>
-                <a:cs typeface="Calibri" pitchFamily="34" charset="-120"/>
-              </a:rPr>
-              <a:t xml:space="preserve">   ieeexplore.ieee.org/document/10591431</a:t>
-            </a:r>
-          </a:p>
-          <a:p>
-            <a:pPr marL="177800" indent="0">
-              <a:spcAft>
-                <a:spcPts val="120"/>
-              </a:spcAft>
-              <a:buSzPct val="100000"/>
-              <a:buNone/>
-            </a:pPr>
-            <a:r>
-              <a:rPr lang="en-US" sz="900" b="1" dirty="0">
-                <a:solidFill>
-                  <a:srgbClr val="000000"/>
-                </a:solidFill>
-                <a:latin typeface="Calibri" pitchFamily="34" charset="0"/>
-                <a:ea typeface="Calibri" pitchFamily="34" charset="-122"/>
-                <a:cs typeface="Calibri" pitchFamily="34" charset="-120"/>
-              </a:rPr>
-              <a:t xml:space="preserve">[13]  </a:t>
-            </a:r>
-            <a:r>
-              <a:rPr lang="en-US" sz="900" dirty="0">
-                <a:solidFill>
-                  <a:srgbClr val="000000"/>
-                </a:solidFill>
-                <a:latin typeface="Calibri" pitchFamily="34" charset="0"/>
-                <a:ea typeface="Calibri" pitchFamily="34" charset="-122"/>
-                <a:cs typeface="Calibri" pitchFamily="34" charset="-120"/>
-              </a:rPr>
-              <a:t xml:space="preserve">Y. Cai, D. Ye, W. Lv and Z. Chen, “A High-Efficient GaN Driver With Hybrid Adaptive Dead-Time Control and Peak Delay Control for Synchronous Buck Converter,” IEEE Trans. Power Electron., vol. 41, no. 1, pp. 279–290, 2026.</a:t>
-            </a:r>
-            <a:r>
-              <a:rPr lang="en-US" sz="900" b="1" dirty="0">
-                <a:solidFill>
-                  <a:srgbClr val="000000"/>
-                </a:solidFill>
-                <a:latin typeface="Calibri" pitchFamily="34" charset="0"/>
-                <a:ea typeface="Calibri" pitchFamily="34" charset="-122"/>
-                <a:cs typeface="Calibri" pitchFamily="34" charset="-120"/>
-              </a:rPr>
-              <a:t xml:space="preserve">   ieeexplore.ieee.org/document/11146698</a:t>
-            </a:r>
-          </a:p>
-          <a:p>
-            <a:pPr marL="177800" indent="0">
-              <a:spcAft>
-                <a:spcPts val="0"/>
-              </a:spcAft>
-              <a:buSzPct val="100000"/>
-              <a:buNone/>
-            </a:pPr>
-            <a:r>
-              <a:rPr lang="en-US" sz="850" dirty="0">
-                <a:solidFill>
-                  <a:srgbClr val="000000"/>
-                </a:solidFill>
-                <a:latin typeface="Calibri" pitchFamily="34" charset="0"/>
-                <a:ea typeface="Calibri" pitchFamily="34" charset="-122"/>
-                <a:cs typeface="Calibri" pitchFamily="34" charset="-120"/>
-              </a:rPr>
-              <a:t xml:space="preserve">All 13 verified against the publisher record </a:t>
-            </a:r>
-            <a:r>
-              <a:rPr lang="en-US" sz="850" dirty="0">
-                <a:solidFill>
-                  <a:srgbClr val="000000"/>
-                </a:solidFill>
-                <a:latin typeface="Calibri" pitchFamily="34" charset="0"/>
-                <a:ea typeface="Calibri" pitchFamily="34" charset="-122"/>
-                <a:cs typeface="Calibri" pitchFamily="34" charset="-120"/>
-              </a:rPr>
-              <a:t xml:space="preserve">— authors, volume, issue and pages resolved through Crossref by DOI and title, not transcribed by hand.</a:t>
+              <a:t xml:space="preserve">M.K. Banda, S. Madichetty, D.M. Natham and S. Koduru, “An Event-Triggered Dual-Polarity Gate Clamp for GaN HEMT Gate Oscillation Suppression,” IEEE Trans. Power Electron., vol. 41, no. 9, pp. 14402–14405, 2026.</a:t>
             </a:r>
           </a:p>
         </p:txBody>
@@ -15145,6 +15034,675 @@
                 <a:cs typeface="Calibri" pitchFamily="34" charset="-120"/>
               </a:rPr>
               <a:t xml:space="preserve">  — four ngspice runs, prints this table.</a:t>
+            </a:r>
+          </a:p>
+        </p:txBody>
+      </p:sp>
+    </p:spTree>
+  </p:cSld>
+  <p:clrMapOvr>
+    <a:masterClrMapping/>
+  </p:clrMapOvr>
+</p:sld>
+</file>
+
+<file path=ppt/slides/slide28.xml><?xml version="1.0" encoding="utf-8"?>
+<p:sld xmlns:a="http://schemas.openxmlformats.org/drawingml/2006/main" xmlns:p="http://schemas.openxmlformats.org/presentationml/2006/main" xmlns:r="http://schemas.openxmlformats.org/officeDocument/2006/relationships">
+  <p:cSld>
+    <p:spTree>
+      <p:nvGrpSpPr>
+        <p:cNvPr id="1" name=""/>
+        <p:cNvGrpSpPr/>
+        <p:nvPr/>
+      </p:nvGrpSpPr>
+      <p:grpSpPr/>
+      <p:sp>
+        <p:nvSpPr>
+          <p:cNvPr id="2" name="Text 0"/>
+          <p:cNvSpPr txBox="1"/>
+          <p:nvPr/>
+        </p:nvSpPr>
+        <p:spPr>
+          <a:xfrm>
+            <a:off x="11460175" y="6446520"/>
+            <a:ext cx="457200" cy="274320"/>
+          </a:xfrm>
+          <a:prstGeom prst="rect">
+            <a:avLst/>
+          </a:prstGeom>
+          <a:noFill/>
+          <a:ln/>
+        </p:spPr>
+        <p:txBody>
+          <a:bodyPr wrap="square" lIns="0" tIns="0" rIns="0" bIns="0" rtlCol="0" anchor="ctr"/>
+          <a:lstStyle/>
+          <a:p>
+            <a:pPr marL="0" indent="0" algn="r">
+              <a:buNone/>
+            </a:pPr>
+            <a:r>
+              <a:rPr lang="en-US" sz="1000" dirty="0">
+                <a:solidFill>
+                  <a:srgbClr val="808080"/>
+                </a:solidFill>
+                <a:latin typeface="Calibri" pitchFamily="34" charset="0"/>
+                <a:ea typeface="Calibri" pitchFamily="34" charset="-122"/>
+                <a:cs typeface="Calibri" pitchFamily="34" charset="-120"/>
+              </a:rPr>
+              <a:t>25</a:t>
+            </a:r>
+            <a:endParaRPr lang="en-US" sz="1000" dirty="0"/>
+          </a:p>
+        </p:txBody>
+      </p:sp>
+      <p:sp>
+        <p:nvSpPr>
+          <p:cNvPr id="3" name="Text 1"/>
+          <p:cNvSpPr txBox="1"/>
+          <p:nvPr/>
+        </p:nvSpPr>
+        <p:spPr>
+          <a:xfrm>
+            <a:off x="548640" y="320040"/>
+            <a:ext cx="9601200" cy="685800"/>
+          </a:xfrm>
+          <a:prstGeom prst="rect">
+            <a:avLst/>
+          </a:prstGeom>
+          <a:noFill/>
+          <a:ln/>
+        </p:spPr>
+        <p:txBody>
+          <a:bodyPr wrap="square" lIns="0" tIns="0" rIns="0" bIns="0" rtlCol="0" anchor="ctr"/>
+          <a:lstStyle/>
+          <a:p>
+            <a:pPr marL="0" indent="0">
+              <a:buNone/>
+            </a:pPr>
+            <a:r>
+              <a:rPr lang="en-US" sz="2800" b="1" dirty="0">
+                <a:solidFill>
+                  <a:srgbClr val="1D2F82"/>
+                </a:solidFill>
+                <a:latin typeface="Calibri" pitchFamily="34" charset="0"/>
+                <a:ea typeface="Calibri" pitchFamily="34" charset="-122"/>
+                <a:cs typeface="Calibri" pitchFamily="34" charset="-120"/>
+              </a:rPr>
+              <a:t>References  (16–30)</a:t>
+            </a:r>
+            <a:endParaRPr lang="en-US" sz="2800" dirty="0"/>
+          </a:p>
+        </p:txBody>
+      </p:sp>
+      <p:pic>
+        <p:nvPicPr>
+          <p:cNvPr id="4" name="Image 0" descr="logo.png"/>
+          <p:cNvPicPr>
+            <a:picLocks noChangeAspect="1"/>
+          </p:cNvPicPr>
+          <p:nvPr/>
+        </p:nvPicPr>
+        <p:blipFill>
+          <a:blip r:embed="rId2"/>
+          <a:stretch>
+            <a:fillRect/>
+          </a:stretch>
+        </p:blipFill>
+        <p:spPr>
+          <a:xfrm>
+            <a:off x="10362895" y="320040"/>
+            <a:ext cx="1371600" cy="518746"/>
+          </a:xfrm>
+          <a:prstGeom prst="rect">
+            <a:avLst/>
+          </a:prstGeom>
+        </p:spPr>
+      </p:pic>
+      <p:sp>
+        <p:nvSpPr>
+          <p:cNvPr id="5" name="Text 2"/>
+          <p:cNvSpPr txBox="1"/>
+          <p:nvPr/>
+        </p:nvSpPr>
+        <p:spPr>
+          <a:xfrm>
+            <a:off x="640080" y="1325880"/>
+            <a:ext cx="10881360" cy="4343400"/>
+          </a:xfrm>
+          <a:prstGeom prst="rect">
+            <a:avLst/>
+          </a:prstGeom>
+          <a:noFill/>
+          <a:ln/>
+        </p:spPr>
+        <p:txBody>
+          <a:bodyPr wrap="square" lIns="0" tIns="0" rIns="0" bIns="0" rtlCol="0" anchor="t"/>
+          <a:lstStyle/>
+          <a:p>
+            <a:pPr marL="177800" indent="0">
+              <a:spcAft>
+                <a:spcPts val="60"/>
+              </a:spcAft>
+              <a:buSzPct val="100000"/>
+              <a:buNone/>
+            </a:pPr>
+            <a:r>
+              <a:rPr lang="en-US" sz="900" b="1" dirty="0">
+                <a:solidFill>
+                  <a:srgbClr val="000000"/>
+                </a:solidFill>
+                <a:latin typeface="Calibri" pitchFamily="34" charset="0"/>
+                <a:ea typeface="Calibri" pitchFamily="34" charset="-122"/>
+                <a:cs typeface="Calibri" pitchFamily="34" charset="-120"/>
+              </a:rPr>
+              <a:t xml:space="preserve">[16]  </a:t>
+            </a:r>
+            <a:r>
+              <a:rPr lang="en-US" sz="900" dirty="0">
+                <a:solidFill>
+                  <a:srgbClr val="000000"/>
+                </a:solidFill>
+                <a:latin typeface="Calibri" pitchFamily="34" charset="0"/>
+                <a:ea typeface="Calibri" pitchFamily="34" charset="-122"/>
+                <a:cs typeface="Calibri" pitchFamily="34" charset="-120"/>
+              </a:rPr>
+              <a:t xml:space="preserve">Z. Yuan, H. Li, M. Zhang, Z. Yang, S. Zhao, H. Wang, X. Wang and L. Ding, “Influence of Negative Gate Bias on Crosstalk Spike in SiC MOSFETs Half-Bridge Circuit,” IEEE J. Emerg. Sel. Topics Power Electron., vol. 14, no. 3, pp. 3217–3229, 2026.</a:t>
+            </a:r>
+          </a:p>
+          <a:p>
+            <a:pPr marL="177800" indent="0">
+              <a:spcAft>
+                <a:spcPts val="60"/>
+              </a:spcAft>
+              <a:buSzPct val="100000"/>
+              <a:buNone/>
+            </a:pPr>
+            <a:r>
+              <a:rPr lang="en-US" sz="900" b="1" dirty="0">
+                <a:solidFill>
+                  <a:srgbClr val="000000"/>
+                </a:solidFill>
+                <a:latin typeface="Calibri" pitchFamily="34" charset="0"/>
+                <a:ea typeface="Calibri" pitchFamily="34" charset="-122"/>
+                <a:cs typeface="Calibri" pitchFamily="34" charset="-120"/>
+              </a:rPr>
+              <a:t xml:space="preserve">[17]  </a:t>
+            </a:r>
+            <a:r>
+              <a:rPr lang="en-US" sz="900" dirty="0">
+                <a:solidFill>
+                  <a:srgbClr val="000000"/>
+                </a:solidFill>
+                <a:latin typeface="Calibri" pitchFamily="34" charset="0"/>
+                <a:ea typeface="Calibri" pitchFamily="34" charset="-122"/>
+                <a:cs typeface="Calibri" pitchFamily="34" charset="-120"/>
+              </a:rPr>
+              <a:t xml:space="preserve">L. Zhang, K. Wang, S. Guo and B. Zhu, “A Gate Driver for Crosstalk Suppression of eGaN HEMT Power Devices,” J. Low Power Electron. Appl., vol. 15, no. 3, pp. 38, 2025.</a:t>
+            </a:r>
+          </a:p>
+          <a:p>
+            <a:pPr marL="177800" indent="0">
+              <a:spcAft>
+                <a:spcPts val="60"/>
+              </a:spcAft>
+              <a:buSzPct val="100000"/>
+              <a:buNone/>
+            </a:pPr>
+            <a:r>
+              <a:rPr lang="en-US" sz="900" b="1" dirty="0">
+                <a:solidFill>
+                  <a:srgbClr val="000000"/>
+                </a:solidFill>
+                <a:latin typeface="Calibri" pitchFamily="34" charset="0"/>
+                <a:ea typeface="Calibri" pitchFamily="34" charset="-122"/>
+                <a:cs typeface="Calibri" pitchFamily="34" charset="-120"/>
+              </a:rPr>
+              <a:t xml:space="preserve">[18]  </a:t>
+            </a:r>
+            <a:r>
+              <a:rPr lang="en-US" sz="900" dirty="0">
+                <a:solidFill>
+                  <a:srgbClr val="000000"/>
+                </a:solidFill>
+                <a:latin typeface="Calibri" pitchFamily="34" charset="0"/>
+                <a:ea typeface="Calibri" pitchFamily="34" charset="-122"/>
+                <a:cs typeface="Calibri" pitchFamily="34" charset="-120"/>
+              </a:rPr>
+              <a:t xml:space="preserve">J. Wu, “Parallel arrangement of MOSFETs, effective suppression of crosstalk: A new gate driver topology,” iEnergy, vol. 2, no. 3, pp. 163–163, 2023.</a:t>
+            </a:r>
+          </a:p>
+          <a:p>
+            <a:pPr marL="177800" indent="0">
+              <a:spcAft>
+                <a:spcPts val="60"/>
+              </a:spcAft>
+              <a:buSzPct val="100000"/>
+              <a:buNone/>
+            </a:pPr>
+            <a:r>
+              <a:rPr lang="en-US" sz="900" b="1" dirty="0">
+                <a:solidFill>
+                  <a:srgbClr val="000000"/>
+                </a:solidFill>
+                <a:latin typeface="Calibri" pitchFamily="34" charset="0"/>
+                <a:ea typeface="Calibri" pitchFamily="34" charset="-122"/>
+                <a:cs typeface="Calibri" pitchFamily="34" charset="-120"/>
+              </a:rPr>
+              <a:t xml:space="preserve">[19]  </a:t>
+            </a:r>
+            <a:r>
+              <a:rPr lang="en-US" sz="900" dirty="0">
+                <a:solidFill>
+                  <a:srgbClr val="000000"/>
+                </a:solidFill>
+                <a:latin typeface="Calibri" pitchFamily="34" charset="0"/>
+                <a:ea typeface="Calibri" pitchFamily="34" charset="-122"/>
+                <a:cs typeface="Calibri" pitchFamily="34" charset="-120"/>
+              </a:rPr>
+              <a:t xml:space="preserve">Y. Mikhaylov, G. Buticchi and M. Galea, “A gate driver for parallel connected MOSFETs with crosstalk suppression,” iEnergy, vol. 2, no. 3, pp. 240–250, 2023.</a:t>
+            </a:r>
+          </a:p>
+          <a:p>
+            <a:pPr marL="177800" indent="0">
+              <a:spcAft>
+                <a:spcPts val="60"/>
+              </a:spcAft>
+              <a:buSzPct val="100000"/>
+              <a:buNone/>
+            </a:pPr>
+            <a:r>
+              <a:rPr lang="en-US" sz="900" b="1" dirty="0">
+                <a:solidFill>
+                  <a:srgbClr val="000000"/>
+                </a:solidFill>
+                <a:latin typeface="Calibri" pitchFamily="34" charset="0"/>
+                <a:ea typeface="Calibri" pitchFamily="34" charset="-122"/>
+                <a:cs typeface="Calibri" pitchFamily="34" charset="-120"/>
+              </a:rPr>
+              <a:t xml:space="preserve">[20]  </a:t>
+            </a:r>
+            <a:r>
+              <a:rPr lang="en-US" sz="900" dirty="0">
+                <a:solidFill>
+                  <a:srgbClr val="000000"/>
+                </a:solidFill>
+                <a:latin typeface="Calibri" pitchFamily="34" charset="0"/>
+                <a:ea typeface="Calibri" pitchFamily="34" charset="-122"/>
+                <a:cs typeface="Calibri" pitchFamily="34" charset="-120"/>
+              </a:rPr>
+              <a:t xml:space="preserve">W. Liu and H. Min, “A Load Adaptive Active Gate Driver with Fast-Switching Three-Level Current Source for Overshoot Suppression in GaN-Based Half-Bridge Converters,” IEEE Trans. Power Electron., pp. 1–8, 2026.</a:t>
+            </a:r>
+          </a:p>
+          <a:p>
+            <a:pPr marL="177800" indent="0">
+              <a:spcAft>
+                <a:spcPts val="60"/>
+              </a:spcAft>
+              <a:buSzPct val="100000"/>
+              <a:buNone/>
+            </a:pPr>
+            <a:r>
+              <a:rPr lang="en-US" sz="900" b="1" dirty="0">
+                <a:solidFill>
+                  <a:srgbClr val="000000"/>
+                </a:solidFill>
+                <a:latin typeface="Calibri" pitchFamily="34" charset="0"/>
+                <a:ea typeface="Calibri" pitchFamily="34" charset="-122"/>
+                <a:cs typeface="Calibri" pitchFamily="34" charset="-120"/>
+              </a:rPr>
+              <a:t xml:space="preserve">[21]  </a:t>
+            </a:r>
+            <a:r>
+              <a:rPr lang="en-US" sz="900" dirty="0">
+                <a:solidFill>
+                  <a:srgbClr val="000000"/>
+                </a:solidFill>
+                <a:latin typeface="Calibri" pitchFamily="34" charset="0"/>
+                <a:ea typeface="Calibri" pitchFamily="34" charset="-122"/>
+                <a:cs typeface="Calibri" pitchFamily="34" charset="-120"/>
+              </a:rPr>
+              <a:t xml:space="preserve">R. Chen, F. Wang, H. Bai and L.M. Tolbert, “A Simple Gate Driver Circuit for Turn-on Overvoltage Suppression of 10 kV SiC MOSFETs With Temporarily Lowering Gate Voltage During &lt;i&gt;dv/dt&lt;/i&gt;,” IEEE Trans. Ind. Electron., pp. 1–6, 2026.</a:t>
+            </a:r>
+          </a:p>
+          <a:p>
+            <a:pPr marL="177800" indent="0">
+              <a:spcAft>
+                <a:spcPts val="60"/>
+              </a:spcAft>
+              <a:buSzPct val="100000"/>
+              <a:buNone/>
+            </a:pPr>
+            <a:r>
+              <a:rPr lang="en-US" sz="900" b="1" dirty="0">
+                <a:solidFill>
+                  <a:srgbClr val="000000"/>
+                </a:solidFill>
+                <a:latin typeface="Calibri" pitchFamily="34" charset="0"/>
+                <a:ea typeface="Calibri" pitchFamily="34" charset="-122"/>
+                <a:cs typeface="Calibri" pitchFamily="34" charset="-120"/>
+              </a:rPr>
+              <a:t xml:space="preserve">[22]  </a:t>
+            </a:r>
+            <a:r>
+              <a:rPr lang="en-US" sz="900" dirty="0">
+                <a:solidFill>
+                  <a:srgbClr val="000000"/>
+                </a:solidFill>
+                <a:latin typeface="Calibri" pitchFamily="34" charset="0"/>
+                <a:ea typeface="Calibri" pitchFamily="34" charset="-122"/>
+                <a:cs typeface="Calibri" pitchFamily="34" charset="-120"/>
+              </a:rPr>
+              <a:t xml:space="preserve">D. Yu, M. Yang, L. Yin, K. Hu, W. Zhang and Q. Fu, “A Dual-Loop Active Gate Driver With Independent Voltage Slew Rate and Overshoot Control for Switching Loss Optimization of SiC MOSFETs,” IEEE Trans. Ind. Electron., pp. 1–12, 2026.</a:t>
+            </a:r>
+          </a:p>
+          <a:p>
+            <a:pPr marL="177800" indent="0">
+              <a:spcAft>
+                <a:spcPts val="60"/>
+              </a:spcAft>
+              <a:buSzPct val="100000"/>
+              <a:buNone/>
+            </a:pPr>
+            <a:r>
+              <a:rPr lang="en-US" sz="900" b="1" dirty="0">
+                <a:solidFill>
+                  <a:srgbClr val="000000"/>
+                </a:solidFill>
+                <a:latin typeface="Calibri" pitchFamily="34" charset="0"/>
+                <a:ea typeface="Calibri" pitchFamily="34" charset="-122"/>
+                <a:cs typeface="Calibri" pitchFamily="34" charset="-120"/>
+              </a:rPr>
+              <a:t xml:space="preserve">[23]  </a:t>
+            </a:r>
+            <a:r>
+              <a:rPr lang="en-US" sz="900" dirty="0">
+                <a:solidFill>
+                  <a:srgbClr val="000000"/>
+                </a:solidFill>
+                <a:latin typeface="Calibri" pitchFamily="34" charset="0"/>
+                <a:ea typeface="Calibri" pitchFamily="34" charset="-122"/>
+                <a:cs typeface="Calibri" pitchFamily="34" charset="-120"/>
+              </a:rPr>
+              <a:t xml:space="preserve">P. Xiang, R. Hao, J. Cai and X. You, “An Active Gate Driver of SiC MOSFET Module Based on PCB Rogowski Coil for Optimizing Tradeoff Between Overshoot and Switching Loss,” IEEE Trans. Power Electron., vol. 38, no. 1, pp. 245–260, 2023.</a:t>
+            </a:r>
+          </a:p>
+          <a:p>
+            <a:pPr marL="177800" indent="0">
+              <a:spcAft>
+                <a:spcPts val="60"/>
+              </a:spcAft>
+              <a:buSzPct val="100000"/>
+              <a:buNone/>
+            </a:pPr>
+            <a:r>
+              <a:rPr lang="en-US" sz="900" b="1" dirty="0">
+                <a:solidFill>
+                  <a:srgbClr val="000000"/>
+                </a:solidFill>
+                <a:latin typeface="Calibri" pitchFamily="34" charset="0"/>
+                <a:ea typeface="Calibri" pitchFamily="34" charset="-122"/>
+                <a:cs typeface="Calibri" pitchFamily="34" charset="-120"/>
+              </a:rPr>
+              <a:t xml:space="preserve">[24]  </a:t>
+            </a:r>
+            <a:r>
+              <a:rPr lang="en-US" sz="900" dirty="0">
+                <a:solidFill>
+                  <a:srgbClr val="000000"/>
+                </a:solidFill>
+                <a:latin typeface="Calibri" pitchFamily="34" charset="0"/>
+                <a:ea typeface="Calibri" pitchFamily="34" charset="-122"/>
+                <a:cs typeface="Calibri" pitchFamily="34" charset="-120"/>
+              </a:rPr>
+              <a:t xml:space="preserve">S. Fukunaga, H. Takayama and T. Hikihara, “Slew rate control of switching transient for SiC MOSFET in boost converter using digital active gate driver,” IET Power Electron., vol. 16, no. 3, pp. 472–482, 2022.</a:t>
+            </a:r>
+          </a:p>
+          <a:p>
+            <a:pPr marL="177800" indent="0">
+              <a:spcAft>
+                <a:spcPts val="60"/>
+              </a:spcAft>
+              <a:buSzPct val="100000"/>
+              <a:buNone/>
+            </a:pPr>
+            <a:r>
+              <a:rPr lang="en-US" sz="900" b="1" dirty="0">
+                <a:solidFill>
+                  <a:srgbClr val="000000"/>
+                </a:solidFill>
+                <a:latin typeface="Calibri" pitchFamily="34" charset="0"/>
+                <a:ea typeface="Calibri" pitchFamily="34" charset="-122"/>
+                <a:cs typeface="Calibri" pitchFamily="34" charset="-120"/>
+              </a:rPr>
+              <a:t xml:space="preserve">[25]  </a:t>
+            </a:r>
+            <a:r>
+              <a:rPr lang="en-US" sz="900" dirty="0">
+                <a:solidFill>
+                  <a:srgbClr val="000000"/>
+                </a:solidFill>
+                <a:latin typeface="Calibri" pitchFamily="34" charset="0"/>
+                <a:ea typeface="Calibri" pitchFamily="34" charset="-122"/>
+                <a:cs typeface="Calibri" pitchFamily="34" charset="-120"/>
+              </a:rPr>
+              <a:t xml:space="preserve">C. Xu, P. Fu, X. Liao, Z. Zhu and L. Liu, “An Integrated Driver With Real-Time Predictive Dead-Time Optimization Technique for GaN-Based Synchronous Buck Converter,” IEEE J. Emerg. Sel. Topics Power Electron., vol. 13, no. 3, pp. 3173–3183, 2025.</a:t>
+            </a:r>
+          </a:p>
+          <a:p>
+            <a:pPr marL="177800" indent="0">
+              <a:spcAft>
+                <a:spcPts val="60"/>
+              </a:spcAft>
+              <a:buSzPct val="100000"/>
+              <a:buNone/>
+            </a:pPr>
+            <a:r>
+              <a:rPr lang="en-US" sz="900" b="1" dirty="0">
+                <a:solidFill>
+                  <a:srgbClr val="000000"/>
+                </a:solidFill>
+                <a:latin typeface="Calibri" pitchFamily="34" charset="0"/>
+                <a:ea typeface="Calibri" pitchFamily="34" charset="-122"/>
+                <a:cs typeface="Calibri" pitchFamily="34" charset="-120"/>
+              </a:rPr>
+              <a:t xml:space="preserve">[26]  </a:t>
+            </a:r>
+            <a:r>
+              <a:rPr lang="en-US" sz="900" dirty="0">
+                <a:solidFill>
+                  <a:srgbClr val="000000"/>
+                </a:solidFill>
+                <a:latin typeface="Calibri" pitchFamily="34" charset="0"/>
+                <a:ea typeface="Calibri" pitchFamily="34" charset="-122"/>
+                <a:cs typeface="Calibri" pitchFamily="34" charset="-120"/>
+              </a:rPr>
+              <a:t xml:space="preserve">C. Chen, P. Chiu, Y. Chen, P. Wang and Y. Chang, “An Integrated Driver With Adaptive Dead-Time Control for GaN-Based Synchronous Buck Converter,” IEEE Trans. Circuits Syst. II, vol. 69, no. 2, pp. 539–543, 2022.</a:t>
+            </a:r>
+          </a:p>
+          <a:p>
+            <a:pPr marL="177800" indent="0">
+              <a:spcAft>
+                <a:spcPts val="60"/>
+              </a:spcAft>
+              <a:buSzPct val="100000"/>
+              <a:buNone/>
+            </a:pPr>
+            <a:r>
+              <a:rPr lang="en-US" sz="900" b="1" dirty="0">
+                <a:solidFill>
+                  <a:srgbClr val="000000"/>
+                </a:solidFill>
+                <a:latin typeface="Calibri" pitchFamily="34" charset="0"/>
+                <a:ea typeface="Calibri" pitchFamily="34" charset="-122"/>
+                <a:cs typeface="Calibri" pitchFamily="34" charset="-120"/>
+              </a:rPr>
+              <a:t xml:space="preserve">[27]  </a:t>
+            </a:r>
+            <a:r>
+              <a:rPr lang="en-US" sz="900" dirty="0">
+                <a:solidFill>
+                  <a:srgbClr val="000000"/>
+                </a:solidFill>
+                <a:latin typeface="Calibri" pitchFamily="34" charset="0"/>
+                <a:ea typeface="Calibri" pitchFamily="34" charset="-122"/>
+                <a:cs typeface="Calibri" pitchFamily="34" charset="-120"/>
+              </a:rPr>
+              <a:t xml:space="preserve">J. Tan, Z. Zhou and G. Zou, “A Programmable Gate Driver Module-Based Multistage Voltage Regulation SiC MOSFET Switching Strategy,” Electronics, vol. 13, no. 22, pp. 4379, 2024.</a:t>
+            </a:r>
+          </a:p>
+          <a:p>
+            <a:pPr marL="177800" indent="0">
+              <a:spcAft>
+                <a:spcPts val="60"/>
+              </a:spcAft>
+              <a:buSzPct val="100000"/>
+              <a:buNone/>
+            </a:pPr>
+            <a:r>
+              <a:rPr lang="en-US" sz="900" b="1" dirty="0">
+                <a:solidFill>
+                  <a:srgbClr val="000000"/>
+                </a:solidFill>
+                <a:latin typeface="Calibri" pitchFamily="34" charset="0"/>
+                <a:ea typeface="Calibri" pitchFamily="34" charset="-122"/>
+                <a:cs typeface="Calibri" pitchFamily="34" charset="-120"/>
+              </a:rPr>
+              <a:t xml:space="preserve">[28]  </a:t>
+            </a:r>
+            <a:r>
+              <a:rPr lang="en-US" sz="900" dirty="0">
+                <a:solidFill>
+                  <a:srgbClr val="000000"/>
+                </a:solidFill>
+                <a:latin typeface="Calibri" pitchFamily="34" charset="0"/>
+                <a:ea typeface="Calibri" pitchFamily="34" charset="-122"/>
+                <a:cs typeface="Calibri" pitchFamily="34" charset="-120"/>
+              </a:rPr>
+              <a:t xml:space="preserve">C. Chen, P. Wang, S. Li, Y. Chen and Y. Chang, “An Integrated Driver With Bang-Bang Dead-Time Control and Charge Sharing Bootstrap Circuit for GaN Synchronous Buck Converter,” IEEE Trans. Power Electron., vol. 37, no. 8, pp. 9503–9514, 2022.</a:t>
+            </a:r>
+          </a:p>
+          <a:p>
+            <a:pPr marL="177800" indent="0">
+              <a:spcAft>
+                <a:spcPts val="60"/>
+              </a:spcAft>
+              <a:buSzPct val="100000"/>
+              <a:buNone/>
+            </a:pPr>
+            <a:r>
+              <a:rPr lang="en-US" sz="900" b="1" dirty="0">
+                <a:solidFill>
+                  <a:srgbClr val="000000"/>
+                </a:solidFill>
+                <a:latin typeface="Calibri" pitchFamily="34" charset="0"/>
+                <a:ea typeface="Calibri" pitchFamily="34" charset="-122"/>
+                <a:cs typeface="Calibri" pitchFamily="34" charset="-120"/>
+              </a:rPr>
+              <a:t xml:space="preserve">[29]  </a:t>
+            </a:r>
+            <a:r>
+              <a:rPr lang="en-US" sz="900" dirty="0">
+                <a:solidFill>
+                  <a:srgbClr val="000000"/>
+                </a:solidFill>
+                <a:latin typeface="Calibri" pitchFamily="34" charset="0"/>
+                <a:ea typeface="Calibri" pitchFamily="34" charset="-122"/>
+                <a:cs typeface="Calibri" pitchFamily="34" charset="-120"/>
+              </a:rPr>
+              <a:t xml:space="preserve">G.H. Thuc, M. Tsai, C. Chen, J. Fu, W. Wu and W. Lin, “A Current Source Gate Driver with Dual-Edge Adaptive Slew Rate for GaN Devices,” in Proc. 2026 IEEE Applied Power Electronics Conference and Exposition (APEC), 2026.</a:t>
+            </a:r>
+          </a:p>
+          <a:p>
+            <a:pPr marL="177800" indent="0">
+              <a:spcAft>
+                <a:spcPts val="60"/>
+              </a:spcAft>
+              <a:buSzPct val="100000"/>
+              <a:buNone/>
+            </a:pPr>
+            <a:r>
+              <a:rPr lang="en-US" sz="900" b="1" dirty="0">
+                <a:solidFill>
+                  <a:srgbClr val="000000"/>
+                </a:solidFill>
+                <a:latin typeface="Calibri" pitchFamily="34" charset="0"/>
+                <a:ea typeface="Calibri" pitchFamily="34" charset="-122"/>
+                <a:cs typeface="Calibri" pitchFamily="34" charset="-120"/>
+              </a:rPr>
+              <a:t xml:space="preserve">[30]  </a:t>
+            </a:r>
+            <a:r>
+              <a:rPr lang="en-US" sz="900" dirty="0">
+                <a:solidFill>
+                  <a:srgbClr val="000000"/>
+                </a:solidFill>
+                <a:latin typeface="Calibri" pitchFamily="34" charset="0"/>
+                <a:ea typeface="Calibri" pitchFamily="34" charset="-122"/>
+                <a:cs typeface="Calibri" pitchFamily="34" charset="-120"/>
+              </a:rPr>
+              <a:t xml:space="preserve">G. Wu, Y. Huang, Y. Chen and C. Chen, “Closed-loop Slew Rate Control of Active Current Source Gate Driver with Digital Implementation for SiC MOSFET,” in Proc. 2025 IEEE Energy Conversion Conference Congress and Exposition (ECCE), 2025.</a:t>
+            </a:r>
+          </a:p>
+          <a:p>
+            <a:pPr marL="177800" indent="0">
+              <a:spcAft>
+                <a:spcPts val="160"/>
+              </a:spcAft>
+              <a:buSzPct val="100000"/>
+              <a:buNone/>
+            </a:pPr>
+            <a:r>
+              <a:rPr lang="en-US" sz="850" dirty="0">
+                <a:solidFill>
+                  <a:srgbClr val="000000"/>
+                </a:solidFill>
+                <a:latin typeface="Calibri" pitchFamily="34" charset="0"/>
+                <a:ea typeface="Calibri" pitchFamily="34" charset="-122"/>
+                <a:cs typeface="Calibri" pitchFamily="34" charset="-120"/>
+              </a:rPr>
+              <a:t xml:space="preserve">All 30 verified against the publisher record — authors, volume, issue and pages resolved through Crossref by DOI and title, not transcribed by hand.</a:t>
+            </a:r>
+          </a:p>
+        </p:txBody>
+      </p:sp>
+      <p:sp>
+        <p:nvSpPr>
+          <p:cNvPr id="6" name="Text 3"/>
+          <p:cNvSpPr txBox="1"/>
+          <p:nvPr/>
+        </p:nvSpPr>
+        <p:spPr>
+          <a:xfrm>
+            <a:off x="640080" y="5806440"/>
+            <a:ext cx="10881360" cy="365760"/>
+          </a:xfrm>
+          <a:prstGeom prst="rect">
+            <a:avLst/>
+          </a:prstGeom>
+          <a:noFill/>
+          <a:ln/>
+        </p:spPr>
+        <p:txBody>
+          <a:bodyPr wrap="square" lIns="0" tIns="0" rIns="0" bIns="0" rtlCol="0" anchor="ctr"/>
+          <a:lstStyle/>
+          <a:p>
+            <a:pPr marL="177800" indent="0">
+              <a:spcAft>
+                <a:spcPts val="0"/>
+              </a:spcAft>
+              <a:buSzPct val="100000"/>
+              <a:buNone/>
+            </a:pPr>
+            <a:r>
+              <a:rPr lang="en-US" sz="1200" dirty="0">
+                <a:solidFill>
+                  <a:srgbClr val="000000"/>
+                </a:solidFill>
+                <a:latin typeface="Calibri" pitchFamily="34" charset="0"/>
+                <a:ea typeface="Calibri" pitchFamily="34" charset="-122"/>
+                <a:cs typeface="Calibri" pitchFamily="34" charset="-120"/>
+              </a:rPr>
+              <a:t xml:space="preserve">Use IEEE format. Every reference listed must be cited in the slides / report.</a:t>
             </a:r>
           </a:p>
         </p:txBody>
@@ -16646,6 +17204,17 @@
                         <a:cs typeface="Calibri" charset="0"/>
                       </a:endParaRPr>
                     </a:p>
+                    <a:p>
+                      <a:r>
+                        <a:rPr sz="1050" b="0">
+                          <a:solidFill>
+                            <a:srgbClr val="000000"/>
+                          </a:solidFill>
+                          <a:latin typeface="Calibri"/>
+                        </a:rPr>
+                        <a:t>[14]–[19]</a:t>
+                      </a:r>
+                    </a:p>
                   </a:txBody>
                   <a:tcPr marL="54864" marR="54864" marT="54864" marB="54864" anchor="ctr">
                     <a:lnL w="9525" cap="flat" cmpd="sng" algn="ctr">
@@ -16958,6 +17527,17 @@
                         <a:ea typeface="Calibri" charset="0"/>
                         <a:cs typeface="Calibri" charset="0"/>
                       </a:endParaRPr>
+                    </a:p>
+                    <a:p>
+                      <a:r>
+                        <a:rPr sz="1050" b="0">
+                          <a:solidFill>
+                            <a:srgbClr val="000000"/>
+                          </a:solidFill>
+                          <a:latin typeface="Calibri"/>
+                        </a:rPr>
+                        <a:t>[20]–[24]</a:t>
+                      </a:r>
                     </a:p>
                   </a:txBody>
                   <a:tcPr marL="54864" marR="54864" marT="54864" marB="54864" anchor="ctr">
@@ -17272,6 +17852,17 @@
                         <a:cs typeface="Calibri" charset="0"/>
                       </a:endParaRPr>
                     </a:p>
+                    <a:p>
+                      <a:r>
+                        <a:rPr sz="1050" b="0">
+                          <a:solidFill>
+                            <a:srgbClr val="000000"/>
+                          </a:solidFill>
+                          <a:latin typeface="Calibri"/>
+                        </a:rPr>
+                        <a:t>[25] [26]</a:t>
+                      </a:r>
+                    </a:p>
                   </a:txBody>
                   <a:tcPr marL="54864" marR="54864" marT="54864" marB="54864" anchor="ctr">
                     <a:lnL w="9525" cap="flat" cmpd="sng" algn="ctr">
@@ -17585,6 +18176,17 @@
                         <a:cs typeface="Calibri" charset="0"/>
                       </a:endParaRPr>
                     </a:p>
+                    <a:p>
+                      <a:r>
+                        <a:rPr sz="1050" b="0">
+                          <a:solidFill>
+                            <a:srgbClr val="000000"/>
+                          </a:solidFill>
+                          <a:latin typeface="Calibri"/>
+                        </a:rPr>
+                        <a:t>[27]–[30]</a:t>
+                      </a:r>
+                    </a:p>
                   </a:txBody>
                   <a:tcPr marL="54864" marR="54864" marT="54864" marB="54864" anchor="ctr">
                     <a:lnL w="9525" cap="flat" cmpd="sng" algn="ctr">
@@ -17789,7 +18391,7 @@
                 <a:ea typeface="Calibri" pitchFamily="34" charset="-122"/>
                 <a:cs typeface="Calibri" pitchFamily="34" charset="-120"/>
               </a:rPr>
-              <a:t xml:space="preserve">13 references. Grouped by what the driver DOES, not by date. Clusters A–C choose a setting or regulate it in analogue; only cluster D makes the setting a digital code — which is what makes an exhaustive search, and this project’s question, possible at all.</a:t>
+              <a:t xml:space="preserve">30 references, all publisher-verified, grouped by what the driver DOES. Clusters A–C set or regulate in analogue; only cluster D makes the setting a digital CODE — which is what makes an exhaustive search possible at all.</a:t>
             </a:r>
           </a:p>
         </p:txBody>

</xml_diff>

<commit_message>
Put all three team members on the title slide
Project-I is a team of three, not a solo project: Sanjay Kumar 23BEC1447,
Aamir Abdullah 23BPS1197 and Amritha S 23BEC1368.

The template's value box is sized for one student -- 4.40 in wide with a fixed
underline rule beneath it. Three names wrap to a second line, and that line is
struck through by the rule. qa.py does not catch it, because the rule is a
separate shape rather than text, so it was found by looking at the render.
Widening the box to the signature block's edge and setting this one field to
9.5 pt keeps all three on a single line above the rule.

Co-Authored-By: Claude Opus 5 <noreply@anthropic.com>
</commit_message>
<xml_diff>
--- a/review/Review1_GaN_Segmented_Gate_Driver.pptx
+++ b/review/Review1_GaN_Segmented_Gate_Driver.pptx
@@ -8941,7 +8941,7 @@
         <p:spPr>
           <a:xfrm>
             <a:off x="3474720" y="3063240"/>
-            <a:ext cx="4023360" cy="384048"/>
+            <a:ext cx="4617720" cy="384048"/>
           </a:xfrm>
           <a:prstGeom prst="rect">
             <a:avLst/>
@@ -8957,15 +8957,15 @@
               <a:buNone/>
             </a:pPr>
             <a:r>
-              <a:rPr lang="en-US" sz="1400" dirty="0">
-                <a:solidFill>
-                  <a:srgbClr val="000000"/>
-                </a:solidFill>
-                <a:latin typeface="Calibri" pitchFamily="34" charset="0"/>
-                <a:ea typeface="Calibri" pitchFamily="34" charset="-122"/>
-                <a:cs typeface="Calibri" pitchFamily="34" charset="-120"/>
-              </a:rPr>
-              <a:t>Amritha S  —  23BEC1368</a:t>
+              <a:rPr lang="en-US" sz="950" dirty="0">
+                <a:solidFill>
+                  <a:srgbClr val="000000"/>
+                </a:solidFill>
+                <a:latin typeface="Calibri" pitchFamily="34" charset="0"/>
+                <a:ea typeface="Calibri" pitchFamily="34" charset="-122"/>
+                <a:cs typeface="Calibri" pitchFamily="34" charset="-120"/>
+              </a:rPr>
+              <a:t>Sanjay Kumar 23BEC1447  ·  Aamir Abdullah 23BPS1197  ·  Amritha S 23BEC1368</a:t>
             </a:r>
             <a:endParaRPr lang="en-US" sz="1400" dirty="0"/>
           </a:p>

</xml_diff>

<commit_message>
Give the deck a theme: four dark section dividers
Thirty slides of white with navy headings reads as raw material, not a
designed deck. Four dividers now break it into acts -- The problem / What we
built / What we found / Where this goes -- at slides 4, 8, 19 and 27. Each
costs about two seconds to present and gives the eye somewhere to rest.

The palette is deliberately not the default deck-builder blue-purple: VIT navy
as the ground, warm off-white for the heading, muted slate for the numeral,
and the same oxblood already used for "failing" in every figure. No gradients,
no decorative stripes, no accent rule under the title -- contrast and
typography do the work, which is what stops it looking machine-made.

Deck is 34 slides. That is more than before but the four additions are
two-second beats, not content.

Co-Authored-By: Claude Opus 5 <noreply@anthropic.com>
</commit_message>
<xml_diff>
--- a/review/Review1_GaN_Segmented_Gate_Driver.pptx
+++ b/review/Review1_GaN_Segmented_Gate_Driver.pptx
@@ -11,9 +11,11 @@
     <p:sldId id="256" r:id="rId2"/>
     <p:sldId id="257" r:id="rId3"/>
     <p:sldId id="258" r:id="rId4"/>
+    <p:sldId id="285" r:id="rId36"/>
     <p:sldId id="259" r:id="rId5"/>
     <p:sldId id="260" r:id="rId6"/>
     <p:sldId id="267" r:id="rId18"/>
+    <p:sldId id="286" r:id="rId37"/>
     <p:sldId id="283" r:id="rId34"/>
     <p:sldId id="261" r:id="rId7"/>
     <p:sldId id="281" r:id="rId32"/>
@@ -24,6 +26,7 @@
     <p:sldId id="278" r:id="rId29"/>
     <p:sldId id="262" r:id="rId8"/>
     <p:sldId id="272" r:id="rId23"/>
+    <p:sldId id="287" r:id="rId38"/>
     <p:sldId id="282" r:id="rId33"/>
     <p:sldId id="273" r:id="rId24"/>
     <p:sldId id="263" r:id="rId9"/>
@@ -31,12 +34,13 @@
     <p:sldId id="275" r:id="rId26"/>
     <p:sldId id="276" r:id="rId27"/>
     <p:sldId id="264" r:id="rId10"/>
+    <p:sldId id="288" r:id="rId39"/>
     <p:sldId id="268" r:id="rId19"/>
+    <p:sldId id="289" r:id="rId40"/>
     <p:sldId id="269" r:id="rId20"/>
     <p:sldId id="270" r:id="rId21"/>
     <p:sldId id="271" r:id="rId22"/>
     <p:sldId id="265" r:id="rId11"/>
-    <p:sldId id="285" r:id="rId36"/>
     <p:sldId id="266" r:id="rId12"/>
   </p:sldIdLst>
   <p:sldSz cx="12192000" cy="6858000"/>
@@ -2465,7 +2469,7 @@
                 <a:ea typeface="Calibri" pitchFamily="34" charset="-122"/>
                 <a:cs typeface="Calibri" pitchFamily="34" charset="-120"/>
               </a:rPr>
-              <a:t>16</a:t>
+              <a:t>18</a:t>
             </a:r>
             <a:endParaRPr lang="en-US" sz="1000" dirty="0"/>
           </a:p>
@@ -2848,7 +2852,7 @@
                 <a:ea typeface="Calibri" pitchFamily="34" charset="-122"/>
                 <a:cs typeface="Calibri" pitchFamily="34" charset="-120"/>
               </a:rPr>
-              <a:t>18</a:t>
+              <a:t>21</a:t>
             </a:r>
             <a:endParaRPr lang="en-US" sz="1000" dirty="0"/>
           </a:p>
@@ -3271,7 +3275,7 @@
                 <a:ea typeface="Calibri" pitchFamily="34" charset="-122"/>
                 <a:cs typeface="Calibri" pitchFamily="34" charset="-120"/>
               </a:rPr>
-              <a:t>19</a:t>
+              <a:t>22</a:t>
             </a:r>
             <a:endParaRPr lang="en-US" sz="1000" dirty="0"/>
           </a:p>
@@ -3787,7 +3791,7 @@
                 <a:ea typeface="Calibri" pitchFamily="34" charset="-122"/>
                 <a:cs typeface="Calibri" pitchFamily="34" charset="-120"/>
               </a:rPr>
-              <a:t>21</a:t>
+              <a:t>24</a:t>
             </a:r>
             <a:endParaRPr lang="en-US" sz="1000" dirty="0"/>
           </a:p>
@@ -4371,7 +4375,7 @@
                 <a:ea typeface="Calibri" pitchFamily="34" charset="-122"/>
                 <a:cs typeface="Calibri" pitchFamily="34" charset="-120"/>
               </a:rPr>
-              <a:t>22</a:t>
+              <a:t>25</a:t>
             </a:r>
             <a:endParaRPr lang="en-US" sz="1000" dirty="0"/>
           </a:p>
@@ -5175,7 +5179,7 @@
                 <a:ea typeface="Calibri" pitchFamily="34" charset="-122"/>
                 <a:cs typeface="Calibri" pitchFamily="34" charset="-120"/>
               </a:rPr>
-              <a:t>23</a:t>
+              <a:t>26</a:t>
             </a:r>
             <a:endParaRPr lang="en-US" sz="1000" dirty="0"/>
           </a:p>
@@ -5421,7 +5425,7 @@
                 <a:ea typeface="Calibri" pitchFamily="34" charset="-122"/>
                 <a:cs typeface="Calibri" pitchFamily="34" charset="-120"/>
               </a:rPr>
-              <a:t>24</a:t>
+              <a:t>28</a:t>
             </a:r>
             <a:endParaRPr lang="en-US" sz="1000" dirty="0"/>
           </a:p>
@@ -7400,7 +7404,7 @@
                 <a:ea typeface="Calibri" pitchFamily="34" charset="-122"/>
                 <a:cs typeface="Calibri" pitchFamily="34" charset="-120"/>
               </a:rPr>
-              <a:t>25</a:t>
+              <a:t>30</a:t>
             </a:r>
             <a:endParaRPr lang="en-US" sz="1000" dirty="0"/>
           </a:p>
@@ -7842,7 +7846,7 @@
                 <a:ea typeface="Calibri" pitchFamily="34" charset="-122"/>
                 <a:cs typeface="Calibri" pitchFamily="34" charset="-120"/>
               </a:rPr>
-              <a:t>26</a:t>
+              <a:t>31</a:t>
             </a:r>
             <a:endParaRPr lang="en-US" sz="1000" dirty="0"/>
           </a:p>
@@ -8363,7 +8367,7 @@
                 <a:ea typeface="Calibri" pitchFamily="34" charset="-122"/>
                 <a:cs typeface="Calibri" pitchFamily="34" charset="-120"/>
               </a:rPr>
-              <a:t>27</a:t>
+              <a:t>32</a:t>
             </a:r>
             <a:endParaRPr lang="en-US" sz="1000" dirty="0"/>
           </a:p>
@@ -9612,7 +9616,7 @@
                 <a:ea typeface="Calibri" pitchFamily="34" charset="-122"/>
                 <a:cs typeface="Calibri" pitchFamily="34" charset="-120"/>
               </a:rPr>
-              <a:t>28</a:t>
+              <a:t>33</a:t>
             </a:r>
             <a:endParaRPr lang="en-US" sz="1000" dirty="0"/>
           </a:p>
@@ -10287,7 +10291,7 @@
                 <a:ea typeface="Calibri" pitchFamily="34" charset="-122"/>
                 <a:cs typeface="Calibri" pitchFamily="34" charset="-120"/>
               </a:rPr>
-              <a:t>30</a:t>
+              <a:t>34</a:t>
             </a:r>
             <a:endParaRPr lang="en-US" sz="1000" dirty="0"/>
           </a:p>
@@ -10407,7 +10411,7 @@
                 <a:ea typeface="Calibri" pitchFamily="34" charset="-122"/>
                 <a:cs typeface="Calibri" pitchFamily="34" charset="-120"/>
               </a:rPr>
-              <a:t>12</a:t>
+              <a:t>14</a:t>
             </a:r>
             <a:endParaRPr lang="en-US" sz="1000" dirty="0"/>
           </a:p>
@@ -11763,7 +11767,7 @@
                 <a:ea typeface="Calibri" pitchFamily="34" charset="-122"/>
                 <a:cs typeface="Calibri" pitchFamily="34" charset="-120"/>
               </a:rPr>
-              <a:t>14</a:t>
+              <a:t>16</a:t>
             </a:r>
             <a:endParaRPr lang="en-US" sz="1000" dirty="0"/>
           </a:p>
@@ -13023,7 +13027,7 @@
                 <a:ea typeface="Calibri" pitchFamily="34" charset="-122"/>
                 <a:cs typeface="Calibri" pitchFamily="34" charset="-120"/>
               </a:rPr>
-              <a:t>11</a:t>
+              <a:t>13</a:t>
             </a:r>
             <a:endParaRPr lang="en-US" sz="1000" dirty="0"/>
           </a:p>
@@ -13309,7 +13313,7 @@
                 <a:ea typeface="Calibri" pitchFamily="34" charset="-122"/>
                 <a:cs typeface="Calibri" pitchFamily="34" charset="-120"/>
               </a:rPr>
-              <a:t>20</a:t>
+              <a:t>23</a:t>
             </a:r>
             <a:endParaRPr lang="en-US" sz="1000" dirty="0"/>
           </a:p>
@@ -13771,7 +13775,7 @@
                 <a:ea typeface="Calibri" pitchFamily="34" charset="-122"/>
                 <a:cs typeface="Calibri" pitchFamily="34" charset="-120"/>
               </a:rPr>
-              <a:t>9</a:t>
+              <a:t>11</a:t>
             </a:r>
             <a:endParaRPr lang="en-US" sz="1000" dirty="0"/>
           </a:p>
@@ -13969,7 +13973,7 @@
                 <a:ea typeface="Calibri" pitchFamily="34" charset="-122"/>
                 <a:cs typeface="Calibri" pitchFamily="34" charset="-120"/>
               </a:rPr>
-              <a:t>17</a:t>
+              <a:t>20</a:t>
             </a:r>
             <a:endParaRPr lang="en-US" sz="1000" dirty="0"/>
           </a:p>
@@ -15118,7 +15122,7 @@
                 <a:ea typeface="Calibri" pitchFamily="34" charset="-122"/>
                 <a:cs typeface="Calibri" pitchFamily="34" charset="-120"/>
               </a:rPr>
-              <a:t xml:space="preserve">7</a:t>
+              <a:t xml:space="preserve">9</a:t>
             </a:r>
           </a:p>
         </p:txBody>
@@ -15763,7 +15767,7 @@
                 <a:ea typeface="Calibri" pitchFamily="34" charset="-122"/>
                 <a:cs typeface="Calibri" pitchFamily="34" charset="-120"/>
               </a:rPr>
-              <a:t xml:space="preserve">13</a:t>
+              <a:t xml:space="preserve">15</a:t>
             </a:r>
           </a:p>
         </p:txBody>
@@ -16821,6 +16825,654 @@
       <p:grpSpPr/>
       <p:sp>
         <p:nvSpPr>
+          <p:cNvPr id="2" name="Rectangle 1"/>
+          <p:cNvSpPr/>
+          <p:nvPr/>
+        </p:nvSpPr>
+        <p:spPr>
+          <a:xfrm>
+            <a:off x="0" y="0"/>
+            <a:ext cx="12191695" cy="6858000"/>
+          </a:xfrm>
+          <a:prstGeom prst="rect">
+            <a:avLst/>
+          </a:prstGeom>
+          <a:solidFill>
+            <a:srgbClr val="14233D"/>
+          </a:solidFill>
+          <a:ln>
+            <a:noFill/>
+          </a:ln>
+          <a:effectLst/>
+        </p:spPr>
+        <p:style>
+          <a:lnRef idx="1">
+            <a:schemeClr val="accent1"/>
+          </a:lnRef>
+          <a:fillRef idx="3">
+            <a:schemeClr val="accent1"/>
+          </a:fillRef>
+          <a:effectRef idx="2">
+            <a:schemeClr val="accent1"/>
+          </a:effectRef>
+          <a:fontRef idx="minor">
+            <a:schemeClr val="lt1"/>
+          </a:fontRef>
+        </p:style>
+        <p:txBody>
+          <a:bodyPr rtlCol="0" anchor="ctr"/>
+          <a:lstStyle/>
+          <a:p/>
+        </p:txBody>
+      </p:sp>
+      <p:sp>
+        <p:nvSpPr>
+          <p:cNvPr id="3" name="TextBox 2"/>
+          <p:cNvSpPr txBox="1"/>
+          <p:nvPr/>
+        </p:nvSpPr>
+        <p:spPr>
+          <a:xfrm>
+            <a:off x="1188720" y="1874519"/>
+            <a:ext cx="2743200" cy="1371600"/>
+          </a:xfrm>
+          <a:prstGeom prst="rect">
+            <a:avLst/>
+          </a:prstGeom>
+          <a:noFill/>
+        </p:spPr>
+        <p:txBody>
+          <a:bodyPr wrap="square">
+            <a:spAutoFit/>
+          </a:bodyPr>
+          <a:lstStyle/>
+          <a:p>
+            <a:r>
+              <a:rPr sz="6600" b="1" i="0">
+                <a:solidFill>
+                  <a:srgbClr val="6B7C93"/>
+                </a:solidFill>
+                <a:latin typeface="Calibri"/>
+              </a:rPr>
+              <a:t>01</a:t>
+            </a:r>
+          </a:p>
+        </p:txBody>
+      </p:sp>
+      <p:sp>
+        <p:nvSpPr>
+          <p:cNvPr id="4" name="TextBox 3"/>
+          <p:cNvSpPr txBox="1"/>
+          <p:nvPr/>
+        </p:nvSpPr>
+        <p:spPr>
+          <a:xfrm>
+            <a:off x="1188720" y="3063240"/>
+            <a:ext cx="9692640" cy="1005840"/>
+          </a:xfrm>
+          <a:prstGeom prst="rect">
+            <a:avLst/>
+          </a:prstGeom>
+          <a:noFill/>
+        </p:spPr>
+        <p:txBody>
+          <a:bodyPr wrap="square">
+            <a:spAutoFit/>
+          </a:bodyPr>
+          <a:lstStyle/>
+          <a:p>
+            <a:r>
+              <a:rPr sz="4400" b="1" i="0">
+                <a:solidFill>
+                  <a:srgbClr val="F4F2EE"/>
+                </a:solidFill>
+                <a:latin typeface="Calibri"/>
+              </a:rPr>
+              <a:t>The problem</a:t>
+            </a:r>
+          </a:p>
+        </p:txBody>
+      </p:sp>
+      <p:sp>
+        <p:nvSpPr>
+          <p:cNvPr id="5" name="TextBox 4"/>
+          <p:cNvSpPr txBox="1"/>
+          <p:nvPr/>
+        </p:nvSpPr>
+        <p:spPr>
+          <a:xfrm>
+            <a:off x="1280160" y="4160520"/>
+            <a:ext cx="9509760" cy="731520"/>
+          </a:xfrm>
+          <a:prstGeom prst="rect">
+            <a:avLst/>
+          </a:prstGeom>
+          <a:noFill/>
+        </p:spPr>
+        <p:txBody>
+          <a:bodyPr wrap="square">
+            <a:spAutoFit/>
+          </a:bodyPr>
+          <a:lstStyle/>
+          <a:p>
+            <a:r>
+              <a:rPr sz="1700" b="0" i="0">
+                <a:solidFill>
+                  <a:srgbClr val="6B7C93"/>
+                </a:solidFill>
+                <a:latin typeface="Calibri"/>
+              </a:rPr>
+              <a:t>A real failure, and the question nobody has answered</a:t>
+            </a:r>
+          </a:p>
+        </p:txBody>
+      </p:sp>
+    </p:spTree>
+  </p:cSld>
+  <p:clrMapOvr>
+    <a:masterClrMapping/>
+  </p:clrMapOvr>
+</p:sld>
+</file>
+
+<file path=ppt/slides/slide31.xml><?xml version="1.0" encoding="utf-8"?>
+<p:sld xmlns:a="http://schemas.openxmlformats.org/drawingml/2006/main" xmlns:p="http://schemas.openxmlformats.org/presentationml/2006/main" xmlns:r="http://schemas.openxmlformats.org/officeDocument/2006/relationships">
+  <p:cSld>
+    <p:spTree>
+      <p:nvGrpSpPr>
+        <p:cNvPr id="1" name=""/>
+        <p:cNvGrpSpPr/>
+        <p:nvPr/>
+      </p:nvGrpSpPr>
+      <p:grpSpPr/>
+      <p:sp>
+        <p:nvSpPr>
+          <p:cNvPr id="2" name="Rectangle 1"/>
+          <p:cNvSpPr/>
+          <p:nvPr/>
+        </p:nvSpPr>
+        <p:spPr>
+          <a:xfrm>
+            <a:off x="0" y="0"/>
+            <a:ext cx="12191695" cy="6858000"/>
+          </a:xfrm>
+          <a:prstGeom prst="rect">
+            <a:avLst/>
+          </a:prstGeom>
+          <a:solidFill>
+            <a:srgbClr val="14233D"/>
+          </a:solidFill>
+          <a:ln>
+            <a:noFill/>
+          </a:ln>
+          <a:effectLst/>
+        </p:spPr>
+        <p:style>
+          <a:lnRef idx="1">
+            <a:schemeClr val="accent1"/>
+          </a:lnRef>
+          <a:fillRef idx="3">
+            <a:schemeClr val="accent1"/>
+          </a:fillRef>
+          <a:effectRef idx="2">
+            <a:schemeClr val="accent1"/>
+          </a:effectRef>
+          <a:fontRef idx="minor">
+            <a:schemeClr val="lt1"/>
+          </a:fontRef>
+        </p:style>
+        <p:txBody>
+          <a:bodyPr rtlCol="0" anchor="ctr"/>
+          <a:lstStyle/>
+          <a:p/>
+        </p:txBody>
+      </p:sp>
+      <p:sp>
+        <p:nvSpPr>
+          <p:cNvPr id="3" name="TextBox 2"/>
+          <p:cNvSpPr txBox="1"/>
+          <p:nvPr/>
+        </p:nvSpPr>
+        <p:spPr>
+          <a:xfrm>
+            <a:off x="1188720" y="1874519"/>
+            <a:ext cx="2743200" cy="1371600"/>
+          </a:xfrm>
+          <a:prstGeom prst="rect">
+            <a:avLst/>
+          </a:prstGeom>
+          <a:noFill/>
+        </p:spPr>
+        <p:txBody>
+          <a:bodyPr wrap="square">
+            <a:spAutoFit/>
+          </a:bodyPr>
+          <a:lstStyle/>
+          <a:p>
+            <a:r>
+              <a:rPr sz="6600" b="1" i="0">
+                <a:solidFill>
+                  <a:srgbClr val="6B7C93"/>
+                </a:solidFill>
+                <a:latin typeface="Calibri"/>
+              </a:rPr>
+              <a:t>02</a:t>
+            </a:r>
+          </a:p>
+        </p:txBody>
+      </p:sp>
+      <p:sp>
+        <p:nvSpPr>
+          <p:cNvPr id="4" name="TextBox 3"/>
+          <p:cNvSpPr txBox="1"/>
+          <p:nvPr/>
+        </p:nvSpPr>
+        <p:spPr>
+          <a:xfrm>
+            <a:off x="1188720" y="3063240"/>
+            <a:ext cx="9692640" cy="1005840"/>
+          </a:xfrm>
+          <a:prstGeom prst="rect">
+            <a:avLst/>
+          </a:prstGeom>
+          <a:noFill/>
+        </p:spPr>
+        <p:txBody>
+          <a:bodyPr wrap="square">
+            <a:spAutoFit/>
+          </a:bodyPr>
+          <a:lstStyle/>
+          <a:p>
+            <a:r>
+              <a:rPr sz="4400" b="1" i="0">
+                <a:solidFill>
+                  <a:srgbClr val="F4F2EE"/>
+                </a:solidFill>
+                <a:latin typeface="Calibri"/>
+              </a:rPr>
+              <a:t>What we built</a:t>
+            </a:r>
+          </a:p>
+        </p:txBody>
+      </p:sp>
+      <p:sp>
+        <p:nvSpPr>
+          <p:cNvPr id="5" name="TextBox 4"/>
+          <p:cNvSpPr txBox="1"/>
+          <p:nvPr/>
+        </p:nvSpPr>
+        <p:spPr>
+          <a:xfrm>
+            <a:off x="1280160" y="4160520"/>
+            <a:ext cx="9509760" cy="731520"/>
+          </a:xfrm>
+          <a:prstGeom prst="rect">
+            <a:avLst/>
+          </a:prstGeom>
+          <a:noFill/>
+        </p:spPr>
+        <p:txBody>
+          <a:bodyPr wrap="square">
+            <a:spAutoFit/>
+          </a:bodyPr>
+          <a:lstStyle/>
+          <a:p>
+            <a:r>
+              <a:rPr sz="1700" b="0" i="0">
+                <a:solidFill>
+                  <a:srgbClr val="6B7C93"/>
+                </a:solidFill>
+                <a:latin typeface="Calibri"/>
+              </a:rPr>
+              <a:t>A 720-point control word, and an exhaustive search</a:t>
+            </a:r>
+          </a:p>
+        </p:txBody>
+      </p:sp>
+    </p:spTree>
+  </p:cSld>
+  <p:clrMapOvr>
+    <a:masterClrMapping/>
+  </p:clrMapOvr>
+</p:sld>
+</file>
+
+<file path=ppt/slides/slide32.xml><?xml version="1.0" encoding="utf-8"?>
+<p:sld xmlns:a="http://schemas.openxmlformats.org/drawingml/2006/main" xmlns:p="http://schemas.openxmlformats.org/presentationml/2006/main" xmlns:r="http://schemas.openxmlformats.org/officeDocument/2006/relationships">
+  <p:cSld>
+    <p:spTree>
+      <p:nvGrpSpPr>
+        <p:cNvPr id="1" name=""/>
+        <p:cNvGrpSpPr/>
+        <p:nvPr/>
+      </p:nvGrpSpPr>
+      <p:grpSpPr/>
+      <p:sp>
+        <p:nvSpPr>
+          <p:cNvPr id="2" name="Rectangle 1"/>
+          <p:cNvSpPr/>
+          <p:nvPr/>
+        </p:nvSpPr>
+        <p:spPr>
+          <a:xfrm>
+            <a:off x="0" y="0"/>
+            <a:ext cx="12191695" cy="6858000"/>
+          </a:xfrm>
+          <a:prstGeom prst="rect">
+            <a:avLst/>
+          </a:prstGeom>
+          <a:solidFill>
+            <a:srgbClr val="14233D"/>
+          </a:solidFill>
+          <a:ln>
+            <a:noFill/>
+          </a:ln>
+          <a:effectLst/>
+        </p:spPr>
+        <p:style>
+          <a:lnRef idx="1">
+            <a:schemeClr val="accent1"/>
+          </a:lnRef>
+          <a:fillRef idx="3">
+            <a:schemeClr val="accent1"/>
+          </a:fillRef>
+          <a:effectRef idx="2">
+            <a:schemeClr val="accent1"/>
+          </a:effectRef>
+          <a:fontRef idx="minor">
+            <a:schemeClr val="lt1"/>
+          </a:fontRef>
+        </p:style>
+        <p:txBody>
+          <a:bodyPr rtlCol="0" anchor="ctr"/>
+          <a:lstStyle/>
+          <a:p/>
+        </p:txBody>
+      </p:sp>
+      <p:sp>
+        <p:nvSpPr>
+          <p:cNvPr id="3" name="TextBox 2"/>
+          <p:cNvSpPr txBox="1"/>
+          <p:nvPr/>
+        </p:nvSpPr>
+        <p:spPr>
+          <a:xfrm>
+            <a:off x="1188720" y="1874519"/>
+            <a:ext cx="2743200" cy="1371600"/>
+          </a:xfrm>
+          <a:prstGeom prst="rect">
+            <a:avLst/>
+          </a:prstGeom>
+          <a:noFill/>
+        </p:spPr>
+        <p:txBody>
+          <a:bodyPr wrap="square">
+            <a:spAutoFit/>
+          </a:bodyPr>
+          <a:lstStyle/>
+          <a:p>
+            <a:r>
+              <a:rPr sz="6600" b="1" i="0">
+                <a:solidFill>
+                  <a:srgbClr val="6B7C93"/>
+                </a:solidFill>
+                <a:latin typeface="Calibri"/>
+              </a:rPr>
+              <a:t>03</a:t>
+            </a:r>
+          </a:p>
+        </p:txBody>
+      </p:sp>
+      <p:sp>
+        <p:nvSpPr>
+          <p:cNvPr id="4" name="TextBox 3"/>
+          <p:cNvSpPr txBox="1"/>
+          <p:nvPr/>
+        </p:nvSpPr>
+        <p:spPr>
+          <a:xfrm>
+            <a:off x="1188720" y="3063240"/>
+            <a:ext cx="9692640" cy="1005840"/>
+          </a:xfrm>
+          <a:prstGeom prst="rect">
+            <a:avLst/>
+          </a:prstGeom>
+          <a:noFill/>
+        </p:spPr>
+        <p:txBody>
+          <a:bodyPr wrap="square">
+            <a:spAutoFit/>
+          </a:bodyPr>
+          <a:lstStyle/>
+          <a:p>
+            <a:r>
+              <a:rPr sz="4400" b="1" i="0">
+                <a:solidFill>
+                  <a:srgbClr val="F4F2EE"/>
+                </a:solidFill>
+                <a:latin typeface="Calibri"/>
+              </a:rPr>
+              <a:t>What we found</a:t>
+            </a:r>
+          </a:p>
+        </p:txBody>
+      </p:sp>
+      <p:sp>
+        <p:nvSpPr>
+          <p:cNvPr id="5" name="TextBox 4"/>
+          <p:cNvSpPr txBox="1"/>
+          <p:nvPr/>
+        </p:nvSpPr>
+        <p:spPr>
+          <a:xfrm>
+            <a:off x="1280160" y="4160520"/>
+            <a:ext cx="9509760" cy="731520"/>
+          </a:xfrm>
+          <a:prstGeom prst="rect">
+            <a:avLst/>
+          </a:prstGeom>
+          <a:noFill/>
+        </p:spPr>
+        <p:txBody>
+          <a:bodyPr wrap="square">
+            <a:spAutoFit/>
+          </a:bodyPr>
+          <a:lstStyle/>
+          <a:p>
+            <a:r>
+              <a:rPr sz="1700" b="0" i="0">
+                <a:solidFill>
+                  <a:srgbClr val="6B7C93"/>
+                </a:solidFill>
+                <a:latin typeface="Calibri"/>
+              </a:rPr>
+              <a:t>Choosing well beats adapting — and by how much</a:t>
+            </a:r>
+          </a:p>
+        </p:txBody>
+      </p:sp>
+    </p:spTree>
+  </p:cSld>
+  <p:clrMapOvr>
+    <a:masterClrMapping/>
+  </p:clrMapOvr>
+</p:sld>
+</file>
+
+<file path=ppt/slides/slide33.xml><?xml version="1.0" encoding="utf-8"?>
+<p:sld xmlns:a="http://schemas.openxmlformats.org/drawingml/2006/main" xmlns:p="http://schemas.openxmlformats.org/presentationml/2006/main" xmlns:r="http://schemas.openxmlformats.org/officeDocument/2006/relationships">
+  <p:cSld>
+    <p:spTree>
+      <p:nvGrpSpPr>
+        <p:cNvPr id="1" name=""/>
+        <p:cNvGrpSpPr/>
+        <p:nvPr/>
+      </p:nvGrpSpPr>
+      <p:grpSpPr/>
+      <p:sp>
+        <p:nvSpPr>
+          <p:cNvPr id="2" name="Rectangle 1"/>
+          <p:cNvSpPr/>
+          <p:nvPr/>
+        </p:nvSpPr>
+        <p:spPr>
+          <a:xfrm>
+            <a:off x="0" y="0"/>
+            <a:ext cx="12191695" cy="6858000"/>
+          </a:xfrm>
+          <a:prstGeom prst="rect">
+            <a:avLst/>
+          </a:prstGeom>
+          <a:solidFill>
+            <a:srgbClr val="14233D"/>
+          </a:solidFill>
+          <a:ln>
+            <a:noFill/>
+          </a:ln>
+          <a:effectLst/>
+        </p:spPr>
+        <p:style>
+          <a:lnRef idx="1">
+            <a:schemeClr val="accent1"/>
+          </a:lnRef>
+          <a:fillRef idx="3">
+            <a:schemeClr val="accent1"/>
+          </a:fillRef>
+          <a:effectRef idx="2">
+            <a:schemeClr val="accent1"/>
+          </a:effectRef>
+          <a:fontRef idx="minor">
+            <a:schemeClr val="lt1"/>
+          </a:fontRef>
+        </p:style>
+        <p:txBody>
+          <a:bodyPr rtlCol="0" anchor="ctr"/>
+          <a:lstStyle/>
+          <a:p/>
+        </p:txBody>
+      </p:sp>
+      <p:sp>
+        <p:nvSpPr>
+          <p:cNvPr id="3" name="TextBox 2"/>
+          <p:cNvSpPr txBox="1"/>
+          <p:nvPr/>
+        </p:nvSpPr>
+        <p:spPr>
+          <a:xfrm>
+            <a:off x="1188720" y="1874519"/>
+            <a:ext cx="2743200" cy="1371600"/>
+          </a:xfrm>
+          <a:prstGeom prst="rect">
+            <a:avLst/>
+          </a:prstGeom>
+          <a:noFill/>
+        </p:spPr>
+        <p:txBody>
+          <a:bodyPr wrap="square">
+            <a:spAutoFit/>
+          </a:bodyPr>
+          <a:lstStyle/>
+          <a:p>
+            <a:r>
+              <a:rPr sz="6600" b="1" i="0">
+                <a:solidFill>
+                  <a:srgbClr val="6B7C93"/>
+                </a:solidFill>
+                <a:latin typeface="Calibri"/>
+              </a:rPr>
+              <a:t>04</a:t>
+            </a:r>
+          </a:p>
+        </p:txBody>
+      </p:sp>
+      <p:sp>
+        <p:nvSpPr>
+          <p:cNvPr id="4" name="TextBox 3"/>
+          <p:cNvSpPr txBox="1"/>
+          <p:nvPr/>
+        </p:nvSpPr>
+        <p:spPr>
+          <a:xfrm>
+            <a:off x="1188720" y="3063240"/>
+            <a:ext cx="9692640" cy="1005840"/>
+          </a:xfrm>
+          <a:prstGeom prst="rect">
+            <a:avLst/>
+          </a:prstGeom>
+          <a:noFill/>
+        </p:spPr>
+        <p:txBody>
+          <a:bodyPr wrap="square">
+            <a:spAutoFit/>
+          </a:bodyPr>
+          <a:lstStyle/>
+          <a:p>
+            <a:r>
+              <a:rPr sz="4400" b="1" i="0">
+                <a:solidFill>
+                  <a:srgbClr val="F4F2EE"/>
+                </a:solidFill>
+                <a:latin typeface="Calibri"/>
+              </a:rPr>
+              <a:t>Where this goes</a:t>
+            </a:r>
+          </a:p>
+        </p:txBody>
+      </p:sp>
+      <p:sp>
+        <p:nvSpPr>
+          <p:cNvPr id="5" name="TextBox 4"/>
+          <p:cNvSpPr txBox="1"/>
+          <p:nvPr/>
+        </p:nvSpPr>
+        <p:spPr>
+          <a:xfrm>
+            <a:off x="1280160" y="4160520"/>
+            <a:ext cx="9509760" cy="731520"/>
+          </a:xfrm>
+          <a:prstGeom prst="rect">
+            <a:avLst/>
+          </a:prstGeom>
+          <a:noFill/>
+        </p:spPr>
+        <p:txBody>
+          <a:bodyPr wrap="square">
+            <a:spAutoFit/>
+          </a:bodyPr>
+          <a:lstStyle/>
+          <a:p>
+            <a:r>
+              <a:rPr sz="1700" b="0" i="0">
+                <a:solidFill>
+                  <a:srgbClr val="6B7C93"/>
+                </a:solidFill>
+                <a:latin typeface="Calibri"/>
+              </a:rPr>
+              <a:t>The deliverable, the limits, and Review-II</a:t>
+            </a:r>
+          </a:p>
+        </p:txBody>
+      </p:sp>
+    </p:spTree>
+  </p:cSld>
+  <p:clrMapOvr>
+    <a:masterClrMapping/>
+  </p:clrMapOvr>
+</p:sld>
+</file>
+
+<file path=ppt/slides/slide34.xml><?xml version="1.0" encoding="utf-8"?>
+<p:sld xmlns:a="http://schemas.openxmlformats.org/drawingml/2006/main" xmlns:p="http://schemas.openxmlformats.org/presentationml/2006/main" xmlns:r="http://schemas.openxmlformats.org/officeDocument/2006/relationships">
+  <p:cSld>
+    <p:spTree>
+      <p:nvGrpSpPr>
+        <p:cNvPr id="1" name=""/>
+        <p:cNvGrpSpPr/>
+        <p:nvPr/>
+      </p:nvGrpSpPr>
+      <p:grpSpPr/>
+      <p:sp>
+        <p:nvSpPr>
           <p:cNvPr id="2" name="Text 0"/>
           <p:cNvSpPr txBox="1"/>
           <p:nvPr/>
@@ -16923,530 +17575,24 @@
       </p:pic>
       <p:sp>
         <p:nvSpPr>
-          <p:cNvPr id="5" name="Text 2"/>
+          <p:cNvPr id="5" name="TextBox 4"/>
           <p:cNvSpPr txBox="1"/>
           <p:nvPr/>
         </p:nvSpPr>
         <p:spPr>
           <a:xfrm>
             <a:off x="640080" y="1325880"/>
-            <a:ext cx="10881360" cy="4343400"/>
-          </a:xfrm>
-          <a:prstGeom prst="rect">
-            <a:avLst/>
-          </a:prstGeom>
-          <a:noFill/>
-          <a:ln/>
-        </p:spPr>
-        <p:txBody>
-          <a:bodyPr wrap="square" lIns="0" tIns="0" rIns="0" bIns="0" rtlCol="0" anchor="t"/>
-          <a:lstStyle/>
-          <a:p>
-            <a:pPr marL="177800" indent="0">
-              <a:spcAft>
-                <a:spcPts val="60"/>
-              </a:spcAft>
-              <a:buSzPct val="100000"/>
-              <a:buNone/>
-            </a:pPr>
-            <a:r>
-              <a:rPr lang="en-US" sz="900" b="1" dirty="0">
-                <a:solidFill>
-                  <a:srgbClr val="000000"/>
-                </a:solidFill>
-                <a:latin typeface="Calibri" pitchFamily="34" charset="0"/>
-                <a:ea typeface="Calibri" pitchFamily="34" charset="-122"/>
-                <a:cs typeface="Calibri" pitchFamily="34" charset="-120"/>
-              </a:rPr>
-              <a:t xml:space="preserve">[16]  </a:t>
-            </a:r>
-            <a:r>
-              <a:rPr lang="en-US" sz="900" dirty="0">
-                <a:solidFill>
-                  <a:srgbClr val="000000"/>
-                </a:solidFill>
-                <a:latin typeface="Calibri" pitchFamily="34" charset="0"/>
-                <a:ea typeface="Calibri" pitchFamily="34" charset="-122"/>
-                <a:cs typeface="Calibri" pitchFamily="34" charset="-120"/>
-              </a:rPr>
-              <a:t xml:space="preserve">Z. Yuan, H. Li, M. Zhang, Z. Yang, S. Zhao, H. Wang, X. Wang and L. Ding, “Influence of Negative Gate Bias on Crosstalk Spike in SiC MOSFETs Half-Bridge Circuit,” IEEE J. Emerg. Sel. Topics Power Electron., vol. 14, no. 3, pp. 3217–3229, 2026.</a:t>
-            </a:r>
-          </a:p>
-          <a:p>
-            <a:pPr marL="177800" indent="0">
-              <a:spcAft>
-                <a:spcPts val="60"/>
-              </a:spcAft>
-              <a:buSzPct val="100000"/>
-              <a:buNone/>
-            </a:pPr>
-            <a:r>
-              <a:rPr lang="en-US" sz="900" b="1" dirty="0">
-                <a:solidFill>
-                  <a:srgbClr val="000000"/>
-                </a:solidFill>
-                <a:latin typeface="Calibri" pitchFamily="34" charset="0"/>
-                <a:ea typeface="Calibri" pitchFamily="34" charset="-122"/>
-                <a:cs typeface="Calibri" pitchFamily="34" charset="-120"/>
-              </a:rPr>
-              <a:t xml:space="preserve">[17]  </a:t>
-            </a:r>
-            <a:r>
-              <a:rPr lang="en-US" sz="900" dirty="0">
-                <a:solidFill>
-                  <a:srgbClr val="000000"/>
-                </a:solidFill>
-                <a:latin typeface="Calibri" pitchFamily="34" charset="0"/>
-                <a:ea typeface="Calibri" pitchFamily="34" charset="-122"/>
-                <a:cs typeface="Calibri" pitchFamily="34" charset="-120"/>
-              </a:rPr>
-              <a:t xml:space="preserve">L. Zhang, K. Wang, S. Guo and B. Zhu, “A Gate Driver for Crosstalk Suppression of eGaN HEMT Power Devices,” J. Low Power Electron. Appl., vol. 15, no. 3, pp. 38, 2025.</a:t>
-            </a:r>
-          </a:p>
-          <a:p>
-            <a:pPr marL="177800" indent="0">
-              <a:spcAft>
-                <a:spcPts val="60"/>
-              </a:spcAft>
-              <a:buSzPct val="100000"/>
-              <a:buNone/>
-            </a:pPr>
-            <a:r>
-              <a:rPr lang="en-US" sz="900" b="1" dirty="0">
-                <a:solidFill>
-                  <a:srgbClr val="000000"/>
-                </a:solidFill>
-                <a:latin typeface="Calibri" pitchFamily="34" charset="0"/>
-                <a:ea typeface="Calibri" pitchFamily="34" charset="-122"/>
-                <a:cs typeface="Calibri" pitchFamily="34" charset="-120"/>
-              </a:rPr>
-              <a:t xml:space="preserve">[18]  </a:t>
-            </a:r>
-            <a:r>
-              <a:rPr lang="en-US" sz="900" dirty="0">
-                <a:solidFill>
-                  <a:srgbClr val="000000"/>
-                </a:solidFill>
-                <a:latin typeface="Calibri" pitchFamily="34" charset="0"/>
-                <a:ea typeface="Calibri" pitchFamily="34" charset="-122"/>
-                <a:cs typeface="Calibri" pitchFamily="34" charset="-120"/>
-              </a:rPr>
-              <a:t xml:space="preserve">J. Wu, “Parallel arrangement of MOSFETs, effective suppression of crosstalk: A new gate driver topology,” iEnergy, vol. 2, no. 3, pp. 163–163, 2023.</a:t>
-            </a:r>
-          </a:p>
-          <a:p>
-            <a:pPr marL="177800" indent="0">
-              <a:spcAft>
-                <a:spcPts val="60"/>
-              </a:spcAft>
-              <a:buSzPct val="100000"/>
-              <a:buNone/>
-            </a:pPr>
-            <a:r>
-              <a:rPr lang="en-US" sz="900" b="1" dirty="0">
-                <a:solidFill>
-                  <a:srgbClr val="000000"/>
-                </a:solidFill>
-                <a:latin typeface="Calibri" pitchFamily="34" charset="0"/>
-                <a:ea typeface="Calibri" pitchFamily="34" charset="-122"/>
-                <a:cs typeface="Calibri" pitchFamily="34" charset="-120"/>
-              </a:rPr>
-              <a:t xml:space="preserve">[19]  </a:t>
-            </a:r>
-            <a:r>
-              <a:rPr lang="en-US" sz="900" dirty="0">
-                <a:solidFill>
-                  <a:srgbClr val="000000"/>
-                </a:solidFill>
-                <a:latin typeface="Calibri" pitchFamily="34" charset="0"/>
-                <a:ea typeface="Calibri" pitchFamily="34" charset="-122"/>
-                <a:cs typeface="Calibri" pitchFamily="34" charset="-120"/>
-              </a:rPr>
-              <a:t xml:space="preserve">Y. Mikhaylov, G. Buticchi and M. Galea, “A gate driver for parallel connected MOSFETs with crosstalk suppression,” iEnergy, vol. 2, no. 3, pp. 240–250, 2023.</a:t>
-            </a:r>
-          </a:p>
-          <a:p>
-            <a:pPr marL="177800" indent="0">
-              <a:spcAft>
-                <a:spcPts val="60"/>
-              </a:spcAft>
-              <a:buSzPct val="100000"/>
-              <a:buNone/>
-            </a:pPr>
-            <a:r>
-              <a:rPr lang="en-US" sz="900" b="1" dirty="0">
-                <a:solidFill>
-                  <a:srgbClr val="000000"/>
-                </a:solidFill>
-                <a:latin typeface="Calibri" pitchFamily="34" charset="0"/>
-                <a:ea typeface="Calibri" pitchFamily="34" charset="-122"/>
-                <a:cs typeface="Calibri" pitchFamily="34" charset="-120"/>
-              </a:rPr>
-              <a:t xml:space="preserve">[20]  </a:t>
-            </a:r>
-            <a:r>
-              <a:rPr lang="en-US" sz="900" dirty="0">
-                <a:solidFill>
-                  <a:srgbClr val="000000"/>
-                </a:solidFill>
-                <a:latin typeface="Calibri" pitchFamily="34" charset="0"/>
-                <a:ea typeface="Calibri" pitchFamily="34" charset="-122"/>
-                <a:cs typeface="Calibri" pitchFamily="34" charset="-120"/>
-              </a:rPr>
-              <a:t xml:space="preserve">W. Liu and H. Min, “A Load Adaptive Active Gate Driver with Fast-Switching Three-Level Current Source for Overshoot Suppression in GaN-Based Half-Bridge Converters,” IEEE Trans. Power Electron., pp. 1–8, 2026.</a:t>
-            </a:r>
-          </a:p>
-          <a:p>
-            <a:pPr marL="177800" indent="0">
-              <a:spcAft>
-                <a:spcPts val="60"/>
-              </a:spcAft>
-              <a:buSzPct val="100000"/>
-              <a:buNone/>
-            </a:pPr>
-            <a:r>
-              <a:rPr lang="en-US" sz="900" b="1" dirty="0">
-                <a:solidFill>
-                  <a:srgbClr val="000000"/>
-                </a:solidFill>
-                <a:latin typeface="Calibri" pitchFamily="34" charset="0"/>
-                <a:ea typeface="Calibri" pitchFamily="34" charset="-122"/>
-                <a:cs typeface="Calibri" pitchFamily="34" charset="-120"/>
-              </a:rPr>
-              <a:t xml:space="preserve">[21]  </a:t>
-            </a:r>
-            <a:r>
-              <a:rPr lang="en-US" sz="900" dirty="0">
-                <a:solidFill>
-                  <a:srgbClr val="000000"/>
-                </a:solidFill>
-                <a:latin typeface="Calibri" pitchFamily="34" charset="0"/>
-                <a:ea typeface="Calibri" pitchFamily="34" charset="-122"/>
-                <a:cs typeface="Calibri" pitchFamily="34" charset="-120"/>
-              </a:rPr>
-              <a:t xml:space="preserve">R. Chen, F. Wang, H. Bai and L.M. Tolbert, “A Simple Gate Driver Circuit for Turn-on Overvoltage Suppression of 10 kV SiC MOSFETs With Temporarily Lowering Gate Voltage During dv/dt,” IEEE Trans. Ind. Electron., pp. 1–6, 2026.</a:t>
-            </a:r>
-          </a:p>
-          <a:p>
-            <a:pPr marL="177800" indent="0">
-              <a:spcAft>
-                <a:spcPts val="60"/>
-              </a:spcAft>
-              <a:buSzPct val="100000"/>
-              <a:buNone/>
-            </a:pPr>
-            <a:r>
-              <a:rPr lang="en-US" sz="900" b="1" dirty="0">
-                <a:solidFill>
-                  <a:srgbClr val="000000"/>
-                </a:solidFill>
-                <a:latin typeface="Calibri" pitchFamily="34" charset="0"/>
-                <a:ea typeface="Calibri" pitchFamily="34" charset="-122"/>
-                <a:cs typeface="Calibri" pitchFamily="34" charset="-120"/>
-              </a:rPr>
-              <a:t xml:space="preserve">[22]  </a:t>
-            </a:r>
-            <a:r>
-              <a:rPr lang="en-US" sz="900" dirty="0">
-                <a:solidFill>
-                  <a:srgbClr val="000000"/>
-                </a:solidFill>
-                <a:latin typeface="Calibri" pitchFamily="34" charset="0"/>
-                <a:ea typeface="Calibri" pitchFamily="34" charset="-122"/>
-                <a:cs typeface="Calibri" pitchFamily="34" charset="-120"/>
-              </a:rPr>
-              <a:t xml:space="preserve">D. Yu, M. Yang, L. Yin, K. Hu, W. Zhang and Q. Fu, “A Dual-Loop Active Gate Driver With Independent Voltage Slew Rate and Overshoot Control for Switching Loss Optimization of SiC MOSFETs,” IEEE Trans. Ind. Electron., pp. 1–12, 2026.</a:t>
-            </a:r>
-          </a:p>
-          <a:p>
-            <a:pPr marL="177800" indent="0">
-              <a:spcAft>
-                <a:spcPts val="60"/>
-              </a:spcAft>
-              <a:buSzPct val="100000"/>
-              <a:buNone/>
-            </a:pPr>
-            <a:r>
-              <a:rPr lang="en-US" sz="900" b="1" dirty="0">
-                <a:solidFill>
-                  <a:srgbClr val="000000"/>
-                </a:solidFill>
-                <a:latin typeface="Calibri" pitchFamily="34" charset="0"/>
-                <a:ea typeface="Calibri" pitchFamily="34" charset="-122"/>
-                <a:cs typeface="Calibri" pitchFamily="34" charset="-120"/>
-              </a:rPr>
-              <a:t xml:space="preserve">[23]  </a:t>
-            </a:r>
-            <a:r>
-              <a:rPr lang="en-US" sz="900" dirty="0">
-                <a:solidFill>
-                  <a:srgbClr val="000000"/>
-                </a:solidFill>
-                <a:latin typeface="Calibri" pitchFamily="34" charset="0"/>
-                <a:ea typeface="Calibri" pitchFamily="34" charset="-122"/>
-                <a:cs typeface="Calibri" pitchFamily="34" charset="-120"/>
-              </a:rPr>
-              <a:t xml:space="preserve">P. Xiang, R. Hao, J. Cai and X. You, “An Active Gate Driver of SiC MOSFET Module Based on PCB Rogowski Coil for Optimizing Tradeoff Between Overshoot and Switching Loss,” IEEE Trans. Power Electron., vol. 38, no. 1, pp. 245–260, 2023.</a:t>
-            </a:r>
-          </a:p>
-          <a:p>
-            <a:pPr marL="177800" indent="0">
-              <a:spcAft>
-                <a:spcPts val="60"/>
-              </a:spcAft>
-              <a:buSzPct val="100000"/>
-              <a:buNone/>
-            </a:pPr>
-            <a:r>
-              <a:rPr lang="en-US" sz="900" b="1" dirty="0">
-                <a:solidFill>
-                  <a:srgbClr val="000000"/>
-                </a:solidFill>
-                <a:latin typeface="Calibri" pitchFamily="34" charset="0"/>
-                <a:ea typeface="Calibri" pitchFamily="34" charset="-122"/>
-                <a:cs typeface="Calibri" pitchFamily="34" charset="-120"/>
-              </a:rPr>
-              <a:t xml:space="preserve">[24]  </a:t>
-            </a:r>
-            <a:r>
-              <a:rPr lang="en-US" sz="900" dirty="0">
-                <a:solidFill>
-                  <a:srgbClr val="000000"/>
-                </a:solidFill>
-                <a:latin typeface="Calibri" pitchFamily="34" charset="0"/>
-                <a:ea typeface="Calibri" pitchFamily="34" charset="-122"/>
-                <a:cs typeface="Calibri" pitchFamily="34" charset="-120"/>
-              </a:rPr>
-              <a:t xml:space="preserve">S. Fukunaga, H. Takayama and T. Hikihara, “Slew rate control of switching transient for SiC MOSFET in boost converter using digital active gate driver,” IET Power Electron., vol. 16, no. 3, pp. 472–482, 2022.</a:t>
-            </a:r>
-          </a:p>
-          <a:p>
-            <a:pPr marL="177800" indent="0">
-              <a:spcAft>
-                <a:spcPts val="60"/>
-              </a:spcAft>
-              <a:buSzPct val="100000"/>
-              <a:buNone/>
-            </a:pPr>
-            <a:r>
-              <a:rPr lang="en-US" sz="900" b="1" dirty="0">
-                <a:solidFill>
-                  <a:srgbClr val="000000"/>
-                </a:solidFill>
-                <a:latin typeface="Calibri" pitchFamily="34" charset="0"/>
-                <a:ea typeface="Calibri" pitchFamily="34" charset="-122"/>
-                <a:cs typeface="Calibri" pitchFamily="34" charset="-120"/>
-              </a:rPr>
-              <a:t xml:space="preserve">[25]  </a:t>
-            </a:r>
-            <a:r>
-              <a:rPr lang="en-US" sz="900" dirty="0">
-                <a:solidFill>
-                  <a:srgbClr val="000000"/>
-                </a:solidFill>
-                <a:latin typeface="Calibri" pitchFamily="34" charset="0"/>
-                <a:ea typeface="Calibri" pitchFamily="34" charset="-122"/>
-                <a:cs typeface="Calibri" pitchFamily="34" charset="-120"/>
-              </a:rPr>
-              <a:t xml:space="preserve">C. Xu, P. Fu, X. Liao, Z. Zhu and L. Liu, “An Integrated Driver With Real-Time Predictive Dead-Time Optimization Technique for GaN-Based Synchronous Buck Converter,” IEEE J. Emerg. Sel. Topics Power Electron., vol. 13, no. 3, pp. 3173–3183, 2025.</a:t>
-            </a:r>
-          </a:p>
-          <a:p>
-            <a:pPr marL="177800" indent="0">
-              <a:spcAft>
-                <a:spcPts val="60"/>
-              </a:spcAft>
-              <a:buSzPct val="100000"/>
-              <a:buNone/>
-            </a:pPr>
-            <a:r>
-              <a:rPr lang="en-US" sz="900" b="1" dirty="0">
-                <a:solidFill>
-                  <a:srgbClr val="000000"/>
-                </a:solidFill>
-                <a:latin typeface="Calibri" pitchFamily="34" charset="0"/>
-                <a:ea typeface="Calibri" pitchFamily="34" charset="-122"/>
-                <a:cs typeface="Calibri" pitchFamily="34" charset="-120"/>
-              </a:rPr>
-              <a:t xml:space="preserve">[26]  </a:t>
-            </a:r>
-            <a:r>
-              <a:rPr lang="en-US" sz="900" dirty="0">
-                <a:solidFill>
-                  <a:srgbClr val="000000"/>
-                </a:solidFill>
-                <a:latin typeface="Calibri" pitchFamily="34" charset="0"/>
-                <a:ea typeface="Calibri" pitchFamily="34" charset="-122"/>
-                <a:cs typeface="Calibri" pitchFamily="34" charset="-120"/>
-              </a:rPr>
-              <a:t xml:space="preserve">C. Chen, P. Chiu, Y. Chen, P. Wang and Y. Chang, “An Integrated Driver With Adaptive Dead-Time Control for GaN-Based Synchronous Buck Converter,” IEEE Trans. Circuits Syst. II, vol. 69, no. 2, pp. 539–543, 2022.</a:t>
-            </a:r>
-          </a:p>
-          <a:p>
-            <a:pPr marL="177800" indent="0">
-              <a:spcAft>
-                <a:spcPts val="60"/>
-              </a:spcAft>
-              <a:buSzPct val="100000"/>
-              <a:buNone/>
-            </a:pPr>
-            <a:r>
-              <a:rPr lang="en-US" sz="900" b="1" dirty="0">
-                <a:solidFill>
-                  <a:srgbClr val="000000"/>
-                </a:solidFill>
-                <a:latin typeface="Calibri" pitchFamily="34" charset="0"/>
-                <a:ea typeface="Calibri" pitchFamily="34" charset="-122"/>
-                <a:cs typeface="Calibri" pitchFamily="34" charset="-120"/>
-              </a:rPr>
-              <a:t xml:space="preserve">[27]  </a:t>
-            </a:r>
-            <a:r>
-              <a:rPr lang="en-US" sz="900" dirty="0">
-                <a:solidFill>
-                  <a:srgbClr val="000000"/>
-                </a:solidFill>
-                <a:latin typeface="Calibri" pitchFamily="34" charset="0"/>
-                <a:ea typeface="Calibri" pitchFamily="34" charset="-122"/>
-                <a:cs typeface="Calibri" pitchFamily="34" charset="-120"/>
-              </a:rPr>
-              <a:t xml:space="preserve">J. Tan, Z. Zhou and G. Zou, “A Programmable Gate Driver Module-Based Multistage Voltage Regulation SiC MOSFET Switching Strategy,” Electronics, vol. 13, no. 22, pp. 4379, 2024.</a:t>
-            </a:r>
-          </a:p>
-          <a:p>
-            <a:pPr marL="177800" indent="0">
-              <a:spcAft>
-                <a:spcPts val="60"/>
-              </a:spcAft>
-              <a:buSzPct val="100000"/>
-              <a:buNone/>
-            </a:pPr>
-            <a:r>
-              <a:rPr lang="en-US" sz="900" b="1" dirty="0">
-                <a:solidFill>
-                  <a:srgbClr val="000000"/>
-                </a:solidFill>
-                <a:latin typeface="Calibri" pitchFamily="34" charset="0"/>
-                <a:ea typeface="Calibri" pitchFamily="34" charset="-122"/>
-                <a:cs typeface="Calibri" pitchFamily="34" charset="-120"/>
-              </a:rPr>
-              <a:t xml:space="preserve">[28]  </a:t>
-            </a:r>
-            <a:r>
-              <a:rPr lang="en-US" sz="900" dirty="0">
-                <a:solidFill>
-                  <a:srgbClr val="000000"/>
-                </a:solidFill>
-                <a:latin typeface="Calibri" pitchFamily="34" charset="0"/>
-                <a:ea typeface="Calibri" pitchFamily="34" charset="-122"/>
-                <a:cs typeface="Calibri" pitchFamily="34" charset="-120"/>
-              </a:rPr>
-              <a:t xml:space="preserve">C. Chen, P. Wang, S. Li, Y. Chen and Y. Chang, “An Integrated Driver With Bang-Bang Dead-Time Control and Charge Sharing Bootstrap Circuit for GaN Synchronous Buck Converter,” IEEE Trans. Power Electron., vol. 37, no. 8, pp. 9503–9514, 2022.</a:t>
-            </a:r>
-          </a:p>
-          <a:p>
-            <a:pPr marL="177800" indent="0">
-              <a:spcAft>
-                <a:spcPts val="60"/>
-              </a:spcAft>
-              <a:buSzPct val="100000"/>
-              <a:buNone/>
-            </a:pPr>
-            <a:r>
-              <a:rPr lang="en-US" sz="900" b="1" dirty="0">
-                <a:solidFill>
-                  <a:srgbClr val="000000"/>
-                </a:solidFill>
-                <a:latin typeface="Calibri" pitchFamily="34" charset="0"/>
-                <a:ea typeface="Calibri" pitchFamily="34" charset="-122"/>
-                <a:cs typeface="Calibri" pitchFamily="34" charset="-120"/>
-              </a:rPr>
-              <a:t xml:space="preserve">[29]  </a:t>
-            </a:r>
-            <a:r>
-              <a:rPr lang="en-US" sz="900" dirty="0">
-                <a:solidFill>
-                  <a:srgbClr val="000000"/>
-                </a:solidFill>
-                <a:latin typeface="Calibri" pitchFamily="34" charset="0"/>
-                <a:ea typeface="Calibri" pitchFamily="34" charset="-122"/>
-                <a:cs typeface="Calibri" pitchFamily="34" charset="-120"/>
-              </a:rPr>
-              <a:t xml:space="preserve">G.H. Thuc, M. Tsai, C. Chen, J. Fu, W. Wu and W. Lin, “A Current Source Gate Driver with Dual-Edge Adaptive Slew Rate for GaN Devices,” in Proc. 2026 IEEE Applied Power Electronics Conference and Exposition (APEC), 2026.</a:t>
-            </a:r>
-          </a:p>
-          <a:p>
-            <a:pPr marL="177800" indent="0">
-              <a:spcAft>
-                <a:spcPts val="60"/>
-              </a:spcAft>
-              <a:buSzPct val="100000"/>
-              <a:buNone/>
-            </a:pPr>
-            <a:r>
-              <a:rPr lang="en-US" sz="900" b="1" dirty="0">
-                <a:solidFill>
-                  <a:srgbClr val="000000"/>
-                </a:solidFill>
-                <a:latin typeface="Calibri" pitchFamily="34" charset="0"/>
-                <a:ea typeface="Calibri" pitchFamily="34" charset="-122"/>
-                <a:cs typeface="Calibri" pitchFamily="34" charset="-120"/>
-              </a:rPr>
-              <a:t xml:space="preserve">[30]  </a:t>
-            </a:r>
-            <a:r>
-              <a:rPr lang="en-US" sz="900" dirty="0">
-                <a:solidFill>
-                  <a:srgbClr val="000000"/>
-                </a:solidFill>
-                <a:latin typeface="Calibri" pitchFamily="34" charset="0"/>
-                <a:ea typeface="Calibri" pitchFamily="34" charset="-122"/>
-                <a:cs typeface="Calibri" pitchFamily="34" charset="-120"/>
-              </a:rPr>
-              <a:t xml:space="preserve">G. Wu, Y. Huang, Y. Chen and C. Chen, “Closed-loop Slew Rate Control of Active Current Source Gate Driver with Digital Implementation for SiC MOSFET,” in Proc. 2025 IEEE Energy Conversion Conference Congress and Exposition (ECCE), 2025.</a:t>
-            </a:r>
-          </a:p>
-          <a:p>
-            <a:pPr marL="177800" indent="0">
-              <a:spcAft>
-                <a:spcPts val="160"/>
-              </a:spcAft>
-              <a:buSzPct val="100000"/>
-              <a:buNone/>
-            </a:pPr>
-            <a:r>
-              <a:rPr lang="en-US" sz="850" dirty="0">
-                <a:solidFill>
-                  <a:srgbClr val="000000"/>
-                </a:solidFill>
-                <a:latin typeface="Calibri" pitchFamily="34" charset="0"/>
-                <a:ea typeface="Calibri" pitchFamily="34" charset="-122"/>
-                <a:cs typeface="Calibri" pitchFamily="34" charset="-120"/>
-              </a:rPr>
-              <a:t xml:space="preserve">All 30 verified against the publisher record — authors, volume, issue and pages resolved through Crossref by DOI and title, not transcribed by hand.</a:t>
-            </a:r>
-          </a:p>
-        </p:txBody>
-      </p:sp>
-      <p:sp>
-        <p:nvSpPr>
-          <p:cNvPr id="6" name="Text 3"/>
-          <p:cNvSpPr txBox="1"/>
-          <p:nvPr/>
-        </p:nvSpPr>
-        <p:spPr>
-          <a:xfrm>
-            <a:off x="640080" y="5806440"/>
-            <a:ext cx="10881360" cy="365760"/>
-          </a:xfrm>
-          <a:prstGeom prst="rect">
-            <a:avLst/>
-          </a:prstGeom>
-          <a:noFill/>
-          <a:ln/>
-        </p:spPr>
-        <p:txBody>
-          <a:bodyPr wrap="square" lIns="0" tIns="0" rIns="0" bIns="0" rtlCol="0" anchor="ctr"/>
+            <a:ext cx="3474720" cy="274320"/>
+          </a:xfrm>
+          <a:prstGeom prst="rect">
+            <a:avLst/>
+          </a:prstGeom>
+          <a:noFill/>
+        </p:spPr>
+        <p:txBody>
+          <a:bodyPr wrap="square" lIns="0" tIns="0" rIns="0" bIns="0">
+            <a:spAutoFit/>
+          </a:bodyPr>
           <a:lstStyle/>
           <a:p>
             <a:pPr marL="177800" indent="0">
@@ -17457,6 +17603,221 @@
               <a:buNone/>
             </a:pPr>
             <a:r>
+              <a:rPr lang="en-US" sz="1150" b="1" dirty="0">
+                <a:solidFill>
+                  <a:srgbClr val="000000"/>
+                </a:solidFill>
+                <a:latin typeface="Calibri" pitchFamily="34" charset="0"/>
+                <a:ea typeface="Calibri" pitchFamily="34" charset="-122"/>
+                <a:cs typeface="Calibri" pitchFamily="34" charset="-120"/>
+              </a:rPr>
+              <a:t xml:space="preserve">Perturbation</a:t>
+            </a:r>
+          </a:p>
+        </p:txBody>
+      </p:sp>
+      <p:sp>
+        <p:nvSpPr>
+          <p:cNvPr id="6" name="TextBox 5"/>
+          <p:cNvSpPr txBox="1"/>
+          <p:nvPr/>
+        </p:nvSpPr>
+        <p:spPr>
+          <a:xfrm>
+            <a:off x="4160520" y="1325880"/>
+            <a:ext cx="1005840" cy="274320"/>
+          </a:xfrm>
+          <a:prstGeom prst="rect">
+            <a:avLst/>
+          </a:prstGeom>
+          <a:noFill/>
+        </p:spPr>
+        <p:txBody>
+          <a:bodyPr wrap="square" lIns="0" tIns="0" rIns="0" bIns="0">
+            <a:spAutoFit/>
+          </a:bodyPr>
+          <a:lstStyle/>
+          <a:p>
+            <a:pPr marL="177800" indent="0">
+              <a:spcAft>
+                <a:spcPts val="0"/>
+              </a:spcAft>
+              <a:buSzPct val="100000"/>
+              <a:buNone/>
+            </a:pPr>
+            <a:r>
+              <a:rPr lang="en-US" sz="1150" b="1" dirty="0">
+                <a:solidFill>
+                  <a:srgbClr val="000000"/>
+                </a:solidFill>
+                <a:latin typeface="Calibri" pitchFamily="34" charset="0"/>
+                <a:ea typeface="Calibri" pitchFamily="34" charset="-122"/>
+                <a:cs typeface="Calibri" pitchFamily="34" charset="-120"/>
+              </a:rPr>
+              <a:t xml:space="preserve">Ceiling</a:t>
+            </a:r>
+          </a:p>
+        </p:txBody>
+      </p:sp>
+      <p:sp>
+        <p:nvSpPr>
+          <p:cNvPr id="7" name="TextBox 6"/>
+          <p:cNvSpPr txBox="1"/>
+          <p:nvPr/>
+        </p:nvSpPr>
+        <p:spPr>
+          <a:xfrm>
+            <a:off x="5257800" y="1325880"/>
+            <a:ext cx="1097280" cy="274320"/>
+          </a:xfrm>
+          <a:prstGeom prst="rect">
+            <a:avLst/>
+          </a:prstGeom>
+          <a:noFill/>
+        </p:spPr>
+        <p:txBody>
+          <a:bodyPr wrap="square" lIns="0" tIns="0" rIns="0" bIns="0">
+            <a:spAutoFit/>
+          </a:bodyPr>
+          <a:lstStyle/>
+          <a:p>
+            <a:pPr marL="177800" indent="0">
+              <a:spcAft>
+                <a:spcPts val="0"/>
+              </a:spcAft>
+              <a:buSzPct val="100000"/>
+              <a:buNone/>
+            </a:pPr>
+            <a:r>
+              <a:rPr lang="en-US" sz="1150" dirty="0">
+                <a:solidFill>
+                  <a:srgbClr val="000000"/>
+                </a:solidFill>
+                <a:latin typeface="Calibri" pitchFamily="34" charset="0"/>
+                <a:ea typeface="Calibri" pitchFamily="34" charset="-122"/>
+                <a:cs typeface="Calibri" pitchFamily="34" charset="-120"/>
+              </a:rPr>
+              <a:t xml:space="preserve">vs nom.</a:t>
+            </a:r>
+          </a:p>
+        </p:txBody>
+      </p:sp>
+      <p:sp>
+        <p:nvSpPr>
+          <p:cNvPr id="8" name="TextBox 7"/>
+          <p:cNvSpPr txBox="1"/>
+          <p:nvPr/>
+        </p:nvSpPr>
+        <p:spPr>
+          <a:xfrm>
+            <a:off x="640080" y="1719072"/>
+            <a:ext cx="3474720" cy="274320"/>
+          </a:xfrm>
+          <a:prstGeom prst="rect">
+            <a:avLst/>
+          </a:prstGeom>
+          <a:noFill/>
+        </p:spPr>
+        <p:txBody>
+          <a:bodyPr wrap="square" lIns="0" tIns="0" rIns="0" bIns="0">
+            <a:spAutoFit/>
+          </a:bodyPr>
+          <a:lstStyle/>
+          <a:p>
+            <a:pPr marL="177800" indent="0">
+              <a:spcAft>
+                <a:spcPts val="0"/>
+              </a:spcAft>
+              <a:buSzPct val="100000"/>
+              <a:buNone/>
+            </a:pPr>
+            <a:r>
+              <a:rPr lang="en-US" sz="1200" b="1" dirty="0">
+                <a:solidFill>
+                  <a:srgbClr val="000000"/>
+                </a:solidFill>
+                <a:latin typeface="Calibri" pitchFamily="34" charset="0"/>
+                <a:ea typeface="Calibri" pitchFamily="34" charset="-122"/>
+                <a:cs typeface="Calibri" pitchFamily="34" charset="-120"/>
+              </a:rPr>
+              <a:t xml:space="preserve">Loop inductance −50 %  (1.5 nH)</a:t>
+            </a:r>
+          </a:p>
+        </p:txBody>
+      </p:sp>
+      <p:sp>
+        <p:nvSpPr>
+          <p:cNvPr id="9" name="TextBox 8"/>
+          <p:cNvSpPr txBox="1"/>
+          <p:nvPr/>
+        </p:nvSpPr>
+        <p:spPr>
+          <a:xfrm>
+            <a:off x="4160520" y="1719072"/>
+            <a:ext cx="1005840" cy="274320"/>
+          </a:xfrm>
+          <a:prstGeom prst="rect">
+            <a:avLst/>
+          </a:prstGeom>
+          <a:noFill/>
+        </p:spPr>
+        <p:txBody>
+          <a:bodyPr wrap="square" lIns="0" tIns="0" rIns="0" bIns="0">
+            <a:spAutoFit/>
+          </a:bodyPr>
+          <a:lstStyle/>
+          <a:p>
+            <a:pPr marL="177800" indent="0">
+              <a:spcAft>
+                <a:spcPts val="0"/>
+              </a:spcAft>
+              <a:buSzPct val="100000"/>
+              <a:buNone/>
+            </a:pPr>
+            <a:r>
+              <a:rPr lang="en-US" sz="1200" b="1" dirty="0">
+                <a:solidFill>
+                  <a:srgbClr val="000000"/>
+                </a:solidFill>
+                <a:latin typeface="Calibri" pitchFamily="34" charset="0"/>
+                <a:ea typeface="Calibri" pitchFamily="34" charset="-122"/>
+                <a:cs typeface="Calibri" pitchFamily="34" charset="-120"/>
+              </a:rPr>
+              <a:t xml:space="preserve">13.54 %</a:t>
+            </a:r>
+          </a:p>
+        </p:txBody>
+      </p:sp>
+      <p:sp>
+        <p:nvSpPr>
+          <p:cNvPr id="10" name="TextBox 9"/>
+          <p:cNvSpPr txBox="1"/>
+          <p:nvPr/>
+        </p:nvSpPr>
+        <p:spPr>
+          <a:xfrm>
+            <a:off x="5257800" y="1719072"/>
+            <a:ext cx="1097280" cy="274320"/>
+          </a:xfrm>
+          <a:prstGeom prst="rect">
+            <a:avLst/>
+          </a:prstGeom>
+          <a:noFill/>
+        </p:spPr>
+        <p:txBody>
+          <a:bodyPr wrap="square" lIns="0" tIns="0" rIns="0" bIns="0">
+            <a:spAutoFit/>
+          </a:bodyPr>
+          <a:lstStyle/>
+          <a:p>
+            <a:pPr marL="177800" indent="0">
+              <a:spcAft>
+                <a:spcPts val="0"/>
+              </a:spcAft>
+              <a:buSzPct val="100000"/>
+              <a:buNone/>
+            </a:pPr>
+            <a:r>
               <a:rPr lang="en-US" sz="1200" dirty="0">
                 <a:solidFill>
                   <a:srgbClr val="000000"/>
@@ -17465,7 +17826,1593 @@
                 <a:ea typeface="Calibri" pitchFamily="34" charset="-122"/>
                 <a:cs typeface="Calibri" pitchFamily="34" charset="-120"/>
               </a:rPr>
-              <a:t xml:space="preserve"/>
+              <a:t xml:space="preserve">+7.59</a:t>
+            </a:r>
+          </a:p>
+        </p:txBody>
+      </p:sp>
+      <p:sp>
+        <p:nvSpPr>
+          <p:cNvPr id="11" name="TextBox 10"/>
+          <p:cNvSpPr txBox="1"/>
+          <p:nvPr/>
+        </p:nvSpPr>
+        <p:spPr>
+          <a:xfrm>
+            <a:off x="640080" y="2025395"/>
+            <a:ext cx="3474720" cy="274320"/>
+          </a:xfrm>
+          <a:prstGeom prst="rect">
+            <a:avLst/>
+          </a:prstGeom>
+          <a:noFill/>
+        </p:spPr>
+        <p:txBody>
+          <a:bodyPr wrap="square" lIns="0" tIns="0" rIns="0" bIns="0">
+            <a:spAutoFit/>
+          </a:bodyPr>
+          <a:lstStyle/>
+          <a:p>
+            <a:pPr marL="177800" indent="0">
+              <a:spcAft>
+                <a:spcPts val="0"/>
+              </a:spcAft>
+              <a:buSzPct val="100000"/>
+              <a:buNone/>
+            </a:pPr>
+            <a:r>
+              <a:rPr lang="en-US" sz="1200" dirty="0">
+                <a:solidFill>
+                  <a:srgbClr val="000000"/>
+                </a:solidFill>
+                <a:latin typeface="Calibri" pitchFamily="34" charset="0"/>
+                <a:ea typeface="Calibri" pitchFamily="34" charset="-122"/>
+                <a:cs typeface="Calibri" pitchFamily="34" charset="-120"/>
+              </a:rPr>
+              <a:t xml:space="preserve">Input capacitance +30 %</a:t>
+            </a:r>
+          </a:p>
+        </p:txBody>
+      </p:sp>
+      <p:sp>
+        <p:nvSpPr>
+          <p:cNvPr id="12" name="TextBox 11"/>
+          <p:cNvSpPr txBox="1"/>
+          <p:nvPr/>
+        </p:nvSpPr>
+        <p:spPr>
+          <a:xfrm>
+            <a:off x="4160520" y="2025395"/>
+            <a:ext cx="1005840" cy="274320"/>
+          </a:xfrm>
+          <a:prstGeom prst="rect">
+            <a:avLst/>
+          </a:prstGeom>
+          <a:noFill/>
+        </p:spPr>
+        <p:txBody>
+          <a:bodyPr wrap="square" lIns="0" tIns="0" rIns="0" bIns="0">
+            <a:spAutoFit/>
+          </a:bodyPr>
+          <a:lstStyle/>
+          <a:p>
+            <a:pPr marL="177800" indent="0">
+              <a:spcAft>
+                <a:spcPts val="0"/>
+              </a:spcAft>
+              <a:buSzPct val="100000"/>
+              <a:buNone/>
+            </a:pPr>
+            <a:r>
+              <a:rPr lang="en-US" sz="1200" dirty="0">
+                <a:solidFill>
+                  <a:srgbClr val="000000"/>
+                </a:solidFill>
+                <a:latin typeface="Calibri" pitchFamily="34" charset="0"/>
+                <a:ea typeface="Calibri" pitchFamily="34" charset="-122"/>
+                <a:cs typeface="Calibri" pitchFamily="34" charset="-120"/>
+              </a:rPr>
+              <a:t xml:space="preserve">7.71 %</a:t>
+            </a:r>
+          </a:p>
+        </p:txBody>
+      </p:sp>
+      <p:sp>
+        <p:nvSpPr>
+          <p:cNvPr id="13" name="TextBox 12"/>
+          <p:cNvSpPr txBox="1"/>
+          <p:nvPr/>
+        </p:nvSpPr>
+        <p:spPr>
+          <a:xfrm>
+            <a:off x="5257800" y="2025395"/>
+            <a:ext cx="1097280" cy="274320"/>
+          </a:xfrm>
+          <a:prstGeom prst="rect">
+            <a:avLst/>
+          </a:prstGeom>
+          <a:noFill/>
+        </p:spPr>
+        <p:txBody>
+          <a:bodyPr wrap="square" lIns="0" tIns="0" rIns="0" bIns="0">
+            <a:spAutoFit/>
+          </a:bodyPr>
+          <a:lstStyle/>
+          <a:p>
+            <a:pPr marL="177800" indent="0">
+              <a:spcAft>
+                <a:spcPts val="0"/>
+              </a:spcAft>
+              <a:buSzPct val="100000"/>
+              <a:buNone/>
+            </a:pPr>
+            <a:r>
+              <a:rPr lang="en-US" sz="1200" dirty="0">
+                <a:solidFill>
+                  <a:srgbClr val="000000"/>
+                </a:solidFill>
+                <a:latin typeface="Calibri" pitchFamily="34" charset="0"/>
+                <a:ea typeface="Calibri" pitchFamily="34" charset="-122"/>
+                <a:cs typeface="Calibri" pitchFamily="34" charset="-120"/>
+              </a:rPr>
+              <a:t xml:space="preserve">+1.76</a:t>
+            </a:r>
+          </a:p>
+        </p:txBody>
+      </p:sp>
+      <p:sp>
+        <p:nvSpPr>
+          <p:cNvPr id="14" name="TextBox 13"/>
+          <p:cNvSpPr txBox="1"/>
+          <p:nvPr/>
+        </p:nvSpPr>
+        <p:spPr>
+          <a:xfrm>
+            <a:off x="640080" y="2331720"/>
+            <a:ext cx="3474720" cy="274320"/>
+          </a:xfrm>
+          <a:prstGeom prst="rect">
+            <a:avLst/>
+          </a:prstGeom>
+          <a:noFill/>
+        </p:spPr>
+        <p:txBody>
+          <a:bodyPr wrap="square" lIns="0" tIns="0" rIns="0" bIns="0">
+            <a:spAutoFit/>
+          </a:bodyPr>
+          <a:lstStyle/>
+          <a:p>
+            <a:pPr marL="177800" indent="0">
+              <a:spcAft>
+                <a:spcPts val="0"/>
+              </a:spcAft>
+              <a:buSzPct val="100000"/>
+              <a:buNone/>
+            </a:pPr>
+            <a:r>
+              <a:rPr lang="en-US" sz="1200" dirty="0">
+                <a:solidFill>
+                  <a:srgbClr val="000000"/>
+                </a:solidFill>
+                <a:latin typeface="Calibri" pitchFamily="34" charset="0"/>
+                <a:ea typeface="Calibri" pitchFamily="34" charset="-122"/>
+                <a:cs typeface="Calibri" pitchFamily="34" charset="-120"/>
+              </a:rPr>
+              <a:t xml:space="preserve">Miller capacitance −50 %</a:t>
+            </a:r>
+          </a:p>
+        </p:txBody>
+      </p:sp>
+      <p:sp>
+        <p:nvSpPr>
+          <p:cNvPr id="15" name="TextBox 14"/>
+          <p:cNvSpPr txBox="1"/>
+          <p:nvPr/>
+        </p:nvSpPr>
+        <p:spPr>
+          <a:xfrm>
+            <a:off x="4160520" y="2331720"/>
+            <a:ext cx="1005840" cy="274320"/>
+          </a:xfrm>
+          <a:prstGeom prst="rect">
+            <a:avLst/>
+          </a:prstGeom>
+          <a:noFill/>
+        </p:spPr>
+        <p:txBody>
+          <a:bodyPr wrap="square" lIns="0" tIns="0" rIns="0" bIns="0">
+            <a:spAutoFit/>
+          </a:bodyPr>
+          <a:lstStyle/>
+          <a:p>
+            <a:pPr marL="177800" indent="0">
+              <a:spcAft>
+                <a:spcPts val="0"/>
+              </a:spcAft>
+              <a:buSzPct val="100000"/>
+              <a:buNone/>
+            </a:pPr>
+            <a:r>
+              <a:rPr lang="en-US" sz="1200" dirty="0">
+                <a:solidFill>
+                  <a:srgbClr val="000000"/>
+                </a:solidFill>
+                <a:latin typeface="Calibri" pitchFamily="34" charset="0"/>
+                <a:ea typeface="Calibri" pitchFamily="34" charset="-122"/>
+                <a:cs typeface="Calibri" pitchFamily="34" charset="-120"/>
+              </a:rPr>
+              <a:t xml:space="preserve">6.93 %</a:t>
+            </a:r>
+          </a:p>
+        </p:txBody>
+      </p:sp>
+      <p:sp>
+        <p:nvSpPr>
+          <p:cNvPr id="16" name="TextBox 15"/>
+          <p:cNvSpPr txBox="1"/>
+          <p:nvPr/>
+        </p:nvSpPr>
+        <p:spPr>
+          <a:xfrm>
+            <a:off x="5257800" y="2331720"/>
+            <a:ext cx="1097280" cy="274320"/>
+          </a:xfrm>
+          <a:prstGeom prst="rect">
+            <a:avLst/>
+          </a:prstGeom>
+          <a:noFill/>
+        </p:spPr>
+        <p:txBody>
+          <a:bodyPr wrap="square" lIns="0" tIns="0" rIns="0" bIns="0">
+            <a:spAutoFit/>
+          </a:bodyPr>
+          <a:lstStyle/>
+          <a:p>
+            <a:pPr marL="177800" indent="0">
+              <a:spcAft>
+                <a:spcPts val="0"/>
+              </a:spcAft>
+              <a:buSzPct val="100000"/>
+              <a:buNone/>
+            </a:pPr>
+            <a:r>
+              <a:rPr lang="en-US" sz="1200" dirty="0">
+                <a:solidFill>
+                  <a:srgbClr val="000000"/>
+                </a:solidFill>
+                <a:latin typeface="Calibri" pitchFamily="34" charset="0"/>
+                <a:ea typeface="Calibri" pitchFamily="34" charset="-122"/>
+                <a:cs typeface="Calibri" pitchFamily="34" charset="-120"/>
+              </a:rPr>
+              <a:t xml:space="preserve">+0.99</a:t>
+            </a:r>
+          </a:p>
+        </p:txBody>
+      </p:sp>
+      <p:sp>
+        <p:nvSpPr>
+          <p:cNvPr id="17" name="TextBox 16"/>
+          <p:cNvSpPr txBox="1"/>
+          <p:nvPr/>
+        </p:nvSpPr>
+        <p:spPr>
+          <a:xfrm>
+            <a:off x="640080" y="2638044"/>
+            <a:ext cx="3474720" cy="274320"/>
+          </a:xfrm>
+          <a:prstGeom prst="rect">
+            <a:avLst/>
+          </a:prstGeom>
+          <a:noFill/>
+        </p:spPr>
+        <p:txBody>
+          <a:bodyPr wrap="square" lIns="0" tIns="0" rIns="0" bIns="0">
+            <a:spAutoFit/>
+          </a:bodyPr>
+          <a:lstStyle/>
+          <a:p>
+            <a:pPr marL="177800" indent="0">
+              <a:spcAft>
+                <a:spcPts val="0"/>
+              </a:spcAft>
+              <a:buSzPct val="100000"/>
+              <a:buNone/>
+            </a:pPr>
+            <a:r>
+              <a:rPr lang="en-US" sz="1200" b="1" dirty="0">
+                <a:solidFill>
+                  <a:srgbClr val="000000"/>
+                </a:solidFill>
+                <a:latin typeface="Calibri" pitchFamily="34" charset="0"/>
+                <a:ea typeface="Calibri" pitchFamily="34" charset="-122"/>
+                <a:cs typeface="Calibri" pitchFamily="34" charset="-120"/>
+              </a:rPr>
+              <a:t xml:space="preserve">nominal</a:t>
+            </a:r>
+          </a:p>
+        </p:txBody>
+      </p:sp>
+      <p:sp>
+        <p:nvSpPr>
+          <p:cNvPr id="18" name="TextBox 17"/>
+          <p:cNvSpPr txBox="1"/>
+          <p:nvPr/>
+        </p:nvSpPr>
+        <p:spPr>
+          <a:xfrm>
+            <a:off x="4160520" y="2638044"/>
+            <a:ext cx="1005840" cy="274320"/>
+          </a:xfrm>
+          <a:prstGeom prst="rect">
+            <a:avLst/>
+          </a:prstGeom>
+          <a:noFill/>
+        </p:spPr>
+        <p:txBody>
+          <a:bodyPr wrap="square" lIns="0" tIns="0" rIns="0" bIns="0">
+            <a:spAutoFit/>
+          </a:bodyPr>
+          <a:lstStyle/>
+          <a:p>
+            <a:pPr marL="177800" indent="0">
+              <a:spcAft>
+                <a:spcPts val="0"/>
+              </a:spcAft>
+              <a:buSzPct val="100000"/>
+              <a:buNone/>
+            </a:pPr>
+            <a:r>
+              <a:rPr lang="en-US" sz="1200" b="1" dirty="0">
+                <a:solidFill>
+                  <a:srgbClr val="000000"/>
+                </a:solidFill>
+                <a:latin typeface="Calibri" pitchFamily="34" charset="0"/>
+                <a:ea typeface="Calibri" pitchFamily="34" charset="-122"/>
+                <a:cs typeface="Calibri" pitchFamily="34" charset="-120"/>
+              </a:rPr>
+              <a:t xml:space="preserve">5.95 %</a:t>
+            </a:r>
+          </a:p>
+        </p:txBody>
+      </p:sp>
+      <p:sp>
+        <p:nvSpPr>
+          <p:cNvPr id="19" name="TextBox 18"/>
+          <p:cNvSpPr txBox="1"/>
+          <p:nvPr/>
+        </p:nvSpPr>
+        <p:spPr>
+          <a:xfrm>
+            <a:off x="5257800" y="2638044"/>
+            <a:ext cx="1097280" cy="274320"/>
+          </a:xfrm>
+          <a:prstGeom prst="rect">
+            <a:avLst/>
+          </a:prstGeom>
+          <a:noFill/>
+        </p:spPr>
+        <p:txBody>
+          <a:bodyPr wrap="square" lIns="0" tIns="0" rIns="0" bIns="0">
+            <a:spAutoFit/>
+          </a:bodyPr>
+          <a:lstStyle/>
+          <a:p>
+            <a:pPr marL="177800" indent="0">
+              <a:spcAft>
+                <a:spcPts val="0"/>
+              </a:spcAft>
+              <a:buSzPct val="100000"/>
+              <a:buNone/>
+            </a:pPr>
+            <a:r>
+              <a:rPr lang="en-US" sz="1200" dirty="0">
+                <a:solidFill>
+                  <a:srgbClr val="000000"/>
+                </a:solidFill>
+                <a:latin typeface="Calibri" pitchFamily="34" charset="0"/>
+                <a:ea typeface="Calibri" pitchFamily="34" charset="-122"/>
+                <a:cs typeface="Calibri" pitchFamily="34" charset="-120"/>
+              </a:rPr>
+              <a:t xml:space="preserve">—</a:t>
+            </a:r>
+          </a:p>
+        </p:txBody>
+      </p:sp>
+      <p:sp>
+        <p:nvSpPr>
+          <p:cNvPr id="20" name="TextBox 19"/>
+          <p:cNvSpPr txBox="1"/>
+          <p:nvPr/>
+        </p:nvSpPr>
+        <p:spPr>
+          <a:xfrm>
+            <a:off x="640080" y="2944368"/>
+            <a:ext cx="3474720" cy="274320"/>
+          </a:xfrm>
+          <a:prstGeom prst="rect">
+            <a:avLst/>
+          </a:prstGeom>
+          <a:noFill/>
+        </p:spPr>
+        <p:txBody>
+          <a:bodyPr wrap="square" lIns="0" tIns="0" rIns="0" bIns="0">
+            <a:spAutoFit/>
+          </a:bodyPr>
+          <a:lstStyle/>
+          <a:p>
+            <a:pPr marL="177800" indent="0">
+              <a:spcAft>
+                <a:spcPts val="0"/>
+              </a:spcAft>
+              <a:buSzPct val="100000"/>
+              <a:buNone/>
+            </a:pPr>
+            <a:r>
+              <a:rPr lang="en-US" sz="1200" dirty="0">
+                <a:solidFill>
+                  <a:srgbClr val="000000"/>
+                </a:solidFill>
+                <a:latin typeface="Calibri" pitchFamily="34" charset="0"/>
+                <a:ea typeface="Calibri" pitchFamily="34" charset="-122"/>
+                <a:cs typeface="Calibri" pitchFamily="34" charset="-120"/>
+              </a:rPr>
+              <a:t xml:space="preserve">Threshold −20 %</a:t>
+            </a:r>
+          </a:p>
+        </p:txBody>
+      </p:sp>
+      <p:sp>
+        <p:nvSpPr>
+          <p:cNvPr id="21" name="TextBox 20"/>
+          <p:cNvSpPr txBox="1"/>
+          <p:nvPr/>
+        </p:nvSpPr>
+        <p:spPr>
+          <a:xfrm>
+            <a:off x="4160520" y="2944368"/>
+            <a:ext cx="1005840" cy="274320"/>
+          </a:xfrm>
+          <a:prstGeom prst="rect">
+            <a:avLst/>
+          </a:prstGeom>
+          <a:noFill/>
+        </p:spPr>
+        <p:txBody>
+          <a:bodyPr wrap="square" lIns="0" tIns="0" rIns="0" bIns="0">
+            <a:spAutoFit/>
+          </a:bodyPr>
+          <a:lstStyle/>
+          <a:p>
+            <a:pPr marL="177800" indent="0">
+              <a:spcAft>
+                <a:spcPts val="0"/>
+              </a:spcAft>
+              <a:buSzPct val="100000"/>
+              <a:buNone/>
+            </a:pPr>
+            <a:r>
+              <a:rPr lang="en-US" sz="1200" dirty="0">
+                <a:solidFill>
+                  <a:srgbClr val="000000"/>
+                </a:solidFill>
+                <a:latin typeface="Calibri" pitchFamily="34" charset="0"/>
+                <a:ea typeface="Calibri" pitchFamily="34" charset="-122"/>
+                <a:cs typeface="Calibri" pitchFamily="34" charset="-120"/>
+              </a:rPr>
+              <a:t xml:space="preserve">5.64 %</a:t>
+            </a:r>
+          </a:p>
+        </p:txBody>
+      </p:sp>
+      <p:sp>
+        <p:nvSpPr>
+          <p:cNvPr id="22" name="TextBox 21"/>
+          <p:cNvSpPr txBox="1"/>
+          <p:nvPr/>
+        </p:nvSpPr>
+        <p:spPr>
+          <a:xfrm>
+            <a:off x="5257800" y="2944368"/>
+            <a:ext cx="1097280" cy="274320"/>
+          </a:xfrm>
+          <a:prstGeom prst="rect">
+            <a:avLst/>
+          </a:prstGeom>
+          <a:noFill/>
+        </p:spPr>
+        <p:txBody>
+          <a:bodyPr wrap="square" lIns="0" tIns="0" rIns="0" bIns="0">
+            <a:spAutoFit/>
+          </a:bodyPr>
+          <a:lstStyle/>
+          <a:p>
+            <a:pPr marL="177800" indent="0">
+              <a:spcAft>
+                <a:spcPts val="0"/>
+              </a:spcAft>
+              <a:buSzPct val="100000"/>
+              <a:buNone/>
+            </a:pPr>
+            <a:r>
+              <a:rPr lang="en-US" sz="1200" dirty="0">
+                <a:solidFill>
+                  <a:srgbClr val="000000"/>
+                </a:solidFill>
+                <a:latin typeface="Calibri" pitchFamily="34" charset="0"/>
+                <a:ea typeface="Calibri" pitchFamily="34" charset="-122"/>
+                <a:cs typeface="Calibri" pitchFamily="34" charset="-120"/>
+              </a:rPr>
+              <a:t xml:space="preserve">−0.31</a:t>
+            </a:r>
+          </a:p>
+        </p:txBody>
+      </p:sp>
+      <p:sp>
+        <p:nvSpPr>
+          <p:cNvPr id="23" name="TextBox 22"/>
+          <p:cNvSpPr txBox="1"/>
+          <p:nvPr/>
+        </p:nvSpPr>
+        <p:spPr>
+          <a:xfrm>
+            <a:off x="640080" y="3250691"/>
+            <a:ext cx="3474720" cy="274320"/>
+          </a:xfrm>
+          <a:prstGeom prst="rect">
+            <a:avLst/>
+          </a:prstGeom>
+          <a:noFill/>
+        </p:spPr>
+        <p:txBody>
+          <a:bodyPr wrap="square" lIns="0" tIns="0" rIns="0" bIns="0">
+            <a:spAutoFit/>
+          </a:bodyPr>
+          <a:lstStyle/>
+          <a:p>
+            <a:pPr marL="177800" indent="0">
+              <a:spcAft>
+                <a:spcPts val="0"/>
+              </a:spcAft>
+              <a:buSzPct val="100000"/>
+              <a:buNone/>
+            </a:pPr>
+            <a:r>
+              <a:rPr lang="en-US" sz="1200" dirty="0">
+                <a:solidFill>
+                  <a:srgbClr val="000000"/>
+                </a:solidFill>
+                <a:latin typeface="Calibri" pitchFamily="34" charset="0"/>
+                <a:ea typeface="Calibri" pitchFamily="34" charset="-122"/>
+                <a:cs typeface="Calibri" pitchFamily="34" charset="-120"/>
+              </a:rPr>
+              <a:t xml:space="preserve">Transconductance +30 %</a:t>
+            </a:r>
+          </a:p>
+        </p:txBody>
+      </p:sp>
+      <p:sp>
+        <p:nvSpPr>
+          <p:cNvPr id="24" name="TextBox 23"/>
+          <p:cNvSpPr txBox="1"/>
+          <p:nvPr/>
+        </p:nvSpPr>
+        <p:spPr>
+          <a:xfrm>
+            <a:off x="4160520" y="3250691"/>
+            <a:ext cx="1005840" cy="274320"/>
+          </a:xfrm>
+          <a:prstGeom prst="rect">
+            <a:avLst/>
+          </a:prstGeom>
+          <a:noFill/>
+        </p:spPr>
+        <p:txBody>
+          <a:bodyPr wrap="square" lIns="0" tIns="0" rIns="0" bIns="0">
+            <a:spAutoFit/>
+          </a:bodyPr>
+          <a:lstStyle/>
+          <a:p>
+            <a:pPr marL="177800" indent="0">
+              <a:spcAft>
+                <a:spcPts val="0"/>
+              </a:spcAft>
+              <a:buSzPct val="100000"/>
+              <a:buNone/>
+            </a:pPr>
+            <a:r>
+              <a:rPr lang="en-US" sz="1200" dirty="0">
+                <a:solidFill>
+                  <a:srgbClr val="000000"/>
+                </a:solidFill>
+                <a:latin typeface="Calibri" pitchFamily="34" charset="0"/>
+                <a:ea typeface="Calibri" pitchFamily="34" charset="-122"/>
+                <a:cs typeface="Calibri" pitchFamily="34" charset="-120"/>
+              </a:rPr>
+              <a:t xml:space="preserve">5.08 %</a:t>
+            </a:r>
+          </a:p>
+        </p:txBody>
+      </p:sp>
+      <p:sp>
+        <p:nvSpPr>
+          <p:cNvPr id="25" name="TextBox 24"/>
+          <p:cNvSpPr txBox="1"/>
+          <p:nvPr/>
+        </p:nvSpPr>
+        <p:spPr>
+          <a:xfrm>
+            <a:off x="5257800" y="3250691"/>
+            <a:ext cx="1097280" cy="274320"/>
+          </a:xfrm>
+          <a:prstGeom prst="rect">
+            <a:avLst/>
+          </a:prstGeom>
+          <a:noFill/>
+        </p:spPr>
+        <p:txBody>
+          <a:bodyPr wrap="square" lIns="0" tIns="0" rIns="0" bIns="0">
+            <a:spAutoFit/>
+          </a:bodyPr>
+          <a:lstStyle/>
+          <a:p>
+            <a:pPr marL="177800" indent="0">
+              <a:spcAft>
+                <a:spcPts val="0"/>
+              </a:spcAft>
+              <a:buSzPct val="100000"/>
+              <a:buNone/>
+            </a:pPr>
+            <a:r>
+              <a:rPr lang="en-US" sz="1200" dirty="0">
+                <a:solidFill>
+                  <a:srgbClr val="000000"/>
+                </a:solidFill>
+                <a:latin typeface="Calibri" pitchFamily="34" charset="0"/>
+                <a:ea typeface="Calibri" pitchFamily="34" charset="-122"/>
+                <a:cs typeface="Calibri" pitchFamily="34" charset="-120"/>
+              </a:rPr>
+              <a:t xml:space="preserve">−0.87</a:t>
+            </a:r>
+          </a:p>
+        </p:txBody>
+      </p:sp>
+      <p:sp>
+        <p:nvSpPr>
+          <p:cNvPr id="26" name="TextBox 25"/>
+          <p:cNvSpPr txBox="1"/>
+          <p:nvPr/>
+        </p:nvSpPr>
+        <p:spPr>
+          <a:xfrm>
+            <a:off x="640080" y="3557015"/>
+            <a:ext cx="3474720" cy="274320"/>
+          </a:xfrm>
+          <a:prstGeom prst="rect">
+            <a:avLst/>
+          </a:prstGeom>
+          <a:noFill/>
+        </p:spPr>
+        <p:txBody>
+          <a:bodyPr wrap="square" lIns="0" tIns="0" rIns="0" bIns="0">
+            <a:spAutoFit/>
+          </a:bodyPr>
+          <a:lstStyle/>
+          <a:p>
+            <a:pPr marL="177800" indent="0">
+              <a:spcAft>
+                <a:spcPts val="0"/>
+              </a:spcAft>
+              <a:buSzPct val="100000"/>
+              <a:buNone/>
+            </a:pPr>
+            <a:r>
+              <a:rPr lang="en-US" sz="1200" dirty="0">
+                <a:solidFill>
+                  <a:srgbClr val="000000"/>
+                </a:solidFill>
+                <a:latin typeface="Calibri" pitchFamily="34" charset="0"/>
+                <a:ea typeface="Calibri" pitchFamily="34" charset="-122"/>
+                <a:cs typeface="Calibri" pitchFamily="34" charset="-120"/>
+              </a:rPr>
+              <a:t xml:space="preserve">Threshold +20 %</a:t>
+            </a:r>
+          </a:p>
+        </p:txBody>
+      </p:sp>
+      <p:sp>
+        <p:nvSpPr>
+          <p:cNvPr id="27" name="TextBox 26"/>
+          <p:cNvSpPr txBox="1"/>
+          <p:nvPr/>
+        </p:nvSpPr>
+        <p:spPr>
+          <a:xfrm>
+            <a:off x="4160520" y="3557015"/>
+            <a:ext cx="1005840" cy="274320"/>
+          </a:xfrm>
+          <a:prstGeom prst="rect">
+            <a:avLst/>
+          </a:prstGeom>
+          <a:noFill/>
+        </p:spPr>
+        <p:txBody>
+          <a:bodyPr wrap="square" lIns="0" tIns="0" rIns="0" bIns="0">
+            <a:spAutoFit/>
+          </a:bodyPr>
+          <a:lstStyle/>
+          <a:p>
+            <a:pPr marL="177800" indent="0">
+              <a:spcAft>
+                <a:spcPts val="0"/>
+              </a:spcAft>
+              <a:buSzPct val="100000"/>
+              <a:buNone/>
+            </a:pPr>
+            <a:r>
+              <a:rPr lang="en-US" sz="1200" dirty="0">
+                <a:solidFill>
+                  <a:srgbClr val="000000"/>
+                </a:solidFill>
+                <a:latin typeface="Calibri" pitchFamily="34" charset="0"/>
+                <a:ea typeface="Calibri" pitchFamily="34" charset="-122"/>
+                <a:cs typeface="Calibri" pitchFamily="34" charset="-120"/>
+              </a:rPr>
+              <a:t xml:space="preserve">4.90 %</a:t>
+            </a:r>
+          </a:p>
+        </p:txBody>
+      </p:sp>
+      <p:sp>
+        <p:nvSpPr>
+          <p:cNvPr id="28" name="TextBox 27"/>
+          <p:cNvSpPr txBox="1"/>
+          <p:nvPr/>
+        </p:nvSpPr>
+        <p:spPr>
+          <a:xfrm>
+            <a:off x="5257800" y="3557015"/>
+            <a:ext cx="1097280" cy="274320"/>
+          </a:xfrm>
+          <a:prstGeom prst="rect">
+            <a:avLst/>
+          </a:prstGeom>
+          <a:noFill/>
+        </p:spPr>
+        <p:txBody>
+          <a:bodyPr wrap="square" lIns="0" tIns="0" rIns="0" bIns="0">
+            <a:spAutoFit/>
+          </a:bodyPr>
+          <a:lstStyle/>
+          <a:p>
+            <a:pPr marL="177800" indent="0">
+              <a:spcAft>
+                <a:spcPts val="0"/>
+              </a:spcAft>
+              <a:buSzPct val="100000"/>
+              <a:buNone/>
+            </a:pPr>
+            <a:r>
+              <a:rPr lang="en-US" sz="1200" dirty="0">
+                <a:solidFill>
+                  <a:srgbClr val="000000"/>
+                </a:solidFill>
+                <a:latin typeface="Calibri" pitchFamily="34" charset="0"/>
+                <a:ea typeface="Calibri" pitchFamily="34" charset="-122"/>
+                <a:cs typeface="Calibri" pitchFamily="34" charset="-120"/>
+              </a:rPr>
+              <a:t xml:space="preserve">−1.05</a:t>
+            </a:r>
+          </a:p>
+        </p:txBody>
+      </p:sp>
+      <p:sp>
+        <p:nvSpPr>
+          <p:cNvPr id="29" name="TextBox 28"/>
+          <p:cNvSpPr txBox="1"/>
+          <p:nvPr/>
+        </p:nvSpPr>
+        <p:spPr>
+          <a:xfrm>
+            <a:off x="640080" y="3863339"/>
+            <a:ext cx="3474720" cy="274320"/>
+          </a:xfrm>
+          <a:prstGeom prst="rect">
+            <a:avLst/>
+          </a:prstGeom>
+          <a:noFill/>
+        </p:spPr>
+        <p:txBody>
+          <a:bodyPr wrap="square" lIns="0" tIns="0" rIns="0" bIns="0">
+            <a:spAutoFit/>
+          </a:bodyPr>
+          <a:lstStyle/>
+          <a:p>
+            <a:pPr marL="177800" indent="0">
+              <a:spcAft>
+                <a:spcPts val="0"/>
+              </a:spcAft>
+              <a:buSzPct val="100000"/>
+              <a:buNone/>
+            </a:pPr>
+            <a:r>
+              <a:rPr lang="en-US" sz="1200" dirty="0">
+                <a:solidFill>
+                  <a:srgbClr val="000000"/>
+                </a:solidFill>
+                <a:latin typeface="Calibri" pitchFamily="34" charset="0"/>
+                <a:ea typeface="Calibri" pitchFamily="34" charset="-122"/>
+                <a:cs typeface="Calibri" pitchFamily="34" charset="-120"/>
+              </a:rPr>
+              <a:t xml:space="preserve">Input capacitance −30 %</a:t>
+            </a:r>
+          </a:p>
+        </p:txBody>
+      </p:sp>
+      <p:sp>
+        <p:nvSpPr>
+          <p:cNvPr id="30" name="TextBox 29"/>
+          <p:cNvSpPr txBox="1"/>
+          <p:nvPr/>
+        </p:nvSpPr>
+        <p:spPr>
+          <a:xfrm>
+            <a:off x="4160520" y="3863339"/>
+            <a:ext cx="1005840" cy="274320"/>
+          </a:xfrm>
+          <a:prstGeom prst="rect">
+            <a:avLst/>
+          </a:prstGeom>
+          <a:noFill/>
+        </p:spPr>
+        <p:txBody>
+          <a:bodyPr wrap="square" lIns="0" tIns="0" rIns="0" bIns="0">
+            <a:spAutoFit/>
+          </a:bodyPr>
+          <a:lstStyle/>
+          <a:p>
+            <a:pPr marL="177800" indent="0">
+              <a:spcAft>
+                <a:spcPts val="0"/>
+              </a:spcAft>
+              <a:buSzPct val="100000"/>
+              <a:buNone/>
+            </a:pPr>
+            <a:r>
+              <a:rPr lang="en-US" sz="1200" dirty="0">
+                <a:solidFill>
+                  <a:srgbClr val="000000"/>
+                </a:solidFill>
+                <a:latin typeface="Calibri" pitchFamily="34" charset="0"/>
+                <a:ea typeface="Calibri" pitchFamily="34" charset="-122"/>
+                <a:cs typeface="Calibri" pitchFamily="34" charset="-120"/>
+              </a:rPr>
+              <a:t xml:space="preserve">4.76 %</a:t>
+            </a:r>
+          </a:p>
+        </p:txBody>
+      </p:sp>
+      <p:sp>
+        <p:nvSpPr>
+          <p:cNvPr id="31" name="TextBox 30"/>
+          <p:cNvSpPr txBox="1"/>
+          <p:nvPr/>
+        </p:nvSpPr>
+        <p:spPr>
+          <a:xfrm>
+            <a:off x="5257800" y="3863339"/>
+            <a:ext cx="1097280" cy="274320"/>
+          </a:xfrm>
+          <a:prstGeom prst="rect">
+            <a:avLst/>
+          </a:prstGeom>
+          <a:noFill/>
+        </p:spPr>
+        <p:txBody>
+          <a:bodyPr wrap="square" lIns="0" tIns="0" rIns="0" bIns="0">
+            <a:spAutoFit/>
+          </a:bodyPr>
+          <a:lstStyle/>
+          <a:p>
+            <a:pPr marL="177800" indent="0">
+              <a:spcAft>
+                <a:spcPts val="0"/>
+              </a:spcAft>
+              <a:buSzPct val="100000"/>
+              <a:buNone/>
+            </a:pPr>
+            <a:r>
+              <a:rPr lang="en-US" sz="1200" dirty="0">
+                <a:solidFill>
+                  <a:srgbClr val="000000"/>
+                </a:solidFill>
+                <a:latin typeface="Calibri" pitchFamily="34" charset="0"/>
+                <a:ea typeface="Calibri" pitchFamily="34" charset="-122"/>
+                <a:cs typeface="Calibri" pitchFamily="34" charset="-120"/>
+              </a:rPr>
+              <a:t xml:space="preserve">−1.19</a:t>
+            </a:r>
+          </a:p>
+        </p:txBody>
+      </p:sp>
+      <p:sp>
+        <p:nvSpPr>
+          <p:cNvPr id="32" name="TextBox 31"/>
+          <p:cNvSpPr txBox="1"/>
+          <p:nvPr/>
+        </p:nvSpPr>
+        <p:spPr>
+          <a:xfrm>
+            <a:off x="640080" y="4169663"/>
+            <a:ext cx="3474720" cy="274320"/>
+          </a:xfrm>
+          <a:prstGeom prst="rect">
+            <a:avLst/>
+          </a:prstGeom>
+          <a:noFill/>
+        </p:spPr>
+        <p:txBody>
+          <a:bodyPr wrap="square" lIns="0" tIns="0" rIns="0" bIns="0">
+            <a:spAutoFit/>
+          </a:bodyPr>
+          <a:lstStyle/>
+          <a:p>
+            <a:pPr marL="177800" indent="0">
+              <a:spcAft>
+                <a:spcPts val="0"/>
+              </a:spcAft>
+              <a:buSzPct val="100000"/>
+              <a:buNone/>
+            </a:pPr>
+            <a:r>
+              <a:rPr lang="en-US" sz="1200" dirty="0">
+                <a:solidFill>
+                  <a:srgbClr val="000000"/>
+                </a:solidFill>
+                <a:latin typeface="Calibri" pitchFamily="34" charset="0"/>
+                <a:ea typeface="Calibri" pitchFamily="34" charset="-122"/>
+                <a:cs typeface="Calibri" pitchFamily="34" charset="-120"/>
+              </a:rPr>
+              <a:t xml:space="preserve">Transconductance −30 %</a:t>
+            </a:r>
+          </a:p>
+        </p:txBody>
+      </p:sp>
+      <p:sp>
+        <p:nvSpPr>
+          <p:cNvPr id="33" name="TextBox 32"/>
+          <p:cNvSpPr txBox="1"/>
+          <p:nvPr/>
+        </p:nvSpPr>
+        <p:spPr>
+          <a:xfrm>
+            <a:off x="4160520" y="4169663"/>
+            <a:ext cx="1005840" cy="274320"/>
+          </a:xfrm>
+          <a:prstGeom prst="rect">
+            <a:avLst/>
+          </a:prstGeom>
+          <a:noFill/>
+        </p:spPr>
+        <p:txBody>
+          <a:bodyPr wrap="square" lIns="0" tIns="0" rIns="0" bIns="0">
+            <a:spAutoFit/>
+          </a:bodyPr>
+          <a:lstStyle/>
+          <a:p>
+            <a:pPr marL="177800" indent="0">
+              <a:spcAft>
+                <a:spcPts val="0"/>
+              </a:spcAft>
+              <a:buSzPct val="100000"/>
+              <a:buNone/>
+            </a:pPr>
+            <a:r>
+              <a:rPr lang="en-US" sz="1200" dirty="0">
+                <a:solidFill>
+                  <a:srgbClr val="000000"/>
+                </a:solidFill>
+                <a:latin typeface="Calibri" pitchFamily="34" charset="0"/>
+                <a:ea typeface="Calibri" pitchFamily="34" charset="-122"/>
+                <a:cs typeface="Calibri" pitchFamily="34" charset="-120"/>
+              </a:rPr>
+              <a:t xml:space="preserve">4.45 %</a:t>
+            </a:r>
+          </a:p>
+        </p:txBody>
+      </p:sp>
+      <p:sp>
+        <p:nvSpPr>
+          <p:cNvPr id="34" name="TextBox 33"/>
+          <p:cNvSpPr txBox="1"/>
+          <p:nvPr/>
+        </p:nvSpPr>
+        <p:spPr>
+          <a:xfrm>
+            <a:off x="5257800" y="4169663"/>
+            <a:ext cx="1097280" cy="274320"/>
+          </a:xfrm>
+          <a:prstGeom prst="rect">
+            <a:avLst/>
+          </a:prstGeom>
+          <a:noFill/>
+        </p:spPr>
+        <p:txBody>
+          <a:bodyPr wrap="square" lIns="0" tIns="0" rIns="0" bIns="0">
+            <a:spAutoFit/>
+          </a:bodyPr>
+          <a:lstStyle/>
+          <a:p>
+            <a:pPr marL="177800" indent="0">
+              <a:spcAft>
+                <a:spcPts val="0"/>
+              </a:spcAft>
+              <a:buSzPct val="100000"/>
+              <a:buNone/>
+            </a:pPr>
+            <a:r>
+              <a:rPr lang="en-US" sz="1200" dirty="0">
+                <a:solidFill>
+                  <a:srgbClr val="000000"/>
+                </a:solidFill>
+                <a:latin typeface="Calibri" pitchFamily="34" charset="0"/>
+                <a:ea typeface="Calibri" pitchFamily="34" charset="-122"/>
+                <a:cs typeface="Calibri" pitchFamily="34" charset="-120"/>
+              </a:rPr>
+              <a:t xml:space="preserve">−1.49</a:t>
+            </a:r>
+          </a:p>
+        </p:txBody>
+      </p:sp>
+      <p:sp>
+        <p:nvSpPr>
+          <p:cNvPr id="35" name="TextBox 34"/>
+          <p:cNvSpPr txBox="1"/>
+          <p:nvPr/>
+        </p:nvSpPr>
+        <p:spPr>
+          <a:xfrm>
+            <a:off x="640080" y="4475988"/>
+            <a:ext cx="3474720" cy="274320"/>
+          </a:xfrm>
+          <a:prstGeom prst="rect">
+            <a:avLst/>
+          </a:prstGeom>
+          <a:noFill/>
+        </p:spPr>
+        <p:txBody>
+          <a:bodyPr wrap="square" lIns="0" tIns="0" rIns="0" bIns="0">
+            <a:spAutoFit/>
+          </a:bodyPr>
+          <a:lstStyle/>
+          <a:p>
+            <a:pPr marL="177800" indent="0">
+              <a:spcAft>
+                <a:spcPts val="0"/>
+              </a:spcAft>
+              <a:buSzPct val="100000"/>
+              <a:buNone/>
+            </a:pPr>
+            <a:r>
+              <a:rPr lang="en-US" sz="1200" dirty="0">
+                <a:solidFill>
+                  <a:srgbClr val="000000"/>
+                </a:solidFill>
+                <a:latin typeface="Calibri" pitchFamily="34" charset="0"/>
+                <a:ea typeface="Calibri" pitchFamily="34" charset="-122"/>
+                <a:cs typeface="Calibri" pitchFamily="34" charset="-120"/>
+              </a:rPr>
+              <a:t xml:space="preserve">Miller capacitance +50 %</a:t>
+            </a:r>
+          </a:p>
+        </p:txBody>
+      </p:sp>
+      <p:sp>
+        <p:nvSpPr>
+          <p:cNvPr id="36" name="TextBox 35"/>
+          <p:cNvSpPr txBox="1"/>
+          <p:nvPr/>
+        </p:nvSpPr>
+        <p:spPr>
+          <a:xfrm>
+            <a:off x="4160520" y="4475988"/>
+            <a:ext cx="1005840" cy="274320"/>
+          </a:xfrm>
+          <a:prstGeom prst="rect">
+            <a:avLst/>
+          </a:prstGeom>
+          <a:noFill/>
+        </p:spPr>
+        <p:txBody>
+          <a:bodyPr wrap="square" lIns="0" tIns="0" rIns="0" bIns="0">
+            <a:spAutoFit/>
+          </a:bodyPr>
+          <a:lstStyle/>
+          <a:p>
+            <a:pPr marL="177800" indent="0">
+              <a:spcAft>
+                <a:spcPts val="0"/>
+              </a:spcAft>
+              <a:buSzPct val="100000"/>
+              <a:buNone/>
+            </a:pPr>
+            <a:r>
+              <a:rPr lang="en-US" sz="1200" dirty="0">
+                <a:solidFill>
+                  <a:srgbClr val="000000"/>
+                </a:solidFill>
+                <a:latin typeface="Calibri" pitchFamily="34" charset="0"/>
+                <a:ea typeface="Calibri" pitchFamily="34" charset="-122"/>
+                <a:cs typeface="Calibri" pitchFamily="34" charset="-120"/>
+              </a:rPr>
+              <a:t xml:space="preserve">4.32 %</a:t>
+            </a:r>
+          </a:p>
+        </p:txBody>
+      </p:sp>
+      <p:sp>
+        <p:nvSpPr>
+          <p:cNvPr id="37" name="TextBox 36"/>
+          <p:cNvSpPr txBox="1"/>
+          <p:nvPr/>
+        </p:nvSpPr>
+        <p:spPr>
+          <a:xfrm>
+            <a:off x="5257800" y="4475988"/>
+            <a:ext cx="1097280" cy="274320"/>
+          </a:xfrm>
+          <a:prstGeom prst="rect">
+            <a:avLst/>
+          </a:prstGeom>
+          <a:noFill/>
+        </p:spPr>
+        <p:txBody>
+          <a:bodyPr wrap="square" lIns="0" tIns="0" rIns="0" bIns="0">
+            <a:spAutoFit/>
+          </a:bodyPr>
+          <a:lstStyle/>
+          <a:p>
+            <a:pPr marL="177800" indent="0">
+              <a:spcAft>
+                <a:spcPts val="0"/>
+              </a:spcAft>
+              <a:buSzPct val="100000"/>
+              <a:buNone/>
+            </a:pPr>
+            <a:r>
+              <a:rPr lang="en-US" sz="1200" dirty="0">
+                <a:solidFill>
+                  <a:srgbClr val="000000"/>
+                </a:solidFill>
+                <a:latin typeface="Calibri" pitchFamily="34" charset="0"/>
+                <a:ea typeface="Calibri" pitchFamily="34" charset="-122"/>
+                <a:cs typeface="Calibri" pitchFamily="34" charset="-120"/>
+              </a:rPr>
+              <a:t xml:space="preserve">−1.63</a:t>
+            </a:r>
+          </a:p>
+        </p:txBody>
+      </p:sp>
+      <p:sp>
+        <p:nvSpPr>
+          <p:cNvPr id="38" name="TextBox 37"/>
+          <p:cNvSpPr txBox="1"/>
+          <p:nvPr/>
+        </p:nvSpPr>
+        <p:spPr>
+          <a:xfrm>
+            <a:off x="640080" y="4782312"/>
+            <a:ext cx="3474720" cy="274320"/>
+          </a:xfrm>
+          <a:prstGeom prst="rect">
+            <a:avLst/>
+          </a:prstGeom>
+          <a:noFill/>
+        </p:spPr>
+        <p:txBody>
+          <a:bodyPr wrap="square" lIns="0" tIns="0" rIns="0" bIns="0">
+            <a:spAutoFit/>
+          </a:bodyPr>
+          <a:lstStyle/>
+          <a:p>
+            <a:pPr marL="177800" indent="0">
+              <a:spcAft>
+                <a:spcPts val="0"/>
+              </a:spcAft>
+              <a:buSzPct val="100000"/>
+              <a:buNone/>
+            </a:pPr>
+            <a:r>
+              <a:rPr lang="en-US" sz="1200" b="1" dirty="0">
+                <a:solidFill>
+                  <a:srgbClr val="000000"/>
+                </a:solidFill>
+                <a:latin typeface="Calibri" pitchFamily="34" charset="0"/>
+                <a:ea typeface="Calibri" pitchFamily="34" charset="-122"/>
+                <a:cs typeface="Calibri" pitchFamily="34" charset="-120"/>
+              </a:rPr>
+              <a:t xml:space="preserve">Loop inductance +50 %  (4.5 nH)</a:t>
+            </a:r>
+          </a:p>
+        </p:txBody>
+      </p:sp>
+      <p:sp>
+        <p:nvSpPr>
+          <p:cNvPr id="39" name="TextBox 38"/>
+          <p:cNvSpPr txBox="1"/>
+          <p:nvPr/>
+        </p:nvSpPr>
+        <p:spPr>
+          <a:xfrm>
+            <a:off x="4160520" y="4782312"/>
+            <a:ext cx="1005840" cy="274320"/>
+          </a:xfrm>
+          <a:prstGeom prst="rect">
+            <a:avLst/>
+          </a:prstGeom>
+          <a:noFill/>
+        </p:spPr>
+        <p:txBody>
+          <a:bodyPr wrap="square" lIns="0" tIns="0" rIns="0" bIns="0">
+            <a:spAutoFit/>
+          </a:bodyPr>
+          <a:lstStyle/>
+          <a:p>
+            <a:pPr marL="177800" indent="0">
+              <a:spcAft>
+                <a:spcPts val="0"/>
+              </a:spcAft>
+              <a:buSzPct val="100000"/>
+              <a:buNone/>
+            </a:pPr>
+            <a:r>
+              <a:rPr lang="en-US" sz="1200" b="1" dirty="0">
+                <a:solidFill>
+                  <a:srgbClr val="000000"/>
+                </a:solidFill>
+                <a:latin typeface="Calibri" pitchFamily="34" charset="0"/>
+                <a:ea typeface="Calibri" pitchFamily="34" charset="-122"/>
+                <a:cs typeface="Calibri" pitchFamily="34" charset="-120"/>
+              </a:rPr>
+              <a:t xml:space="preserve">0.55 %</a:t>
+            </a:r>
+          </a:p>
+        </p:txBody>
+      </p:sp>
+      <p:sp>
+        <p:nvSpPr>
+          <p:cNvPr id="40" name="TextBox 39"/>
+          <p:cNvSpPr txBox="1"/>
+          <p:nvPr/>
+        </p:nvSpPr>
+        <p:spPr>
+          <a:xfrm>
+            <a:off x="5257800" y="4782312"/>
+            <a:ext cx="1097280" cy="274320"/>
+          </a:xfrm>
+          <a:prstGeom prst="rect">
+            <a:avLst/>
+          </a:prstGeom>
+          <a:noFill/>
+        </p:spPr>
+        <p:txBody>
+          <a:bodyPr wrap="square" lIns="0" tIns="0" rIns="0" bIns="0">
+            <a:spAutoFit/>
+          </a:bodyPr>
+          <a:lstStyle/>
+          <a:p>
+            <a:pPr marL="177800" indent="0">
+              <a:spcAft>
+                <a:spcPts val="0"/>
+              </a:spcAft>
+              <a:buSzPct val="100000"/>
+              <a:buNone/>
+            </a:pPr>
+            <a:r>
+              <a:rPr lang="en-US" sz="1200" dirty="0">
+                <a:solidFill>
+                  <a:srgbClr val="000000"/>
+                </a:solidFill>
+                <a:latin typeface="Calibri" pitchFamily="34" charset="0"/>
+                <a:ea typeface="Calibri" pitchFamily="34" charset="-122"/>
+                <a:cs typeface="Calibri" pitchFamily="34" charset="-120"/>
+              </a:rPr>
+              <a:t xml:space="preserve">−5.39</a:t>
+            </a:r>
+          </a:p>
+        </p:txBody>
+      </p:sp>
+      <p:sp>
+        <p:nvSpPr>
+          <p:cNvPr id="41" name="TextBox 40"/>
+          <p:cNvSpPr txBox="1"/>
+          <p:nvPr/>
+        </p:nvSpPr>
+        <p:spPr>
+          <a:xfrm>
+            <a:off x="6903720" y="1325880"/>
+            <a:ext cx="4617720" cy="548640"/>
+          </a:xfrm>
+          <a:prstGeom prst="rect">
+            <a:avLst/>
+          </a:prstGeom>
+          <a:noFill/>
+        </p:spPr>
+        <p:txBody>
+          <a:bodyPr wrap="square" lIns="0" tIns="0" rIns="0" bIns="0">
+            <a:spAutoFit/>
+          </a:bodyPr>
+          <a:lstStyle/>
+          <a:p>
+            <a:pPr marL="177800" indent="0">
+              <a:spcAft>
+                <a:spcPts val="0"/>
+              </a:spcAft>
+              <a:buSzPct val="100000"/>
+              <a:buNone/>
+            </a:pPr>
+            <a:r>
+              <a:rPr lang="en-US" sz="1500" b="1" dirty="0">
+                <a:solidFill>
+                  <a:srgbClr val="000000"/>
+                </a:solidFill>
+                <a:latin typeface="Calibri" pitchFamily="34" charset="0"/>
+                <a:ea typeface="Calibri" pitchFamily="34" charset="-122"/>
+                <a:cs typeface="Calibri" pitchFamily="34" charset="-120"/>
+              </a:rPr>
+              <a:t xml:space="preserve">Robust to the device,</a:t>
+            </a:r>
+          </a:p>
+          <a:p>
+            <a:pPr marL="177800" indent="0">
+              <a:spcAft>
+                <a:spcPts val="0"/>
+              </a:spcAft>
+              <a:buSzPct val="100000"/>
+              <a:buNone/>
+            </a:pPr>
+            <a:r>
+              <a:rPr lang="en-US" sz="1500" b="1" dirty="0">
+                <a:solidFill>
+                  <a:srgbClr val="000000"/>
+                </a:solidFill>
+                <a:latin typeface="Calibri" pitchFamily="34" charset="0"/>
+                <a:ea typeface="Calibri" pitchFamily="34" charset="-122"/>
+                <a:cs typeface="Calibri" pitchFamily="34" charset="-120"/>
+              </a:rPr>
+              <a:t xml:space="preserve">conditional on the layout.</a:t>
+            </a:r>
+          </a:p>
+        </p:txBody>
+      </p:sp>
+      <p:sp>
+        <p:nvSpPr>
+          <p:cNvPr id="42" name="TextBox 41"/>
+          <p:cNvSpPr txBox="1"/>
+          <p:nvPr/>
+        </p:nvSpPr>
+        <p:spPr>
+          <a:xfrm>
+            <a:off x="6903720" y="2057400"/>
+            <a:ext cx="4617720" cy="4114800"/>
+          </a:xfrm>
+          <a:prstGeom prst="rect">
+            <a:avLst/>
+          </a:prstGeom>
+          <a:noFill/>
+        </p:spPr>
+        <p:txBody>
+          <a:bodyPr wrap="square" lIns="0" tIns="0" rIns="0" bIns="0">
+            <a:spAutoFit/>
+          </a:bodyPr>
+          <a:lstStyle/>
+          <a:p>
+            <a:pPr marL="177800" indent="-177800">
+              <a:spcAft>
+                <a:spcPts val="200"/>
+              </a:spcAft>
+              <a:buSzPct val="100000"/>
+              <a:buChar char="•"/>
+            </a:pPr>
+            <a:r>
+              <a:rPr lang="en-US" sz="1300" b="1" dirty="0">
+                <a:solidFill>
+                  <a:srgbClr val="000000"/>
+                </a:solidFill>
+                <a:latin typeface="Calibri" pitchFamily="34" charset="0"/>
+                <a:ea typeface="Calibri" pitchFamily="34" charset="-122"/>
+                <a:cs typeface="Calibri" pitchFamily="34" charset="-120"/>
+              </a:rPr>
+              <a:t xml:space="preserve">21,600 transients</a:t>
+            </a:r>
+            <a:r>
+              <a:rPr lang="en-US" sz="1300" dirty="0">
+                <a:solidFill>
+                  <a:srgbClr val="000000"/>
+                </a:solidFill>
+                <a:latin typeface="Calibri" pitchFamily="34" charset="0"/>
+                <a:ea typeface="Calibri" pitchFamily="34" charset="-122"/>
+                <a:cs typeface="Calibri" pitchFamily="34" charset="-120"/>
+              </a:rPr>
+              <a:t xml:space="preserve"> — a full 720-word search at two corners under each of eleven single-parameter perturbations. One failure.</a:t>
+            </a:r>
+          </a:p>
+          <a:p>
+            <a:pPr marL="177800" indent="-177800">
+              <a:spcAft>
+                <a:spcPts val="200"/>
+              </a:spcAft>
+              <a:buSzPct val="100000"/>
+              <a:buChar char="•"/>
+            </a:pPr>
+            <a:r>
+              <a:rPr lang="en-US" sz="1300" dirty="0">
+                <a:solidFill>
+                  <a:srgbClr val="000000"/>
+                </a:solidFill>
+                <a:latin typeface="Calibri" pitchFamily="34" charset="0"/>
+                <a:ea typeface="Calibri" pitchFamily="34" charset="-122"/>
+                <a:cs typeface="Calibri" pitchFamily="34" charset="-120"/>
+              </a:rPr>
+              <a:t xml:space="preserve">Every </a:t>
+            </a:r>
+            <a:r>
+              <a:rPr lang="en-US" sz="1300" b="1" dirty="0">
+                <a:solidFill>
+                  <a:srgbClr val="000000"/>
+                </a:solidFill>
+                <a:latin typeface="Calibri" pitchFamily="34" charset="0"/>
+                <a:ea typeface="Calibri" pitchFamily="34" charset="-122"/>
+                <a:cs typeface="Calibri" pitchFamily="34" charset="-120"/>
+              </a:rPr>
+              <a:t xml:space="preserve">device</a:t>
+            </a:r>
+            <a:r>
+              <a:rPr lang="en-US" sz="1300" dirty="0">
+                <a:solidFill>
+                  <a:srgbClr val="000000"/>
+                </a:solidFill>
+                <a:latin typeface="Calibri" pitchFamily="34" charset="0"/>
+                <a:ea typeface="Calibri" pitchFamily="34" charset="-122"/>
+                <a:cs typeface="Calibri" pitchFamily="34" charset="-120"/>
+              </a:rPr>
+              <a:t xml:space="preserve"> parameter leaves the ceiling between 4.3 % and 7.7 % — at most 1.76 points from nominal. The objection this study was built to answer is not supported.</a:t>
+            </a:r>
+          </a:p>
+          <a:p>
+            <a:pPr marL="177800" indent="-177800">
+              <a:spcAft>
+                <a:spcPts val="200"/>
+              </a:spcAft>
+              <a:buSzPct val="100000"/>
+              <a:buChar char="•"/>
+            </a:pPr>
+            <a:r>
+              <a:rPr lang="en-US" sz="1300" dirty="0">
+                <a:solidFill>
+                  <a:srgbClr val="000000"/>
+                </a:solidFill>
+                <a:latin typeface="Calibri" pitchFamily="34" charset="0"/>
+                <a:ea typeface="Calibri" pitchFamily="34" charset="-122"/>
+                <a:cs typeface="Calibri" pitchFamily="34" charset="-120"/>
+              </a:rPr>
+              <a:t xml:space="preserve">The one thing that moves it is </a:t>
+            </a:r>
+            <a:r>
+              <a:rPr lang="en-US" sz="1300" b="1" dirty="0">
+                <a:solidFill>
+                  <a:srgbClr val="000000"/>
+                </a:solidFill>
+                <a:latin typeface="Calibri" pitchFamily="34" charset="0"/>
+                <a:ea typeface="Calibri" pitchFamily="34" charset="-122"/>
+                <a:cs typeface="Calibri" pitchFamily="34" charset="-120"/>
+              </a:rPr>
+              <a:t xml:space="preserve">loop inductance</a:t>
+            </a:r>
+            <a:r>
+              <a:rPr lang="en-US" sz="1300" dirty="0">
+                <a:solidFill>
+                  <a:srgbClr val="000000"/>
+                </a:solidFill>
+                <a:latin typeface="Calibri" pitchFamily="34" charset="0"/>
+                <a:ea typeface="Calibri" pitchFamily="34" charset="-122"/>
+                <a:cs typeface="Calibri" pitchFamily="34" charset="-120"/>
+              </a:rPr>
+              <a:t xml:space="preserve">, which is board layout, not the transistor. A tighter loop commutates faster, so more charge couples through C</a:t>
+            </a:r>
+            <a:r>
+              <a:rPr lang="en-US" sz="1300" dirty="0">
+                <a:solidFill>
+                  <a:srgbClr val="000000"/>
+                </a:solidFill>
+                <a:latin typeface="Calibri" pitchFamily="34" charset="0"/>
+                <a:ea typeface="Calibri" pitchFamily="34" charset="-122"/>
+                <a:cs typeface="Calibri" pitchFamily="34" charset="-120"/>
+              </a:rPr>
+              <a:t xml:space="preserve">GD</a:t>
+            </a:r>
+            <a:r>
+              <a:rPr lang="en-US" sz="1300" dirty="0">
+                <a:solidFill>
+                  <a:srgbClr val="000000"/>
+                </a:solidFill>
+                <a:latin typeface="Calibri" pitchFamily="34" charset="0"/>
+                <a:ea typeface="Calibri" pitchFamily="34" charset="-122"/>
+                <a:cs typeface="Calibri" pitchFamily="34" charset="-120"/>
+              </a:rPr>
+              <a:t xml:space="preserve">: the median spurious gate voltage goes 0.640 V to 3.522 V and the feasible set collapses 474 → 158.</a:t>
+            </a:r>
+          </a:p>
+          <a:p>
+            <a:pPr marL="177800" indent="-177800">
+              <a:spcAft>
+                <a:spcPts val="200"/>
+              </a:spcAft>
+              <a:buSzPct val="100000"/>
+              <a:buChar char="•"/>
+            </a:pPr>
+            <a:r>
+              <a:rPr lang="en-US" sz="1300" dirty="0">
+                <a:solidFill>
+                  <a:srgbClr val="000000"/>
+                </a:solidFill>
+                <a:latin typeface="Calibri" pitchFamily="34" charset="0"/>
+                <a:ea typeface="Calibri" pitchFamily="34" charset="-122"/>
+                <a:cs typeface="Calibri" pitchFamily="34" charset="-120"/>
+              </a:rPr>
+              <a:t xml:space="preserve">So the claim is narrower and more useful than “robust”: from about 2.5 nH upward a fixed word is nearly as good; on a tighter loop the question has to be re-asked, and the answer there is not even monotonic — see slide 19.</a:t>
+            </a:r>
+          </a:p>
+          <a:p>
+            <a:pPr marL="177800" indent="-177800">
+              <a:spcAft>
+                <a:spcPts val="0"/>
+              </a:spcAft>
+              <a:buSzPct val="100000"/>
+              <a:buChar char="•"/>
+            </a:pPr>
+            <a:r>
+              <a:rPr lang="en-US" sz="1150" b="1" dirty="0">
+                <a:solidFill>
+                  <a:srgbClr val="000000"/>
+                </a:solidFill>
+                <a:latin typeface="Calibri" pitchFamily="34" charset="0"/>
+                <a:ea typeface="Calibri" pitchFamily="34" charset="-122"/>
+                <a:cs typeface="Calibri" pitchFamily="34" charset="-120"/>
+              </a:rPr>
+              <a:t xml:space="preserve">Baseline note. </a:t>
+            </a:r>
+            <a:r>
+              <a:rPr lang="en-US" sz="1150" dirty="0">
+                <a:solidFill>
+                  <a:srgbClr val="000000"/>
+                </a:solidFill>
+                <a:latin typeface="Calibri" pitchFamily="34" charset="0"/>
+                <a:ea typeface="Calibri" pitchFamily="34" charset="-122"/>
+                <a:cs typeface="Calibri" pitchFamily="34" charset="-120"/>
+              </a:rPr>
+              <a:t xml:space="preserve">Nominal here is 5.95 %, not the 5.2 % headline — a two-corner search on its own sweep. Compare the </a:t>
+            </a:r>
+            <a:r>
+              <a:rPr lang="en-US" sz="1150" b="1" dirty="0">
+                <a:solidFill>
+                  <a:srgbClr val="000000"/>
+                </a:solidFill>
+                <a:latin typeface="Calibri" pitchFamily="34" charset="0"/>
+                <a:ea typeface="Calibri" pitchFamily="34" charset="-122"/>
+                <a:cs typeface="Calibri" pitchFamily="34" charset="-120"/>
+              </a:rPr>
+              <a:t xml:space="preserve">vs nom.</a:t>
+            </a:r>
+            <a:r>
+              <a:rPr lang="en-US" sz="1150" dirty="0">
+                <a:solidFill>
+                  <a:srgbClr val="000000"/>
+                </a:solidFill>
+                <a:latin typeface="Calibri" pitchFamily="34" charset="0"/>
+                <a:ea typeface="Calibri" pitchFamily="34" charset="-122"/>
+                <a:cs typeface="Calibri" pitchFamily="34" charset="-120"/>
+              </a:rPr>
+              <a:t xml:space="preserve"> column, not the absolute values.</a:t>
             </a:r>
           </a:p>
         </p:txBody>
@@ -17536,7 +19483,7 @@
                 <a:ea typeface="Calibri" pitchFamily="34" charset="-122"/>
                 <a:cs typeface="Calibri" pitchFamily="34" charset="-120"/>
               </a:rPr>
-              <a:t>4</a:t>
+              <a:t>5</a:t>
             </a:r>
             <a:endParaRPr lang="en-US" sz="1000" dirty="0"/>
           </a:p>
@@ -17908,7 +19855,7 @@
                 <a:ea typeface="Calibri" pitchFamily="34" charset="-122"/>
                 <a:cs typeface="Calibri" pitchFamily="34" charset="-120"/>
               </a:rPr>
-              <a:t>5</a:t>
+              <a:t>6</a:t>
             </a:r>
             <a:endParaRPr lang="en-US" sz="1000" dirty="0"/>
           </a:p>
@@ -19772,7 +21719,7 @@
                 <a:ea typeface="Calibri" pitchFamily="34" charset="-122"/>
                 <a:cs typeface="Calibri" pitchFamily="34" charset="-120"/>
               </a:rPr>
-              <a:t>6</a:t>
+              <a:t>7</a:t>
             </a:r>
             <a:endParaRPr lang="en-US" sz="1000" dirty="0"/>
           </a:p>
@@ -22159,7 +24106,7 @@
                 <a:ea typeface="Calibri" pitchFamily="34" charset="-122"/>
                 <a:cs typeface="Calibri" pitchFamily="34" charset="-120"/>
               </a:rPr>
-              <a:t>8</a:t>
+              <a:t>10</a:t>
             </a:r>
             <a:endParaRPr lang="en-US" sz="1000" dirty="0"/>
           </a:p>
@@ -22560,7 +24507,7 @@
                 <a:ea typeface="Calibri" pitchFamily="34" charset="-122"/>
                 <a:cs typeface="Calibri" pitchFamily="34" charset="-120"/>
               </a:rPr>
-              <a:t>10</a:t>
+              <a:t>12</a:t>
             </a:r>
             <a:endParaRPr lang="en-US" sz="1000" dirty="0"/>
           </a:p>
@@ -22762,7 +24709,7 @@
                 <a:ea typeface="Calibri" pitchFamily="34" charset="-122"/>
                 <a:cs typeface="Calibri" pitchFamily="34" charset="-120"/>
               </a:rPr>
-              <a:t>15</a:t>
+              <a:t>17</a:t>
             </a:r>
             <a:endParaRPr lang="en-US" sz="1000" dirty="0"/>
           </a:p>

</xml_diff>

<commit_message>
Divider: numeral box no longer overlaps the heading
At 1.50 in tall the numeral box ran to 3.55 in and the heading box starts at
3.35 in -- a 0.20 in overlap on all four dividers. It rendered acceptably
because the numeral sits high in its box, but the geometry was wrong. qa.py
now reports only the full-bleed grounds and the MATLAB backing panels, both
intentional, plus the three pre-existing signature-block flags.

Co-Authored-By: Claude Opus 5 <noreply@anthropic.com>
</commit_message>
<xml_diff>
--- a/review/Review1_GaN_Segmented_Gate_Driver.pptx
+++ b/review/Review1_GaN_Segmented_Gate_Driver.pptx
@@ -16874,7 +16874,7 @@
         <p:spPr>
           <a:xfrm>
             <a:off x="1188720" y="1874519"/>
-            <a:ext cx="2743200" cy="1371600"/>
+            <a:ext cx="2743200" cy="1143000"/>
           </a:xfrm>
           <a:prstGeom prst="rect">
             <a:avLst/>
@@ -17036,7 +17036,7 @@
         <p:spPr>
           <a:xfrm>
             <a:off x="1188720" y="1874519"/>
-            <a:ext cx="2743200" cy="1371600"/>
+            <a:ext cx="2743200" cy="1143000"/>
           </a:xfrm>
           <a:prstGeom prst="rect">
             <a:avLst/>
@@ -17198,7 +17198,7 @@
         <p:spPr>
           <a:xfrm>
             <a:off x="1188720" y="1874519"/>
-            <a:ext cx="2743200" cy="1371600"/>
+            <a:ext cx="2743200" cy="1143000"/>
           </a:xfrm>
           <a:prstGeom prst="rect">
             <a:avLst/>
@@ -17360,7 +17360,7 @@
         <p:spPr>
           <a:xfrm>
             <a:off x="1188720" y="1874519"/>
-            <a:ext cx="2743200" cy="1371600"/>
+            <a:ext cx="2743200" cy="1143000"/>
           </a:xfrm>
           <a:prstGeom prst="rect">
             <a:avLst/>

</xml_diff>

<commit_message>
Fit the redrawn architecture figure, drop its duplicated caption
The placement sized the picture by WIDTH against a hard-coded aspect of
2.095. The redraw is 1.969, so at 11 in wide it became 5.59 in tall and sat on
its own caption. Sized by height now, which does not encode an assumption
about the figure that a later redraw can silently break.

The slide-level caption said what the figure's own footer already said. One of
them had to go, and it was the slide's.

Co-Authored-By: Claude Opus 5 <noreply@anthropic.com>
</commit_message>
<xml_diff>
--- a/review/Review1_GaN_Segmented_Gate_Driver.pptx
+++ b/review/Review1_GaN_Segmented_Gate_Driver.pptx
@@ -24592,57 +24592,14 @@
         </p:blipFill>
         <p:spPr>
           <a:xfrm>
-            <a:off x="1069848" y="1207008"/>
-            <a:ext cx="10058400" cy="5108249"/>
+            <a:off x="1417320" y="1207008"/>
+            <a:ext cx="9362598" cy="4754880"/>
           </a:xfrm>
           <a:prstGeom prst="rect">
             <a:avLst/>
           </a:prstGeom>
         </p:spPr>
       </p:pic>
-      <p:sp>
-        <p:nvSpPr>
-          <p:cNvPr id="6" name="TextBox 5"/>
-          <p:cNvSpPr txBox="1"/>
-          <p:nvPr/>
-        </p:nvSpPr>
-        <p:spPr>
-          <a:xfrm>
-            <a:off x="640080" y="6089904"/>
-            <a:ext cx="10881360" cy="347472"/>
-          </a:xfrm>
-          <a:prstGeom prst="rect">
-            <a:avLst/>
-          </a:prstGeom>
-          <a:noFill/>
-        </p:spPr>
-        <p:txBody>
-          <a:bodyPr wrap="square" lIns="0" tIns="0" rIns="0" bIns="0">
-            <a:spAutoFit/>
-          </a:bodyPr>
-          <a:lstStyle/>
-          <a:p>
-            <a:pPr marL="177800" indent="0">
-              <a:spcAft>
-                <a:spcPts val="0"/>
-              </a:spcAft>
-              <a:buSzPct val="100000"/>
-              <a:buNone/>
-            </a:pPr>
-            <a:r>
-              <a:rPr lang="en-US" sz="1100" dirty="0">
-                <a:solidFill>
-                  <a:srgbClr val="000000"/>
-                </a:solidFill>
-                <a:latin typeface="Calibri" pitchFamily="34" charset="0"/>
-                <a:ea typeface="Calibri" pitchFamily="34" charset="-122"/>
-                <a:cs typeface="Calibri" pitchFamily="34" charset="-120"/>
-              </a:rPr>
-              <a:t xml:space="preserve">Solid blocks are configured once at power-up. The dashed block — sensing, ADC and lookup table — is the adaptive machinery this project exists to price.</a:t>
-            </a:r>
-          </a:p>
-        </p:txBody>
-      </p:sp>
     </p:spTree>
   </p:cSld>
   <p:clrMapOvr>

</xml_diff>

<commit_message>
Lead the literature with the base paper, not the cluster table
Asked for directly: describe the base paper first, and drop the A/B/C/D
landscape. Slide 6 is now Takayama, Okuda & Hikihara 2022 in three rows --
what it does, why it matters to us, what it leaves open -- with the full
citation and DOI beneath it.

The clusters are gone rather than demoted. They were a good answer to "did you
read the field?", but the wrong first thing to show someone who does not yet
know what the project builds on, and the next slide already gives the five
closest papers with the base paper at the top. Nothing is lost: refs.py still
carries all thirty, and the reference list is unchanged.

Also collapsed the template's first table column, which held a row letter for
the old clusters and was left as an empty band down every row.

Co-Authored-By: Claude Opus 5 <noreply@anthropic.com>
</commit_message>
<xml_diff>
--- a/review/Review1_GaN_Segmented_Gate_Driver.pptx
+++ b/review/Review1_GaN_Segmented_Gate_Driver.pptx
@@ -19894,7 +19894,7 @@
                 <a:ea typeface="Calibri" pitchFamily="34" charset="-122"/>
                 <a:cs typeface="Calibri" pitchFamily="34" charset="-120"/>
               </a:rPr>
-              <a:t>Literature Landscape — four clusters, and where we sit</a:t>
+              <a:t>The base paper we build on</a:t>
             </a:r>
             <a:endParaRPr lang="en-US" sz="2800" dirty="0"/>
           </a:p>
@@ -19940,14 +19940,14 @@
         </p:nvGraphicFramePr>
         <p:xfrm>
           <a:off x="548640" y="1371600"/>
-          <a:ext cx="11091672" cy="3611880"/>
+          <a:ext cx="10652760" cy="3657600"/>
         </p:xfrm>
         <a:graphic>
           <a:graphicData uri="http://schemas.openxmlformats.org/drawingml/2006/table">
             <a:tbl>
               <a:tblPr/>
               <a:tblGrid>
-                <a:gridCol w="548640">
+                <a:gridCol w="109728">
                   <a:extLst>
                     <a:ext uri="{9D8B030D-6E8A-4147-A177-3AD203B41FA5}">
                       <a16:colId xmlns:a16="http://schemas.microsoft.com/office/drawing/2014/main" val="20000"/>
@@ -19983,7 +19983,7 @@
                   </a:extLst>
                 </a:gridCol>
               </a:tblGrid>
-              <a:tr h="320040">
+              <a:tr h="365760">
                 <a:tc>
                   <a:txBody>
                     <a:bodyPr wrap="square"/>
@@ -19992,14 +19992,71 @@
                       <a:pPr marL="0" indent="0">
                         <a:buNone/>
                       </a:pPr>
+                      <a:endParaRPr lang="en-US" sz="1300" dirty="0">
+                        <a:latin typeface="Calibri" charset="0"/>
+                        <a:ea typeface="Calibri" charset="0"/>
+                        <a:cs typeface="Calibri" charset="0"/>
+                      </a:endParaRPr>
+                    </a:p>
+                  </a:txBody>
+                  <a:tcPr marL="54864" marR="54864" marT="54864" marB="54864" anchor="ctr">
+                    <a:lnL w="9525" cap="flat" cmpd="sng" algn="ctr">
+                      <a:solidFill>
+                        <a:srgbClr val="BFBFBF"/>
+                      </a:solidFill>
+                      <a:prstDash val="solid"/>
+                      <a:round/>
+                      <a:headEnd type="none" w="med" len="med"/>
+                      <a:tailEnd type="none" w="med" len="med"/>
+                    </a:lnL>
+                    <a:lnR w="9525" cap="flat" cmpd="sng" algn="ctr">
+                      <a:solidFill>
+                        <a:srgbClr val="BFBFBF"/>
+                      </a:solidFill>
+                      <a:prstDash val="solid"/>
+                      <a:round/>
+                      <a:headEnd type="none" w="med" len="med"/>
+                      <a:tailEnd type="none" w="med" len="med"/>
+                    </a:lnR>
+                    <a:lnT w="9525" cap="flat" cmpd="sng" algn="ctr">
+                      <a:solidFill>
+                        <a:srgbClr val="BFBFBF"/>
+                      </a:solidFill>
+                      <a:prstDash val="solid"/>
+                      <a:round/>
+                      <a:headEnd type="none" w="med" len="med"/>
+                      <a:tailEnd type="none" w="med" len="med"/>
+                    </a:lnT>
+                    <a:lnB w="9525" cap="flat" cmpd="sng" algn="ctr">
+                      <a:solidFill>
+                        <a:srgbClr val="BFBFBF"/>
+                      </a:solidFill>
+                      <a:prstDash val="solid"/>
+                      <a:round/>
+                      <a:headEnd type="none" w="med" len="med"/>
+                      <a:tailEnd type="none" w="med" len="med"/>
+                    </a:lnB>
+                    <a:solidFill>
+                      <a:srgbClr val="1D2F82"/>
+                    </a:solidFill>
+                  </a:tcPr>
+                </a:tc>
+                <a:tc gridSpan="4">
+                  <a:txBody>
+                    <a:bodyPr wrap="square"/>
+                    <a:lstStyle/>
+                    <a:p>
+                      <a:pPr marL="0" indent="0">
+                        <a:buNone/>
+                      </a:pPr>
                       <a:r>
-                        <a:rPr sz="1050" b="0">
+                        <a:rPr sz="1050" b="1">
                           <a:solidFill>
                             <a:srgbClr val="000000"/>
                           </a:solidFill>
                           <a:latin typeface="Calibri"/>
                         </a:rPr>
-                        <a:t>#</a:t>
+                        <a:t>Takayama, Okuda &amp; Hikihara (2022)</a:t>
                       </a:r>
                       <a:endParaRPr lang="en-US" sz="1300" dirty="0">
                         <a:latin typeface="Calibri" charset="0"/>
@@ -20050,7 +20107,7 @@
                     </a:solidFill>
                   </a:tcPr>
                 </a:tc>
-                <a:tc>
+                <a:tc hMerge="1">
                   <a:txBody>
                     <a:bodyPr wrap="square"/>
                     <a:lstStyle/>
@@ -20058,15 +20115,6 @@
                       <a:pPr marL="0" indent="0">
                         <a:buNone/>
                       </a:pPr>
-                      <a:r>
-                        <a:rPr sz="1050" b="0">
-                          <a:solidFill>
-                            <a:srgbClr val="000000"/>
-                          </a:solidFill>
-                          <a:latin typeface="Calibri"/>
-                        </a:rPr>
-                        <a:t>Cluster</a:t>
-                      </a:r>
                       <a:endParaRPr lang="en-US" sz="1300" dirty="0">
                         <a:latin typeface="Calibri" charset="0"/>
                         <a:ea typeface="Calibri" charset="0"/>
@@ -20116,7 +20164,7 @@
                     </a:solidFill>
                   </a:tcPr>
                 </a:tc>
-                <a:tc>
+                <a:tc hMerge="1">
                   <a:txBody>
                     <a:bodyPr wrap="square"/>
                     <a:lstStyle/>
@@ -20124,81 +20172,6 @@
                       <a:pPr marL="0" indent="0">
                         <a:buNone/>
                       </a:pPr>
-                      <a:r>
-                        <a:rPr sz="1050" b="0">
-                          <a:solidFill>
-                            <a:srgbClr val="000000"/>
-                          </a:solidFill>
-                          <a:latin typeface="Calibri"/>
-                        </a:rPr>
-                        <a:t>Refs</a:t>
-                      </a:r>
-                      <a:endParaRPr lang="en-US" sz="1300" dirty="0">
-                        <a:latin typeface="Calibri" charset="0"/>
-                        <a:ea typeface="Calibri" charset="0"/>
-                        <a:cs typeface="Calibri" charset="0"/>
-                      </a:endParaRPr>
-                    </a:p>
-                  </a:txBody>
-                  <a:tcPr marL="54864" marR="54864" marT="54864" marB="54864" anchor="ctr">
-                    <a:lnL w="9525" cap="flat" cmpd="sng" algn="ctr">
-                      <a:solidFill>
-                        <a:srgbClr val="BFBFBF"/>
-                      </a:solidFill>
-                      <a:prstDash val="solid"/>
-                      <a:round/>
-                      <a:headEnd type="none" w="med" len="med"/>
-                      <a:tailEnd type="none" w="med" len="med"/>
-                    </a:lnL>
-                    <a:lnR w="9525" cap="flat" cmpd="sng" algn="ctr">
-                      <a:solidFill>
-                        <a:srgbClr val="BFBFBF"/>
-                      </a:solidFill>
-                      <a:prstDash val="solid"/>
-                      <a:round/>
-                      <a:headEnd type="none" w="med" len="med"/>
-                      <a:tailEnd type="none" w="med" len="med"/>
-                    </a:lnR>
-                    <a:lnT w="9525" cap="flat" cmpd="sng" algn="ctr">
-                      <a:solidFill>
-                        <a:srgbClr val="BFBFBF"/>
-                      </a:solidFill>
-                      <a:prstDash val="solid"/>
-                      <a:round/>
-                      <a:headEnd type="none" w="med" len="med"/>
-                      <a:tailEnd type="none" w="med" len="med"/>
-                    </a:lnT>
-                    <a:lnB w="9525" cap="flat" cmpd="sng" algn="ctr">
-                      <a:solidFill>
-                        <a:srgbClr val="BFBFBF"/>
-                      </a:solidFill>
-                      <a:prstDash val="solid"/>
-                      <a:round/>
-                      <a:headEnd type="none" w="med" len="med"/>
-                      <a:tailEnd type="none" w="med" len="med"/>
-                    </a:lnB>
-                    <a:solidFill>
-                      <a:srgbClr val="1D2F82"/>
-                    </a:solidFill>
-                  </a:tcPr>
-                </a:tc>
-                <a:tc gridSpan="2">
-                  <a:txBody>
-                    <a:bodyPr wrap="square"/>
-                    <a:lstStyle/>
-                    <a:p>
-                      <a:pPr marL="0" indent="0">
-                        <a:buNone/>
-                      </a:pPr>
-                      <a:r>
-                        <a:rPr sz="1050" b="0">
-                          <a:solidFill>
-                            <a:srgbClr val="000000"/>
-                          </a:solidFill>
-                          <a:latin typeface="Calibri"/>
-                        </a:rPr>
-                        <a:t>What the cluster does</a:t>
-                      </a:r>
                       <a:endParaRPr lang="en-US" sz="1300" dirty="0">
                         <a:latin typeface="Calibri" charset="0"/>
                         <a:ea typeface="Calibri" charset="0"/>
@@ -20311,7 +20284,7 @@
                   </a:ext>
                 </a:extLst>
               </a:tr>
-              <a:tr h="822960">
+              <a:tr h="1097280">
                 <a:tc>
                   <a:txBody>
                     <a:bodyPr wrap="square"/>
@@ -20320,15 +20293,6 @@
                       <a:pPr marL="0" indent="0">
                         <a:buNone/>
                       </a:pPr>
-                      <a:r>
-                        <a:rPr sz="1050" b="0">
-                          <a:solidFill>
-                            <a:srgbClr val="000000"/>
-                          </a:solidFill>
-                          <a:latin typeface="Calibri"/>
-                        </a:rPr>
-                        <a:t>A</a:t>
-                      </a:r>
                       <a:endParaRPr lang="en-US" sz="1300" dirty="0">
                         <a:latin typeface="Calibri" charset="0"/>
                         <a:ea typeface="Calibri" charset="0"/>
@@ -20390,7 +20354,7 @@
                           </a:solidFill>
                           <a:latin typeface="Calibri"/>
                         </a:rPr>
-                        <a:t>A · Passive / analogue crosstalk fixes</a:t>
+                        <a:t>What it does</a:t>
                       </a:r>
                       <a:endParaRPr lang="en-US" sz="1300" dirty="0">
                         <a:latin typeface="Calibri" charset="0"/>
@@ -20438,7 +20402,7 @@
                     </a:lnB>
                   </a:tcPr>
                 </a:tc>
-                <a:tc>
+                <a:tc gridSpan="3">
                   <a:txBody>
                     <a:bodyPr wrap="square"/>
                     <a:lstStyle/>
@@ -20453,24 +20417,13 @@
                           </a:solidFill>
                           <a:latin typeface="Calibri"/>
                         </a:rPr>
-                        <a:t>[1] [2] [3] [4] [11] [12]</a:t>
+                        <a:t>Drives the gate from a multibit CODE instead of a resistor — the driver is a DAC, and the code changes DURING the switching edge.</a:t>
                       </a:r>
                       <a:endParaRPr lang="en-US" sz="1300" dirty="0">
                         <a:latin typeface="Calibri" charset="0"/>
                         <a:ea typeface="Calibri" charset="0"/>
                         <a:cs typeface="Calibri" charset="0"/>
                       </a:endParaRPr>
-                    </a:p>
-                    <a:p>
-                      <a:r>
-                        <a:rPr sz="1050" b="0">
-                          <a:solidFill>
-                            <a:srgbClr val="000000"/>
-                          </a:solidFill>
-                          <a:latin typeface="Calibri"/>
-                        </a:rPr>
-                        <a:t>[14]–[19] [21]</a:t>
-                      </a:r>
                     </a:p>
                   </a:txBody>
                   <a:tcPr marL="54864" marR="54864" marT="54864" marB="54864" anchor="ctr">
@@ -20512,23 +20465,14 @@
                     </a:lnB>
                   </a:tcPr>
                 </a:tc>
-                <a:tc gridSpan="2">
+                <a:tc hMerge="1">
                   <a:txBody>
-                    <a:bodyPr wrap="square"/>
+                    <a:bodyPr/>
                     <a:lstStyle/>
                     <a:p>
                       <a:pPr marL="0" indent="0">
                         <a:buNone/>
                       </a:pPr>
-                      <a:r>
-                        <a:rPr sz="1050" b="0">
-                          <a:solidFill>
-                            <a:srgbClr val="000000"/>
-                          </a:solidFill>
-                          <a:latin typeface="Calibri"/>
-                        </a:rPr>
-                        <a:t>Negative off-bias, RC-diode rails, three-level drive, Miller clamps. Cheap and effective, but the setting is chosen once by hand and never revisited.</a:t>
-                      </a:r>
                       <a:endParaRPr lang="en-US" sz="1300" dirty="0">
                         <a:latin typeface="Calibri" charset="0"/>
                         <a:ea typeface="Calibri" charset="0"/>
@@ -20635,7 +20579,7 @@
                   </a:ext>
                 </a:extLst>
               </a:tr>
-              <a:tr h="822960">
+              <a:tr h="1097280">
                 <a:tc>
                   <a:txBody>
                     <a:bodyPr wrap="square"/>
@@ -20644,15 +20588,6 @@
                       <a:pPr marL="0" indent="0">
                         <a:buNone/>
                       </a:pPr>
-                      <a:r>
-                        <a:rPr sz="1050" b="0">
-                          <a:solidFill>
-                            <a:srgbClr val="000000"/>
-                          </a:solidFill>
-                          <a:latin typeface="Calibri"/>
-                        </a:rPr>
-                        <a:t>B</a:t>
-                      </a:r>
                       <a:endParaRPr lang="en-US" sz="1300" dirty="0">
                         <a:latin typeface="Calibri" charset="0"/>
                         <a:ea typeface="Calibri" charset="0"/>
@@ -20714,7 +20649,7 @@
                           </a:solidFill>
                           <a:latin typeface="Calibri"/>
                         </a:rPr>
-                        <a:t>B · Closed-loop analogue adaptation</a:t>
+                        <a:t>Why it matters to us</a:t>
                       </a:r>
                       <a:endParaRPr lang="en-US" sz="1300" dirty="0">
                         <a:latin typeface="Calibri" charset="0"/>
@@ -20762,7 +20697,7 @@
                     </a:lnB>
                   </a:tcPr>
                 </a:tc>
-                <a:tc>
+                <a:tc gridSpan="3">
                   <a:txBody>
                     <a:bodyPr wrap="square"/>
                     <a:lstStyle/>
@@ -20777,24 +20712,13 @@
                           </a:solidFill>
                           <a:latin typeface="Calibri"/>
                         </a:rPr>
-                        <a:t>[5] [6] [7]</a:t>
+                        <a:t>A digital code is finite. That is what makes the setting space searchable, and what makes the driver implementable on an FPGA rather than as an analogue network.</a:t>
                       </a:r>
                       <a:endParaRPr lang="en-US" sz="1300" dirty="0">
                         <a:latin typeface="Calibri" charset="0"/>
                         <a:ea typeface="Calibri" charset="0"/>
                         <a:cs typeface="Calibri" charset="0"/>
                       </a:endParaRPr>
-                    </a:p>
-                    <a:p>
-                      <a:r>
-                        <a:rPr sz="1050" b="0">
-                          <a:solidFill>
-                            <a:srgbClr val="000000"/>
-                          </a:solidFill>
-                          <a:latin typeface="Calibri"/>
-                        </a:rPr>
-                        <a:t>[20] [22] [23] [29] [30]</a:t>
-                      </a:r>
                     </a:p>
                   </a:txBody>
                   <a:tcPr marL="54864" marR="54864" marT="54864" marB="54864" anchor="ctr">
@@ -20836,23 +20760,14 @@
                     </a:lnB>
                   </a:tcPr>
                 </a:tc>
-                <a:tc gridSpan="2">
+                <a:tc hMerge="1">
                   <a:txBody>
-                    <a:bodyPr wrap="square"/>
+                    <a:bodyPr/>
                     <a:lstStyle/>
                     <a:p>
                       <a:pPr marL="0" indent="0">
                         <a:buNone/>
                       </a:pPr>
-                      <a:r>
-                        <a:rPr sz="1050" b="0">
-                          <a:solidFill>
-                            <a:srgbClr val="000000"/>
-                          </a:solidFill>
-                          <a:latin typeface="Calibri"/>
-                        </a:rPr>
-                        <a:t>Sense the operating point, regulate drive strength or timing in the loop. Reports large gains — 30.5 % less overshoot, 75 % less turn-off loss — against a conventional driver.</a:t>
-                      </a:r>
                       <a:endParaRPr lang="en-US" sz="1300" dirty="0">
                         <a:latin typeface="Calibri" charset="0"/>
                         <a:ea typeface="Calibri" charset="0"/>
@@ -20959,7 +20874,7 @@
                   </a:ext>
                 </a:extLst>
               </a:tr>
-              <a:tr h="822960">
+              <a:tr h="1097280">
                 <a:tc>
                   <a:txBody>
                     <a:bodyPr wrap="square"/>
@@ -20968,15 +20883,6 @@
                       <a:pPr marL="0" indent="0">
                         <a:buNone/>
                       </a:pPr>
-                      <a:r>
-                        <a:rPr sz="1050" b="0">
-                          <a:solidFill>
-                            <a:srgbClr val="000000"/>
-                          </a:solidFill>
-                          <a:latin typeface="Calibri"/>
-                        </a:rPr>
-                        <a:t>C</a:t>
-                      </a:r>
                       <a:endParaRPr lang="en-US" sz="1300" dirty="0">
                         <a:latin typeface="Calibri" charset="0"/>
                         <a:ea typeface="Calibri" charset="0"/>
@@ -21038,7 +20944,7 @@
                           </a:solidFill>
                           <a:latin typeface="Calibri"/>
                         </a:rPr>
-                        <a:t>C · Adaptive dead-time control</a:t>
+                        <a:t>What it leaves open</a:t>
                       </a:r>
                       <a:endParaRPr lang="en-US" sz="1300" dirty="0">
                         <a:latin typeface="Calibri" charset="0"/>
@@ -21086,7 +20992,7 @@
                     </a:lnB>
                   </a:tcPr>
                 </a:tc>
-                <a:tc>
+                <a:tc gridSpan="3">
                   <a:txBody>
                     <a:bodyPr wrap="square"/>
                     <a:lstStyle/>
@@ -21101,24 +21007,13 @@
                           </a:solidFill>
                           <a:latin typeface="Calibri"/>
                         </a:rPr>
-                        <a:t>[8] [13]</a:t>
+                        <a:t>It never asks whether the code has to CHANGE as load, voltage and temperature move. That question is this project.</a:t>
                       </a:r>
                       <a:endParaRPr lang="en-US" sz="1300" dirty="0">
                         <a:latin typeface="Calibri" charset="0"/>
                         <a:ea typeface="Calibri" charset="0"/>
                         <a:cs typeface="Calibri" charset="0"/>
                       </a:endParaRPr>
-                    </a:p>
-                    <a:p>
-                      <a:r>
-                        <a:rPr sz="1050" b="0">
-                          <a:solidFill>
-                            <a:srgbClr val="000000"/>
-                          </a:solidFill>
-                          <a:latin typeface="Calibri"/>
-                        </a:rPr>
-                        <a:t>[25] [26] [28]</a:t>
-                      </a:r>
                     </a:p>
                   </a:txBody>
                   <a:tcPr marL="54864" marR="54864" marT="54864" marB="54864" anchor="ctr">
@@ -21160,23 +21055,14 @@
                     </a:lnB>
                   </a:tcPr>
                 </a:tc>
-                <a:tc gridSpan="2">
+                <a:tc hMerge="1">
                   <a:txBody>
-                    <a:bodyPr wrap="square"/>
+                    <a:bodyPr/>
                     <a:lstStyle/>
                     <a:p>
                       <a:pPr marL="0" indent="0">
                         <a:buNone/>
                       </a:pPr>
-                      <a:r>
-                        <a:rPr sz="1050" b="0">
-                          <a:solidFill>
-                            <a:srgbClr val="000000"/>
-                          </a:solidFill>
-                          <a:latin typeface="Calibri"/>
-                        </a:rPr>
-                        <a:t>Dead time driven to sub-nanosecond across load. The one field our own freeze test finds actually carries the benefit — and only at light load.</a:t>
-                      </a:r>
                       <a:endParaRPr lang="en-US" sz="1300" dirty="0">
                         <a:latin typeface="Calibri" charset="0"/>
                         <a:ea typeface="Calibri" charset="0"/>
@@ -21283,330 +21169,6 @@
                   </a:ext>
                 </a:extLst>
               </a:tr>
-              <a:tr h="822960">
-                <a:tc>
-                  <a:txBody>
-                    <a:bodyPr wrap="square"/>
-                    <a:lstStyle/>
-                    <a:p>
-                      <a:pPr marL="0" indent="0">
-                        <a:buNone/>
-                      </a:pPr>
-                      <a:r>
-                        <a:rPr sz="1050" b="0">
-                          <a:solidFill>
-                            <a:srgbClr val="000000"/>
-                          </a:solidFill>
-                          <a:latin typeface="Calibri"/>
-                        </a:rPr>
-                        <a:t>D</a:t>
-                      </a:r>
-                      <a:endParaRPr lang="en-US" sz="1300" dirty="0">
-                        <a:latin typeface="Calibri" charset="0"/>
-                        <a:ea typeface="Calibri" charset="0"/>
-                        <a:cs typeface="Calibri" charset="0"/>
-                      </a:endParaRPr>
-                    </a:p>
-                  </a:txBody>
-                  <a:tcPr marL="54864" marR="54864" marT="54864" marB="54864" anchor="ctr">
-                    <a:lnL w="9525" cap="flat" cmpd="sng" algn="ctr">
-                      <a:solidFill>
-                        <a:srgbClr val="BFBFBF"/>
-                      </a:solidFill>
-                      <a:prstDash val="solid"/>
-                      <a:round/>
-                      <a:headEnd type="none" w="med" len="med"/>
-                      <a:tailEnd type="none" w="med" len="med"/>
-                    </a:lnL>
-                    <a:lnR w="9525" cap="flat" cmpd="sng" algn="ctr">
-                      <a:solidFill>
-                        <a:srgbClr val="BFBFBF"/>
-                      </a:solidFill>
-                      <a:prstDash val="solid"/>
-                      <a:round/>
-                      <a:headEnd type="none" w="med" len="med"/>
-                      <a:tailEnd type="none" w="med" len="med"/>
-                    </a:lnR>
-                    <a:lnT w="9525" cap="flat" cmpd="sng" algn="ctr">
-                      <a:solidFill>
-                        <a:srgbClr val="BFBFBF"/>
-                      </a:solidFill>
-                      <a:prstDash val="solid"/>
-                      <a:round/>
-                      <a:headEnd type="none" w="med" len="med"/>
-                      <a:tailEnd type="none" w="med" len="med"/>
-                    </a:lnT>
-                    <a:lnB w="9525" cap="flat" cmpd="sng" algn="ctr">
-                      <a:solidFill>
-                        <a:srgbClr val="BFBFBF"/>
-                      </a:solidFill>
-                      <a:prstDash val="solid"/>
-                      <a:round/>
-                      <a:headEnd type="none" w="med" len="med"/>
-                      <a:tailEnd type="none" w="med" len="med"/>
-                    </a:lnB>
-                  </a:tcPr>
-                </a:tc>
-                <a:tc>
-                  <a:txBody>
-                    <a:bodyPr wrap="square"/>
-                    <a:lstStyle/>
-                    <a:p>
-                      <a:pPr marL="0" indent="0">
-                        <a:buNone/>
-                      </a:pPr>
-                      <a:r>
-                        <a:rPr sz="1050" b="1">
-                          <a:solidFill>
-                            <a:srgbClr val="000000"/>
-                          </a:solidFill>
-                          <a:latin typeface="Calibri"/>
-                        </a:rPr>
-                        <a:t>D · DIGITAL / segmented drive  — where this project sits</a:t>
-                      </a:r>
-                      <a:endParaRPr lang="en-US" sz="1300" dirty="0">
-                        <a:latin typeface="Calibri" charset="0"/>
-                        <a:ea typeface="Calibri" charset="0"/>
-                        <a:cs typeface="Calibri" charset="0"/>
-                      </a:endParaRPr>
-                    </a:p>
-                  </a:txBody>
-                  <a:tcPr marL="54864" marR="54864" marT="54864" marB="54864" anchor="ctr">
-                    <a:lnL w="9525" cap="flat" cmpd="sng" algn="ctr">
-                      <a:solidFill>
-                        <a:srgbClr val="BFBFBF"/>
-                      </a:solidFill>
-                      <a:prstDash val="solid"/>
-                      <a:round/>
-                      <a:headEnd type="none" w="med" len="med"/>
-                      <a:tailEnd type="none" w="med" len="med"/>
-                    </a:lnL>
-                    <a:lnR w="9525" cap="flat" cmpd="sng" algn="ctr">
-                      <a:solidFill>
-                        <a:srgbClr val="BFBFBF"/>
-                      </a:solidFill>
-                      <a:prstDash val="solid"/>
-                      <a:round/>
-                      <a:headEnd type="none" w="med" len="med"/>
-                      <a:tailEnd type="none" w="med" len="med"/>
-                    </a:lnR>
-                    <a:lnT w="9525" cap="flat" cmpd="sng" algn="ctr">
-                      <a:solidFill>
-                        <a:srgbClr val="BFBFBF"/>
-                      </a:solidFill>
-                      <a:prstDash val="solid"/>
-                      <a:round/>
-                      <a:headEnd type="none" w="med" len="med"/>
-                      <a:tailEnd type="none" w="med" len="med"/>
-                    </a:lnT>
-                    <a:lnB w="9525" cap="flat" cmpd="sng" algn="ctr">
-                      <a:solidFill>
-                        <a:srgbClr val="BFBFBF"/>
-                      </a:solidFill>
-                      <a:prstDash val="solid"/>
-                      <a:round/>
-                      <a:headEnd type="none" w="med" len="med"/>
-                      <a:tailEnd type="none" w="med" len="med"/>
-                    </a:lnB>
-                  </a:tcPr>
-                </a:tc>
-                <a:tc>
-                  <a:txBody>
-                    <a:bodyPr wrap="square"/>
-                    <a:lstStyle/>
-                    <a:p>
-                      <a:pPr marL="0" indent="0">
-                        <a:buNone/>
-                      </a:pPr>
-                      <a:r>
-                        <a:rPr sz="1050" b="0">
-                          <a:solidFill>
-                            <a:srgbClr val="000000"/>
-                          </a:solidFill>
-                          <a:latin typeface="Calibri"/>
-                        </a:rPr>
-                        <a:t>[9] BASE   [10]</a:t>
-                      </a:r>
-                      <a:endParaRPr lang="en-US" sz="1300" dirty="0">
-                        <a:latin typeface="Calibri" charset="0"/>
-                        <a:ea typeface="Calibri" charset="0"/>
-                        <a:cs typeface="Calibri" charset="0"/>
-                      </a:endParaRPr>
-                    </a:p>
-                    <a:p>
-                      <a:r>
-                        <a:rPr sz="1050" b="0">
-                          <a:solidFill>
-                            <a:srgbClr val="000000"/>
-                          </a:solidFill>
-                          <a:latin typeface="Calibri"/>
-                        </a:rPr>
-                        <a:t>[24] [27]</a:t>
-                      </a:r>
-                    </a:p>
-                  </a:txBody>
-                  <a:tcPr marL="54864" marR="54864" marT="54864" marB="54864" anchor="ctr">
-                    <a:lnL w="9525" cap="flat" cmpd="sng" algn="ctr">
-                      <a:solidFill>
-                        <a:srgbClr val="BFBFBF"/>
-                      </a:solidFill>
-                      <a:prstDash val="solid"/>
-                      <a:round/>
-                      <a:headEnd type="none" w="med" len="med"/>
-                      <a:tailEnd type="none" w="med" len="med"/>
-                    </a:lnL>
-                    <a:lnR w="9525" cap="flat" cmpd="sng" algn="ctr">
-                      <a:solidFill>
-                        <a:srgbClr val="BFBFBF"/>
-                      </a:solidFill>
-                      <a:prstDash val="solid"/>
-                      <a:round/>
-                      <a:headEnd type="none" w="med" len="med"/>
-                      <a:tailEnd type="none" w="med" len="med"/>
-                    </a:lnR>
-                    <a:lnT w="9525" cap="flat" cmpd="sng" algn="ctr">
-                      <a:solidFill>
-                        <a:srgbClr val="BFBFBF"/>
-                      </a:solidFill>
-                      <a:prstDash val="solid"/>
-                      <a:round/>
-                      <a:headEnd type="none" w="med" len="med"/>
-                      <a:tailEnd type="none" w="med" len="med"/>
-                    </a:lnT>
-                    <a:lnB w="9525" cap="flat" cmpd="sng" algn="ctr">
-                      <a:solidFill>
-                        <a:srgbClr val="BFBFBF"/>
-                      </a:solidFill>
-                      <a:prstDash val="solid"/>
-                      <a:round/>
-                      <a:headEnd type="none" w="med" len="med"/>
-                      <a:tailEnd type="none" w="med" len="med"/>
-                    </a:lnB>
-                  </a:tcPr>
-                </a:tc>
-                <a:tc gridSpan="2">
-                  <a:txBody>
-                    <a:bodyPr wrap="square"/>
-                    <a:lstStyle/>
-                    <a:p>
-                      <a:pPr marL="0" indent="0">
-                        <a:buNone/>
-                      </a:pPr>
-                      <a:r>
-                        <a:rPr sz="1050" b="0">
-                          <a:solidFill>
-                            <a:srgbClr val="000000"/>
-                          </a:solidFill>
-                          <a:latin typeface="Calibri"/>
-                        </a:rPr>
-                        <a:t>The gate waveform selected by a multibit CODE rather than a resistor network. [9] is the BASE PAPER — doi.org/10.1002/cta.3136 — and [10] is the closest GaN implementation. Digital means FPGA-implementable, and the code space can be searched exhaustively.</a:t>
-                      </a:r>
-                      <a:endParaRPr lang="en-US" sz="1300" dirty="0">
-                        <a:latin typeface="Calibri" charset="0"/>
-                        <a:ea typeface="Calibri" charset="0"/>
-                        <a:cs typeface="Calibri" charset="0"/>
-                      </a:endParaRPr>
-                    </a:p>
-                  </a:txBody>
-                  <a:tcPr marL="54864" marR="54864" marT="54864" marB="54864" anchor="ctr">
-                    <a:lnL w="9525" cap="flat" cmpd="sng" algn="ctr">
-                      <a:solidFill>
-                        <a:srgbClr val="BFBFBF"/>
-                      </a:solidFill>
-                      <a:prstDash val="solid"/>
-                      <a:round/>
-                      <a:headEnd type="none" w="med" len="med"/>
-                      <a:tailEnd type="none" w="med" len="med"/>
-                    </a:lnL>
-                    <a:lnR w="9525" cap="flat" cmpd="sng" algn="ctr">
-                      <a:solidFill>
-                        <a:srgbClr val="BFBFBF"/>
-                      </a:solidFill>
-                      <a:prstDash val="solid"/>
-                      <a:round/>
-                      <a:headEnd type="none" w="med" len="med"/>
-                      <a:tailEnd type="none" w="med" len="med"/>
-                    </a:lnR>
-                    <a:lnT w="9525" cap="flat" cmpd="sng" algn="ctr">
-                      <a:solidFill>
-                        <a:srgbClr val="BFBFBF"/>
-                      </a:solidFill>
-                      <a:prstDash val="solid"/>
-                      <a:round/>
-                      <a:headEnd type="none" w="med" len="med"/>
-                      <a:tailEnd type="none" w="med" len="med"/>
-                    </a:lnT>
-                    <a:lnB w="9525" cap="flat" cmpd="sng" algn="ctr">
-                      <a:solidFill>
-                        <a:srgbClr val="BFBFBF"/>
-                      </a:solidFill>
-                      <a:prstDash val="solid"/>
-                      <a:round/>
-                      <a:headEnd type="none" w="med" len="med"/>
-                      <a:tailEnd type="none" w="med" len="med"/>
-                    </a:lnB>
-                  </a:tcPr>
-                </a:tc>
-                <a:tc hMerge="1">
-                  <a:txBody>
-                    <a:bodyPr/>
-                    <a:lstStyle/>
-                    <a:p>
-                      <a:pPr marL="0" indent="0">
-                        <a:buNone/>
-                      </a:pPr>
-                      <a:endParaRPr lang="en-US" sz="1300" dirty="0">
-                        <a:latin typeface="Calibri" charset="0"/>
-                        <a:ea typeface="Calibri" charset="0"/>
-                        <a:cs typeface="Calibri" charset="0"/>
-                      </a:endParaRPr>
-                    </a:p>
-                  </a:txBody>
-                  <a:tcPr marL="54864" marR="54864" marT="54864" marB="54864" anchor="ctr">
-                    <a:lnL w="9525" cap="flat" cmpd="sng" algn="ctr">
-                      <a:solidFill>
-                        <a:srgbClr val="BFBFBF"/>
-                      </a:solidFill>
-                      <a:prstDash val="solid"/>
-                      <a:round/>
-                      <a:headEnd type="none" w="med" len="med"/>
-                      <a:tailEnd type="none" w="med" len="med"/>
-                    </a:lnL>
-                    <a:lnR w="9525" cap="flat" cmpd="sng" algn="ctr">
-                      <a:solidFill>
-                        <a:srgbClr val="BFBFBF"/>
-                      </a:solidFill>
-                      <a:prstDash val="solid"/>
-                      <a:round/>
-                      <a:headEnd type="none" w="med" len="med"/>
-                      <a:tailEnd type="none" w="med" len="med"/>
-                    </a:lnR>
-                    <a:lnT w="9525" cap="flat" cmpd="sng" algn="ctr">
-                      <a:solidFill>
-                        <a:srgbClr val="BFBFBF"/>
-                      </a:solidFill>
-                      <a:prstDash val="solid"/>
-                      <a:round/>
-                      <a:headEnd type="none" w="med" len="med"/>
-                      <a:tailEnd type="none" w="med" len="med"/>
-                    </a:lnT>
-                    <a:lnB w="9525" cap="flat" cmpd="sng" algn="ctr">
-                      <a:solidFill>
-                        <a:srgbClr val="BFBFBF"/>
-                      </a:solidFill>
-                      <a:prstDash val="solid"/>
-                      <a:round/>
-                      <a:headEnd type="none" w="med" len="med"/>
-                      <a:tailEnd type="none" w="med" len="med"/>
-                    </a:lnB>
-                  </a:tcPr>
-                </a:tc>
-                <a:extLst>
-                  <a:ext uri="{0D108BD9-81ED-4DB2-BD59-A6C34878D82A}">
-                    <a16:rowId xmlns:a16="http://schemas.microsoft.com/office/drawing/2014/main" val="10004"/>
-                  </a:ext>
-                </a:extLst>
-              </a:tr>
             </a:tbl>
           </a:graphicData>
         </a:graphic>
@@ -21648,7 +21210,29 @@
                 <a:ea typeface="Calibri" pitchFamily="34" charset="-122"/>
                 <a:cs typeface="Calibri" pitchFamily="34" charset="-120"/>
               </a:rPr>
-              <a:t xml:space="preserve">30 references, all publisher-verified, grouped by what the driver DOES. Clusters A–C set or regulate in analogue; only cluster D makes the setting a digital CODE — which is what makes an exhaustive search possible at all.</a:t>
+              <a:t xml:space="preserve">H. Takayama, T. Okuda and T. Hikihara, </a:t>
+            </a:r>
+            <a:r>
+              <a:rPr lang="en-US" sz="1150" b="1" dirty="0">
+                <a:solidFill>
+                  <a:srgbClr val="000000"/>
+                </a:solidFill>
+                <a:latin typeface="Calibri" pitchFamily="34" charset="0"/>
+                <a:ea typeface="Calibri" pitchFamily="34" charset="-122"/>
+                <a:cs typeface="Calibri" pitchFamily="34" charset="-120"/>
+              </a:rPr>
+              <a:t xml:space="preserve">“Digital Active Gate Drive of SiC MOSFETs for Controlling Switching Behavior,”</a:t>
+            </a:r>
+            <a:r>
+              <a:rPr lang="en-US" sz="1150" dirty="0">
+                <a:solidFill>
+                  <a:srgbClr val="000000"/>
+                </a:solidFill>
+                <a:latin typeface="Calibri" pitchFamily="34" charset="0"/>
+                <a:ea typeface="Calibri" pitchFamily="34" charset="-122"/>
+                <a:cs typeface="Calibri" pitchFamily="34" charset="-120"/>
+              </a:rPr>
+              <a:t xml:space="preserve"> Int. J. Circuit Theory Appl., vol. 50, no. 1, pp. 183–196, 2022.  doi.org/10.1002/cta.3136</a:t>
             </a:r>
           </a:p>
         </p:txBody>

</xml_diff>

<commit_message>
Show Vivado's report on a slide, and allow a second synthesis run
The deck quoted Vivado's numbers but never showed the report. A number typed
onto a slide and a number lifted out of the tool are not the same evidence,
and the FPGA section is exactly where a panel wants the second kind. New slide
20 reproduces both report excerpts verbatim from rtl/vivado/build/, with the
timing panel showing BOTH rows -- because "Timing constraints are not met" on
its own is misleading when the design meets 200 MHz register-to-register with
1.996 ns to spare.

synth_only.tcl now takes an optional second argument, the top module. Running
it once more with seg_gate_ctrl instead of seg_gate_ctrl_top would give the
cost of programmability in Vivado numbers rather than the yosys estimate the
deck currently rests that comparison on.

Deck is 34 slides.

Co-Authored-By: Claude Opus 5 <noreply@anthropic.com>
</commit_message>
<xml_diff>
--- a/review/Review1_GaN_Segmented_Gate_Driver.pptx
+++ b/review/Review1_GaN_Segmented_Gate_Driver.pptx
@@ -11,12 +11,12 @@
     <p:sldId id="256" r:id="rId2"/>
     <p:sldId id="257" r:id="rId3"/>
     <p:sldId id="258" r:id="rId4"/>
-    <p:sldId id="284" r:id="rId35"/>
+    <p:sldId id="285" r:id="rId36"/>
     <p:sldId id="259" r:id="rId5"/>
     <p:sldId id="260" r:id="rId6"/>
     <p:sldId id="267" r:id="rId18"/>
     <p:sldId id="282" r:id="rId33"/>
-    <p:sldId id="285" r:id="rId36"/>
+    <p:sldId id="286" r:id="rId37"/>
     <p:sldId id="261" r:id="rId7"/>
     <p:sldId id="280" r:id="rId31"/>
     <p:sldId id="274" r:id="rId25"/>
@@ -27,7 +27,8 @@
     <p:sldId id="272" r:id="rId23"/>
     <p:sldId id="281" r:id="rId32"/>
     <p:sldId id="273" r:id="rId24"/>
-    <p:sldId id="286" r:id="rId37"/>
+    <p:sldId id="284" r:id="rId35"/>
+    <p:sldId id="287" r:id="rId38"/>
     <p:sldId id="263" r:id="rId9"/>
     <p:sldId id="275" r:id="rId26"/>
     <p:sldId id="279" r:id="rId30"/>
@@ -36,10 +37,10 @@
     <p:sldId id="268" r:id="rId19"/>
     <p:sldId id="269" r:id="rId20"/>
     <p:sldId id="270" r:id="rId21"/>
-    <p:sldId id="287" r:id="rId38"/>
+    <p:sldId id="288" r:id="rId39"/>
     <p:sldId id="271" r:id="rId22"/>
     <p:sldId id="265" r:id="rId11"/>
-    <p:sldId id="288" r:id="rId39"/>
+    <p:sldId id="289" r:id="rId40"/>
     <p:sldId id="266" r:id="rId12"/>
   </p:sldIdLst>
   <p:sldSz cx="12192000" cy="6858000"/>
@@ -3228,7 +3229,7 @@
                 <a:ea typeface="Calibri" pitchFamily="34" charset="-122"/>
                 <a:cs typeface="Calibri" pitchFamily="34" charset="-120"/>
               </a:rPr>
-              <a:t>21</a:t>
+              <a:t>22</a:t>
             </a:r>
             <a:endParaRPr lang="en-US" sz="1000" dirty="0"/>
           </a:p>
@@ -3744,7 +3745,7 @@
                 <a:ea typeface="Calibri" pitchFamily="34" charset="-122"/>
                 <a:cs typeface="Calibri" pitchFamily="34" charset="-120"/>
               </a:rPr>
-              <a:t>22</a:t>
+              <a:t>23</a:t>
             </a:r>
             <a:endParaRPr lang="en-US" sz="1000" dirty="0"/>
           </a:p>
@@ -4328,7 +4329,7 @@
                 <a:ea typeface="Calibri" pitchFamily="34" charset="-122"/>
                 <a:cs typeface="Calibri" pitchFamily="34" charset="-120"/>
               </a:rPr>
-              <a:t>24</a:t>
+              <a:t>25</a:t>
             </a:r>
             <a:endParaRPr lang="en-US" sz="1000" dirty="0"/>
           </a:p>
@@ -5132,7 +5133,7 @@
                 <a:ea typeface="Calibri" pitchFamily="34" charset="-122"/>
                 <a:cs typeface="Calibri" pitchFamily="34" charset="-120"/>
               </a:rPr>
-              <a:t>25</a:t>
+              <a:t>26</a:t>
             </a:r>
             <a:endParaRPr lang="en-US" sz="1000" dirty="0"/>
           </a:p>
@@ -5378,7 +5379,7 @@
                 <a:ea typeface="Calibri" pitchFamily="34" charset="-122"/>
                 <a:cs typeface="Calibri" pitchFamily="34" charset="-120"/>
               </a:rPr>
-              <a:t>26</a:t>
+              <a:t>27</a:t>
             </a:r>
             <a:endParaRPr lang="en-US" sz="1000" dirty="0"/>
           </a:p>
@@ -7357,7 +7358,7 @@
                 <a:ea typeface="Calibri" pitchFamily="34" charset="-122"/>
                 <a:cs typeface="Calibri" pitchFamily="34" charset="-120"/>
               </a:rPr>
-              <a:t>27</a:t>
+              <a:t>28</a:t>
             </a:r>
             <a:endParaRPr lang="en-US" sz="1000" dirty="0"/>
           </a:p>
@@ -7799,7 +7800,7 @@
                 <a:ea typeface="Calibri" pitchFamily="34" charset="-122"/>
                 <a:cs typeface="Calibri" pitchFamily="34" charset="-120"/>
               </a:rPr>
-              <a:t>28</a:t>
+              <a:t>29</a:t>
             </a:r>
             <a:endParaRPr lang="en-US" sz="1000" dirty="0"/>
           </a:p>
@@ -8320,7 +8321,7 @@
                 <a:ea typeface="Calibri" pitchFamily="34" charset="-122"/>
                 <a:cs typeface="Calibri" pitchFamily="34" charset="-120"/>
               </a:rPr>
-              <a:t>30</a:t>
+              <a:t>31</a:t>
             </a:r>
             <a:endParaRPr lang="en-US" sz="1000" dirty="0"/>
           </a:p>
@@ -9600,7 +9601,7 @@
                 <a:ea typeface="Calibri" pitchFamily="34" charset="-122"/>
                 <a:cs typeface="Calibri" pitchFamily="34" charset="-120"/>
               </a:rPr>
-              <a:t>31</a:t>
+              <a:t>32</a:t>
             </a:r>
             <a:endParaRPr lang="en-US" sz="1000" dirty="0"/>
           </a:p>
@@ -10275,7 +10276,7 @@
                 <a:ea typeface="Calibri" pitchFamily="34" charset="-122"/>
                 <a:cs typeface="Calibri" pitchFamily="34" charset="-120"/>
               </a:rPr>
-              <a:t>33</a:t>
+              <a:t>34</a:t>
             </a:r>
             <a:endParaRPr lang="en-US" sz="1000" dirty="0"/>
           </a:p>
@@ -12037,7 +12038,7 @@
                 <a:ea typeface="Calibri" pitchFamily="34" charset="-122"/>
                 <a:cs typeface="Calibri" pitchFamily="34" charset="-120"/>
               </a:rPr>
-              <a:t>23</a:t>
+              <a:t>24</a:t>
             </a:r>
             <a:endParaRPr lang="en-US" sz="1000" dirty="0"/>
           </a:p>
@@ -15182,144 +15183,180 @@
       <p:grpSpPr/>
       <p:sp>
         <p:nvSpPr>
-          <p:cNvPr id="2" name="Rectangle 1"/>
-          <p:cNvSpPr/>
-          <p:nvPr/>
-        </p:nvSpPr>
-        <p:spPr>
-          <a:xfrm>
-            <a:off x="0" y="0"/>
-            <a:ext cx="12191695" cy="6858000"/>
-          </a:xfrm>
-          <a:prstGeom prst="rect">
-            <a:avLst/>
-          </a:prstGeom>
-          <a:solidFill>
-            <a:srgbClr val="14233D"/>
-          </a:solidFill>
-          <a:ln>
-            <a:noFill/>
-          </a:ln>
-          <a:effectLst/>
-        </p:spPr>
-        <p:style>
-          <a:lnRef idx="1">
-            <a:schemeClr val="accent1"/>
-          </a:lnRef>
-          <a:fillRef idx="3">
-            <a:schemeClr val="accent1"/>
-          </a:fillRef>
-          <a:effectRef idx="2">
-            <a:schemeClr val="accent1"/>
-          </a:effectRef>
-          <a:fontRef idx="minor">
-            <a:schemeClr val="lt1"/>
-          </a:fontRef>
-        </p:style>
-        <p:txBody>
-          <a:bodyPr rtlCol="0" anchor="ctr"/>
-          <a:lstStyle/>
-          <a:p/>
-        </p:txBody>
-      </p:sp>
-      <p:sp>
-        <p:nvSpPr>
-          <p:cNvPr id="3" name="TextBox 2"/>
-          <p:cNvSpPr txBox="1"/>
-          <p:nvPr/>
-        </p:nvSpPr>
-        <p:spPr>
-          <a:xfrm>
-            <a:off x="1188720" y="1874519"/>
-            <a:ext cx="2743200" cy="1143000"/>
-          </a:xfrm>
-          <a:prstGeom prst="rect">
-            <a:avLst/>
-          </a:prstGeom>
-          <a:noFill/>
-        </p:spPr>
-        <p:txBody>
-          <a:bodyPr wrap="square">
+          <p:cNvPr id="2" name="Text 0"/>
+          <p:cNvSpPr txBox="1"/>
+          <p:nvPr/>
+        </p:nvSpPr>
+        <p:spPr>
+          <a:xfrm>
+            <a:off x="11460175" y="6446520"/>
+            <a:ext cx="457200" cy="274320"/>
+          </a:xfrm>
+          <a:prstGeom prst="rect">
+            <a:avLst/>
+          </a:prstGeom>
+          <a:noFill/>
+          <a:ln/>
+        </p:spPr>
+        <p:txBody>
+          <a:bodyPr wrap="square" lIns="0" tIns="0" rIns="0" bIns="0" rtlCol="0" anchor="ctr"/>
+          <a:lstStyle/>
+          <a:p>
+            <a:pPr marL="0" indent="0" algn="r">
+              <a:buNone/>
+            </a:pPr>
+            <a:r>
+              <a:rPr lang="en-US" sz="1000" dirty="0">
+                <a:solidFill>
+                  <a:srgbClr val="808080"/>
+                </a:solidFill>
+                <a:latin typeface="Calibri" pitchFamily="34" charset="0"/>
+                <a:ea typeface="Calibri" pitchFamily="34" charset="-122"/>
+                <a:cs typeface="Calibri" pitchFamily="34" charset="-120"/>
+              </a:rPr>
+              <a:t>20</a:t>
+            </a:r>
+            <a:endParaRPr lang="en-US" sz="1000" dirty="0"/>
+          </a:p>
+        </p:txBody>
+      </p:sp>
+      <p:sp>
+        <p:nvSpPr>
+          <p:cNvPr id="3" name="Text 1"/>
+          <p:cNvSpPr txBox="1"/>
+          <p:nvPr/>
+        </p:nvSpPr>
+        <p:spPr>
+          <a:xfrm>
+            <a:off x="548640" y="320040"/>
+            <a:ext cx="9601200" cy="685800"/>
+          </a:xfrm>
+          <a:prstGeom prst="rect">
+            <a:avLst/>
+          </a:prstGeom>
+          <a:noFill/>
+          <a:ln/>
+        </p:spPr>
+        <p:txBody>
+          <a:bodyPr wrap="square" lIns="0" tIns="0" rIns="0" bIns="0" rtlCol="0" anchor="ctr"/>
+          <a:lstStyle/>
+          <a:p>
+            <a:pPr marL="0" indent="0">
+              <a:buNone/>
+            </a:pPr>
+            <a:r>
+              <a:rPr lang="en-US" sz="2800" b="1" dirty="0">
+                <a:solidFill>
+                  <a:srgbClr val="1D2F82"/>
+                </a:solidFill>
+                <a:latin typeface="Calibri" pitchFamily="34" charset="0"/>
+                <a:ea typeface="Calibri" pitchFamily="34" charset="-122"/>
+                <a:cs typeface="Calibri" pitchFamily="34" charset="-120"/>
+              </a:rPr>
+              <a:t>Vivado — the synthesis report itself</a:t>
+            </a:r>
+            <a:endParaRPr lang="en-US" sz="2800" dirty="0"/>
+          </a:p>
+        </p:txBody>
+      </p:sp>
+      <p:pic>
+        <p:nvPicPr>
+          <p:cNvPr id="4" name="Image 0" descr="logo.png"/>
+          <p:cNvPicPr>
+            <a:picLocks noChangeAspect="1"/>
+          </p:cNvPicPr>
+          <p:nvPr/>
+        </p:nvPicPr>
+        <p:blipFill>
+          <a:blip r:embed="rId2"/>
+          <a:stretch>
+            <a:fillRect/>
+          </a:stretch>
+        </p:blipFill>
+        <p:spPr>
+          <a:xfrm>
+            <a:off x="10362895" y="320040"/>
+            <a:ext cx="1371600" cy="518746"/>
+          </a:xfrm>
+          <a:prstGeom prst="rect">
+            <a:avLst/>
+          </a:prstGeom>
+        </p:spPr>
+      </p:pic>
+      <p:pic>
+        <p:nvPicPr>
+          <p:cNvPr id="5" name="Picture 4" descr="fig_vivado.png"/>
+          <p:cNvPicPr>
+            <a:picLocks noChangeAspect="1"/>
+          </p:cNvPicPr>
+          <p:nvPr/>
+        </p:nvPicPr>
+        <p:blipFill>
+          <a:blip r:embed="rId4"/>
+          <a:stretch>
+            <a:fillRect/>
+          </a:stretch>
+        </p:blipFill>
+        <p:spPr>
+          <a:xfrm>
+            <a:off x="685800" y="1325880"/>
+            <a:ext cx="10283174" cy="4434840"/>
+          </a:xfrm>
+          <a:prstGeom prst="rect">
+            <a:avLst/>
+          </a:prstGeom>
+        </p:spPr>
+      </p:pic>
+      <p:sp>
+        <p:nvSpPr>
+          <p:cNvPr id="6" name="TextBox 5"/>
+          <p:cNvSpPr txBox="1"/>
+          <p:nvPr/>
+        </p:nvSpPr>
+        <p:spPr>
+          <a:xfrm>
+            <a:off x="685800" y="5989320"/>
+            <a:ext cx="10789920" cy="411480"/>
+          </a:xfrm>
+          <a:prstGeom prst="rect">
+            <a:avLst/>
+          </a:prstGeom>
+          <a:noFill/>
+        </p:spPr>
+        <p:txBody>
+          <a:bodyPr wrap="square" lIns="0" tIns="0" rIns="0" bIns="0">
             <a:spAutoFit/>
           </a:bodyPr>
           <a:lstStyle/>
           <a:p>
-            <a:r>
-              <a:rPr sz="6600" b="1" i="0">
-                <a:solidFill>
-                  <a:srgbClr val="6B7C93"/>
-                </a:solidFill>
-                <a:latin typeface="Calibri"/>
-              </a:rPr>
-              <a:t>01</a:t>
-            </a:r>
-          </a:p>
-        </p:txBody>
-      </p:sp>
-      <p:sp>
-        <p:nvSpPr>
-          <p:cNvPr id="4" name="TextBox 3"/>
-          <p:cNvSpPr txBox="1"/>
-          <p:nvPr/>
-        </p:nvSpPr>
-        <p:spPr>
-          <a:xfrm>
-            <a:off x="1188720" y="3063240"/>
-            <a:ext cx="9692640" cy="1005840"/>
-          </a:xfrm>
-          <a:prstGeom prst="rect">
-            <a:avLst/>
-          </a:prstGeom>
-          <a:noFill/>
-        </p:spPr>
-        <p:txBody>
-          <a:bodyPr wrap="square">
-            <a:spAutoFit/>
-          </a:bodyPr>
-          <a:lstStyle/>
-          <a:p>
-            <a:r>
-              <a:rPr sz="4400" b="1" i="0">
-                <a:solidFill>
-                  <a:srgbClr val="F4F2EE"/>
-                </a:solidFill>
-                <a:latin typeface="Calibri"/>
-              </a:rPr>
-              <a:t>The problem</a:t>
-            </a:r>
-          </a:p>
-        </p:txBody>
-      </p:sp>
-      <p:sp>
-        <p:nvSpPr>
-          <p:cNvPr id="5" name="TextBox 4"/>
-          <p:cNvSpPr txBox="1"/>
-          <p:nvPr/>
-        </p:nvSpPr>
-        <p:spPr>
-          <a:xfrm>
-            <a:off x="1280160" y="4160520"/>
-            <a:ext cx="9509760" cy="731520"/>
-          </a:xfrm>
-          <a:prstGeom prst="rect">
-            <a:avLst/>
-          </a:prstGeom>
-          <a:noFill/>
-        </p:spPr>
-        <p:txBody>
-          <a:bodyPr wrap="square">
-            <a:spAutoFit/>
-          </a:bodyPr>
-          <a:lstStyle/>
-          <a:p>
-            <a:r>
-              <a:rPr sz="1700" b="0" i="0">
-                <a:solidFill>
-                  <a:srgbClr val="6B7C93"/>
-                </a:solidFill>
-                <a:latin typeface="Calibri"/>
-              </a:rPr>
-              <a:t>A real failure, and the question nobody has answered</a:t>
+            <a:pPr marL="177800" indent="0">
+              <a:spcAft>
+                <a:spcPts val="0"/>
+              </a:spcAft>
+              <a:buSzPct val="100000"/>
+              <a:buNone/>
+            </a:pPr>
+            <a:r>
+              <a:rPr lang="en-US" sz="1200" b="1" dirty="0">
+                <a:solidFill>
+                  <a:srgbClr val="000000"/>
+                </a:solidFill>
+                <a:latin typeface="Calibri" pitchFamily="34" charset="0"/>
+                <a:ea typeface="Calibri" pitchFamily="34" charset="-122"/>
+                <a:cs typeface="Calibri" pitchFamily="34" charset="-120"/>
+              </a:rPr>
+              <a:t xml:space="preserve">Run by a colleague on Windows — Vivado has no macOS build. </a:t>
+            </a:r>
+            <a:r>
+              <a:rPr lang="en-US" sz="1200" dirty="0">
+                <a:solidFill>
+                  <a:srgbClr val="000000"/>
+                </a:solidFill>
+                <a:latin typeface="Calibri" pitchFamily="34" charset="0"/>
+                <a:ea typeface="Calibri" pitchFamily="34" charset="-122"/>
+                <a:cs typeface="Calibri" pitchFamily="34" charset="-120"/>
+              </a:rPr>
+              <a:t xml:space="preserve">Both reports are committed in rtl/vivado/build/.</a:t>
             </a:r>
           </a:p>
         </p:txBody>
@@ -15780,7 +15817,7 @@
                 </a:solidFill>
                 <a:latin typeface="Calibri"/>
               </a:rPr>
-              <a:t>02</a:t>
+              <a:t>01</a:t>
             </a:r>
           </a:p>
         </p:txBody>
@@ -15814,7 +15851,7 @@
                 </a:solidFill>
                 <a:latin typeface="Calibri"/>
               </a:rPr>
-              <a:t>What we built</a:t>
+              <a:t>The problem</a:t>
             </a:r>
           </a:p>
         </p:txBody>
@@ -15848,7 +15885,7 @@
                 </a:solidFill>
                 <a:latin typeface="Calibri"/>
               </a:rPr>
-              <a:t>A 720-point control word, and an exhaustive search</a:t>
+              <a:t>A real failure, and the question nobody has answered</a:t>
             </a:r>
           </a:p>
         </p:txBody>
@@ -15942,7 +15979,7 @@
                 </a:solidFill>
                 <a:latin typeface="Calibri"/>
               </a:rPr>
-              <a:t>03</a:t>
+              <a:t>02</a:t>
             </a:r>
           </a:p>
         </p:txBody>
@@ -15976,7 +16013,7 @@
                 </a:solidFill>
                 <a:latin typeface="Calibri"/>
               </a:rPr>
-              <a:t>What we found</a:t>
+              <a:t>What we built</a:t>
             </a:r>
           </a:p>
         </p:txBody>
@@ -16010,7 +16047,7 @@
                 </a:solidFill>
                 <a:latin typeface="Calibri"/>
               </a:rPr>
-              <a:t>Choosing well beats adapting — and by how much</a:t>
+              <a:t>A 720-point control word, and an exhaustive search</a:t>
             </a:r>
           </a:p>
         </p:txBody>
@@ -16104,7 +16141,7 @@
                 </a:solidFill>
                 <a:latin typeface="Calibri"/>
               </a:rPr>
-              <a:t>04</a:t>
+              <a:t>03</a:t>
             </a:r>
           </a:p>
         </p:txBody>
@@ -16138,7 +16175,7 @@
                 </a:solidFill>
                 <a:latin typeface="Calibri"/>
               </a:rPr>
-              <a:t>Where this goes</a:t>
+              <a:t>What we found</a:t>
             </a:r>
           </a:p>
         </p:txBody>
@@ -16172,7 +16209,7 @@
                 </a:solidFill>
                 <a:latin typeface="Calibri"/>
               </a:rPr>
-              <a:t>The deliverable, the limits, and Review-II</a:t>
+              <a:t>Choosing well beats adapting — and by how much</a:t>
             </a:r>
           </a:p>
         </p:txBody>
@@ -16197,6 +16234,168 @@
       <p:grpSpPr/>
       <p:sp>
         <p:nvSpPr>
+          <p:cNvPr id="2" name="Rectangle 1"/>
+          <p:cNvSpPr/>
+          <p:nvPr/>
+        </p:nvSpPr>
+        <p:spPr>
+          <a:xfrm>
+            <a:off x="0" y="0"/>
+            <a:ext cx="12191695" cy="6858000"/>
+          </a:xfrm>
+          <a:prstGeom prst="rect">
+            <a:avLst/>
+          </a:prstGeom>
+          <a:solidFill>
+            <a:srgbClr val="14233D"/>
+          </a:solidFill>
+          <a:ln>
+            <a:noFill/>
+          </a:ln>
+          <a:effectLst/>
+        </p:spPr>
+        <p:style>
+          <a:lnRef idx="1">
+            <a:schemeClr val="accent1"/>
+          </a:lnRef>
+          <a:fillRef idx="3">
+            <a:schemeClr val="accent1"/>
+          </a:fillRef>
+          <a:effectRef idx="2">
+            <a:schemeClr val="accent1"/>
+          </a:effectRef>
+          <a:fontRef idx="minor">
+            <a:schemeClr val="lt1"/>
+          </a:fontRef>
+        </p:style>
+        <p:txBody>
+          <a:bodyPr rtlCol="0" anchor="ctr"/>
+          <a:lstStyle/>
+          <a:p/>
+        </p:txBody>
+      </p:sp>
+      <p:sp>
+        <p:nvSpPr>
+          <p:cNvPr id="3" name="TextBox 2"/>
+          <p:cNvSpPr txBox="1"/>
+          <p:nvPr/>
+        </p:nvSpPr>
+        <p:spPr>
+          <a:xfrm>
+            <a:off x="1188720" y="1874519"/>
+            <a:ext cx="2743200" cy="1143000"/>
+          </a:xfrm>
+          <a:prstGeom prst="rect">
+            <a:avLst/>
+          </a:prstGeom>
+          <a:noFill/>
+        </p:spPr>
+        <p:txBody>
+          <a:bodyPr wrap="square">
+            <a:spAutoFit/>
+          </a:bodyPr>
+          <a:lstStyle/>
+          <a:p>
+            <a:r>
+              <a:rPr sz="6600" b="1" i="0">
+                <a:solidFill>
+                  <a:srgbClr val="6B7C93"/>
+                </a:solidFill>
+                <a:latin typeface="Calibri"/>
+              </a:rPr>
+              <a:t>04</a:t>
+            </a:r>
+          </a:p>
+        </p:txBody>
+      </p:sp>
+      <p:sp>
+        <p:nvSpPr>
+          <p:cNvPr id="4" name="TextBox 3"/>
+          <p:cNvSpPr txBox="1"/>
+          <p:nvPr/>
+        </p:nvSpPr>
+        <p:spPr>
+          <a:xfrm>
+            <a:off x="1188720" y="3063240"/>
+            <a:ext cx="9692640" cy="1005840"/>
+          </a:xfrm>
+          <a:prstGeom prst="rect">
+            <a:avLst/>
+          </a:prstGeom>
+          <a:noFill/>
+        </p:spPr>
+        <p:txBody>
+          <a:bodyPr wrap="square">
+            <a:spAutoFit/>
+          </a:bodyPr>
+          <a:lstStyle/>
+          <a:p>
+            <a:r>
+              <a:rPr sz="4400" b="1" i="0">
+                <a:solidFill>
+                  <a:srgbClr val="F4F2EE"/>
+                </a:solidFill>
+                <a:latin typeface="Calibri"/>
+              </a:rPr>
+              <a:t>Where this goes</a:t>
+            </a:r>
+          </a:p>
+        </p:txBody>
+      </p:sp>
+      <p:sp>
+        <p:nvSpPr>
+          <p:cNvPr id="5" name="TextBox 4"/>
+          <p:cNvSpPr txBox="1"/>
+          <p:nvPr/>
+        </p:nvSpPr>
+        <p:spPr>
+          <a:xfrm>
+            <a:off x="1280160" y="4160520"/>
+            <a:ext cx="9509760" cy="731520"/>
+          </a:xfrm>
+          <a:prstGeom prst="rect">
+            <a:avLst/>
+          </a:prstGeom>
+          <a:noFill/>
+        </p:spPr>
+        <p:txBody>
+          <a:bodyPr wrap="square">
+            <a:spAutoFit/>
+          </a:bodyPr>
+          <a:lstStyle/>
+          <a:p>
+            <a:r>
+              <a:rPr sz="1700" b="0" i="0">
+                <a:solidFill>
+                  <a:srgbClr val="6B7C93"/>
+                </a:solidFill>
+                <a:latin typeface="Calibri"/>
+              </a:rPr>
+              <a:t>The deliverable, the limits, and Review-II</a:t>
+            </a:r>
+          </a:p>
+        </p:txBody>
+      </p:sp>
+    </p:spTree>
+  </p:cSld>
+  <p:clrMapOvr>
+    <a:masterClrMapping/>
+  </p:clrMapOvr>
+</p:sld>
+</file>
+
+<file path=ppt/slides/slide34.xml><?xml version="1.0" encoding="utf-8"?>
+<p:sld xmlns:a="http://schemas.openxmlformats.org/drawingml/2006/main" xmlns:p="http://schemas.openxmlformats.org/presentationml/2006/main" xmlns:r="http://schemas.openxmlformats.org/officeDocument/2006/relationships">
+  <p:cSld>
+    <p:spTree>
+      <p:nvGrpSpPr>
+        <p:cNvPr id="1" name=""/>
+        <p:cNvGrpSpPr/>
+        <p:nvPr/>
+      </p:nvGrpSpPr>
+      <p:grpSpPr/>
+      <p:sp>
+        <p:nvSpPr>
           <p:cNvPr id="2" name="Text 0"/>
           <p:cNvSpPr txBox="1"/>
           <p:nvPr/>
@@ -16228,7 +16427,7 @@
                 <a:ea typeface="Calibri" pitchFamily="34" charset="-122"/>
                 <a:cs typeface="Calibri" pitchFamily="34" charset="-120"/>
               </a:rPr>
-              <a:t>32</a:t>
+              <a:t>33</a:t>
             </a:r>
             <a:endParaRPr lang="en-US" sz="1000" dirty="0"/>
           </a:p>

</xml_diff>